<commit_message>
Regenerate sample deck with triangle shape
Refresh examples/sample-deck.pptx after adding the triangle demo so the committed output matches the current YAML.

Co-authored-by: shotaminato <shotaminato@users.noreply.github.com>
</commit_message>
<xml_diff>
--- a/examples/sample-deck.pptx
+++ b/examples/sample-deck.pptx
@@ -591,7 +591,7 @@
           <a:p>
             <a:r>
               <a:rPr lang="en-US" dirty="0"/>
-              <a:t>Shape showcase — rect, roundRect, ellipse, block arrows, and line arrows.</a:t>
+              <a:t>Shape showcase — rect, roundRect, ellipse, triangle, block arrows, and line arrows.</a:t>
             </a:r>
             <a:endParaRPr lang="en-US" dirty="0"/>
           </a:p>
@@ -1180,7 +1180,7 @@
                 <a:ea typeface="Calibri" pitchFamily="34" charset="-122"/>
                 <a:cs typeface="Calibri" pitchFamily="34" charset="-120"/>
               </a:rPr>
-              <a:t>text · image · rect · roundRect · ellipse · arrows</a:t>
+              <a:t>text · image · rect · roundRect · ellipse · triangle · arrows</a:t>
             </a:r>
             <a:endParaRPr lang="en-US" sz="1600" dirty="0"/>
           </a:p>
@@ -1894,10 +1894,10 @@
         </p:nvSpPr>
         <p:spPr>
           <a:xfrm>
-            <a:off x="8229600" y="5074920"/>
-            <a:ext cx="3474720" cy="1051560"/>
-          </a:xfrm>
-          <a:prstGeom prst="chevron">
+            <a:off x="8229600" y="4937760"/>
+            <a:ext cx="3474720" cy="1234440"/>
+          </a:xfrm>
+          <a:prstGeom prst="triangle">
             <a:avLst/>
           </a:prstGeom>
           <a:solidFill>
@@ -1925,7 +1925,7 @@
                 <a:ea typeface="Calibri" pitchFamily="34" charset="-122"/>
                 <a:cs typeface="Calibri" pitchFamily="34" charset="-120"/>
               </a:rPr>
-              <a:t>chevron</a:t>
+              <a:t>triangle</a:t>
             </a:r>
             <a:endParaRPr lang="en-US" sz="1400" dirty="0"/>
           </a:p>

</xml_diff>

<commit_message>
Regenerate sample deck with transparent shape
Refresh examples/sample-deck.pptx so the RISC-V base-ISA slide includes the semi-transparent ellipse.

Co-authored-by: shotaminato <shotaminato@users.noreply.github.com>
</commit_message>
<xml_diff>
--- a/examples/sample-deck.pptx
+++ b/examples/sample-deck.pptx
@@ -773,7 +773,7 @@
           <a:p>
             <a:r>
               <a:rPr lang="en-US" dirty="0"/>
-              <a:t>RV32I / RV64I が主。x0 はゼロ。整数レジスタは 32 本（RV32E は 16 本）。</a:t>
+              <a:t>RV32I / RV64I が主。x0 はゼロ。整数レジスタは 32 本（RV32E は 16 本）。半透明シェイプの例あり。</a:t>
             </a:r>
             <a:endParaRPr lang="en-US" dirty="0"/>
           </a:p>
@@ -3231,6 +3231,72 @@
       <p:sp>
         <p:nvSpPr>
           <p:cNvPr id="16" name="Text 13"/>
+          <p:cNvSpPr/>
+          <p:nvPr/>
+        </p:nvSpPr>
+        <p:spPr>
+          <a:xfrm>
+            <a:off x="9281160" y="2606040"/>
+            <a:ext cx="2377440" cy="2331720"/>
+          </a:xfrm>
+          <a:prstGeom prst="ellipse">
+            <a:avLst/>
+          </a:prstGeom>
+          <a:solidFill>
+            <a:srgbClr val="C97800">
+              <a:alpha val="40000"/>
+            </a:srgbClr>
+          </a:solidFill>
+          <a:ln w="20320">
+            <a:solidFill>
+              <a:srgbClr val="C97800">
+                <a:alpha val="67000"/>
+              </a:srgbClr>
+            </a:solidFill>
+          </a:ln>
+        </p:spPr>
+        <p:txBody>
+          <a:bodyPr wrap="square" lIns="50800" tIns="50800" rIns="50800" bIns="50800" rtlCol="0" anchor="ctr"/>
+          <a:lstStyle/>
+          <a:p>
+            <a:pPr algn="ctr" indent="0" marL="0">
+              <a:buNone/>
+            </a:pPr>
+            <a:r>
+              <a:rPr lang="ja-JP" altLang="en-US" sz="1300" b="1" dirty="0">
+                <a:solidFill>
+                  <a:srgbClr val="1B2430"/>
+                </a:solidFill>
+                <a:latin typeface="Yu Gothic UI" pitchFamily="34" charset="0"/>
+                <a:ea typeface="Yu Gothic UI" pitchFamily="34" charset="-122"/>
+                <a:cs typeface="Yu Gothic UI" pitchFamily="34" charset="-120"/>
+              </a:rPr>
+              <a:t>半透明</a:t>
+            </a:r>
+            <a:endParaRPr lang="ja-JP" sz="1300" dirty="0"/>
+          </a:p>
+          <a:p>
+            <a:pPr algn="ctr" indent="0" marL="0">
+              <a:buNone/>
+            </a:pPr>
+            <a:r>
+              <a:rPr lang="ja-JP" altLang="en-US" sz="1300" b="1" dirty="0">
+                <a:solidFill>
+                  <a:srgbClr val="1B2430"/>
+                </a:solidFill>
+                <a:latin typeface="Yu Gothic UI" pitchFamily="34" charset="0"/>
+                <a:ea typeface="Yu Gothic UI" pitchFamily="34" charset="-122"/>
+                <a:cs typeface="Yu Gothic UI" pitchFamily="34" charset="-120"/>
+              </a:rPr>
+              <a:t>F/D の fp</a:t>
+            </a:r>
+            <a:endParaRPr lang="ja-JP" sz="1300" dirty="0"/>
+          </a:p>
+        </p:txBody>
+      </p:sp>
+      <p:sp>
+        <p:nvSpPr>
+          <p:cNvPr id="17" name="Text 14"/>
           <p:cNvSpPr/>
           <p:nvPr/>
         </p:nvSpPr>

</xml_diff>

<commit_message>
Regenerate sample deck after font-size increase
Rebuild examples/sample-deck.pptx so the RISC-V slides match the 14pt+ YAML.

Co-authored-by: shotaminato <shotaminato@users.noreply.github.com>
</commit_message>
<xml_diff>
--- a/examples/sample-deck.pptx
+++ b/examples/sample-deck.pptx
@@ -1526,8 +1526,8 @@
         </p:nvSpPr>
         <p:spPr>
           <a:xfrm>
-            <a:off x="0" y="6565392"/>
-            <a:ext cx="12191695" cy="292608"/>
+            <a:off x="0" y="6510528"/>
+            <a:ext cx="12191695" cy="347472"/>
           </a:xfrm>
           <a:prstGeom prst="rect">
             <a:avLst/>
@@ -1546,8 +1546,8 @@
         </p:nvSpPr>
         <p:spPr>
           <a:xfrm>
-            <a:off x="502920" y="6565392"/>
-            <a:ext cx="11247120" cy="292608"/>
+            <a:off x="502920" y="6510528"/>
+            <a:ext cx="11247120" cy="347472"/>
           </a:xfrm>
           <a:prstGeom prst="rect">
             <a:avLst/>
@@ -1563,7 +1563,7 @@
               <a:buNone/>
             </a:pPr>
             <a:r>
-              <a:rPr lang="ja-JP" altLang="en-US" sz="1100" dirty="0">
+              <a:rPr lang="ja-JP" altLang="en-US" sz="1400" dirty="0">
                 <a:solidFill>
                   <a:srgbClr val="5C6B7A"/>
                 </a:solidFill>
@@ -1573,7 +1573,7 @@
               </a:rPr>
               <a:t>RISC-V 入門  ·  オープン ISA</a:t>
             </a:r>
-            <a:endParaRPr lang="ja-JP" sz="1100" dirty="0"/>
+            <a:endParaRPr lang="ja-JP" sz="1400" dirty="0"/>
           </a:p>
         </p:txBody>
       </p:sp>
@@ -1626,7 +1626,7 @@
               <a:buNone/>
             </a:pPr>
             <a:r>
-              <a:rPr lang="ja-JP" altLang="en-US" sz="4000" b="1" dirty="0">
+              <a:rPr lang="ja-JP" altLang="en-US" sz="4400" b="1" dirty="0">
                 <a:solidFill>
                   <a:srgbClr val="1B2430"/>
                 </a:solidFill>
@@ -1636,7 +1636,7 @@
               </a:rPr>
               <a:t>RISC-V 入門</a:t>
             </a:r>
-            <a:endParaRPr lang="ja-JP" sz="4000" dirty="0"/>
+            <a:endParaRPr lang="ja-JP" sz="4400" dirty="0"/>
           </a:p>
         </p:txBody>
       </p:sp>
@@ -1665,7 +1665,7 @@
               <a:buNone/>
             </a:pPr>
             <a:r>
-              <a:rPr lang="ja-JP" altLang="en-US" sz="2000" dirty="0">
+              <a:rPr lang="ja-JP" altLang="en-US" sz="2200" dirty="0">
                 <a:solidFill>
                   <a:srgbClr val="5C6B7A"/>
                 </a:solidFill>
@@ -1675,7 +1675,7 @@
               </a:rPr>
               <a:t>オープンな命令セットアーキテクチャ</a:t>
             </a:r>
-            <a:endParaRPr lang="ja-JP" sz="2000" dirty="0"/>
+            <a:endParaRPr lang="ja-JP" sz="2200" dirty="0"/>
           </a:p>
         </p:txBody>
       </p:sp>
@@ -1726,7 +1726,7 @@
               <a:buNone/>
             </a:pPr>
             <a:r>
-              <a:rPr lang="ja-JP" altLang="en-US" sz="1600" dirty="0">
+              <a:rPr lang="ja-JP" altLang="en-US" sz="1800" dirty="0">
                 <a:solidFill>
                   <a:srgbClr val="0B6BCB"/>
                 </a:solidFill>
@@ -1736,7 +1736,7 @@
               </a:rPr>
               <a:t>基本 ISA  ·  標準拡張  ·  特権レベル</a:t>
             </a:r>
-            <a:endParaRPr lang="ja-JP" sz="1600" dirty="0"/>
+            <a:endParaRPr lang="ja-JP" sz="1800" dirty="0"/>
           </a:p>
         </p:txBody>
       </p:sp>
@@ -1820,8 +1820,8 @@
         </p:nvSpPr>
         <p:spPr>
           <a:xfrm>
-            <a:off x="0" y="6565392"/>
-            <a:ext cx="12191695" cy="292608"/>
+            <a:off x="0" y="6510528"/>
+            <a:ext cx="12191695" cy="347472"/>
           </a:xfrm>
           <a:prstGeom prst="rect">
             <a:avLst/>
@@ -1840,8 +1840,8 @@
         </p:nvSpPr>
         <p:spPr>
           <a:xfrm>
-            <a:off x="411480" y="6565392"/>
-            <a:ext cx="11338560" cy="292608"/>
+            <a:off x="411480" y="6510528"/>
+            <a:ext cx="11338560" cy="347472"/>
           </a:xfrm>
           <a:prstGeom prst="rect">
             <a:avLst/>
@@ -1857,7 +1857,7 @@
               <a:buNone/>
             </a:pPr>
             <a:r>
-              <a:rPr lang="ja-JP" altLang="en-US" sz="1100" dirty="0">
+              <a:rPr lang="ja-JP" altLang="en-US" sz="1400" dirty="0">
                 <a:solidFill>
                   <a:srgbClr val="5C6B7A"/>
                 </a:solidFill>
@@ -1867,7 +1867,7 @@
               </a:rPr>
               <a:t>RISC-V 入門  ·  オープン ISA</a:t>
             </a:r>
-            <a:endParaRPr lang="ja-JP" sz="1100" dirty="0"/>
+            <a:endParaRPr lang="ja-JP" sz="1400" dirty="0"/>
           </a:p>
         </p:txBody>
       </p:sp>
@@ -1879,8 +1879,8 @@
         </p:nvSpPr>
         <p:spPr>
           <a:xfrm>
-            <a:off x="411480" y="54864"/>
-            <a:ext cx="11338560" cy="457200"/>
+            <a:off x="411480" y="45720"/>
+            <a:ext cx="11338560" cy="493776"/>
           </a:xfrm>
           <a:prstGeom prst="rect">
             <a:avLst/>
@@ -1896,7 +1896,7 @@
               <a:buNone/>
             </a:pPr>
             <a:r>
-              <a:rPr lang="ja-JP" altLang="en-US" sz="2200" b="1" dirty="0">
+              <a:rPr lang="ja-JP" altLang="en-US" sz="2600" b="1" dirty="0">
                 <a:solidFill>
                   <a:srgbClr val="1B2430"/>
                 </a:solidFill>
@@ -1906,7 +1906,7 @@
               </a:rPr>
               <a:t>RISC-V とは</a:t>
             </a:r>
-            <a:endParaRPr lang="ja-JP" sz="2200" dirty="0"/>
+            <a:endParaRPr lang="ja-JP" sz="2600" dirty="0"/>
           </a:p>
         </p:txBody>
       </p:sp>
@@ -2040,7 +2040,7 @@
               <a:buNone/>
             </a:pPr>
             <a:r>
-              <a:rPr lang="ja-JP" altLang="en-US" sz="1400" dirty="0">
+              <a:rPr lang="ja-JP" altLang="en-US" sz="1600" dirty="0">
                 <a:solidFill>
                   <a:srgbClr val="1B2430"/>
                 </a:solidFill>
@@ -2050,14 +2050,14 @@
               </a:rPr>
               <a:t>仕様にライセンス料はかかりません。</a:t>
             </a:r>
-            <a:endParaRPr lang="ja-JP" sz="1400" dirty="0"/>
+            <a:endParaRPr lang="ja-JP" sz="1600" dirty="0"/>
           </a:p>
           <a:p>
             <a:pPr indent="0" marL="0">
               <a:buNone/>
             </a:pPr>
             <a:r>
-              <a:rPr lang="ja-JP" altLang="en-US" sz="1400" dirty="0">
+              <a:rPr lang="ja-JP" altLang="en-US" sz="1600" dirty="0">
                 <a:solidFill>
                   <a:srgbClr val="1B2430"/>
                 </a:solidFill>
@@ -2067,7 +2067,7 @@
               </a:rPr>
               <a:t>実装はオープンソースでも、プロプライエタリでも構いません。</a:t>
             </a:r>
-            <a:endParaRPr lang="ja-JP" sz="1400" dirty="0"/>
+            <a:endParaRPr lang="ja-JP" sz="1600" dirty="0"/>
           </a:p>
         </p:txBody>
       </p:sp>
@@ -2162,7 +2162,7 @@
               <a:buNone/>
             </a:pPr>
             <a:r>
-              <a:rPr lang="ja-JP" altLang="en-US" sz="1400" dirty="0">
+              <a:rPr lang="ja-JP" altLang="en-US" sz="1600" dirty="0">
                 <a:solidFill>
                   <a:srgbClr val="1B2430"/>
                 </a:solidFill>
@@ -2172,7 +2172,7 @@
               </a:rPr>
               <a:t>ロードストア型。演算はレジスタ間で行い、メモリは load / store 経由です。エンディアンはリトルエンディアンです。</a:t>
             </a:r>
-            <a:endParaRPr lang="ja-JP" sz="1400" dirty="0"/>
+            <a:endParaRPr lang="ja-JP" sz="1600" dirty="0"/>
           </a:p>
         </p:txBody>
       </p:sp>
@@ -2267,7 +2267,7 @@
               <a:buNone/>
             </a:pPr>
             <a:r>
-              <a:rPr lang="ja-JP" altLang="en-US" sz="1400" dirty="0">
+              <a:rPr lang="ja-JP" altLang="en-US" sz="1600" dirty="0">
                 <a:solidFill>
                   <a:srgbClr val="1B2430"/>
                 </a:solidFill>
@@ -2277,7 +2277,7 @@
               </a:rPr>
               <a:t>整数ベース ISA を凍結し、乗除・浮動小数点・圧縮・ベクトルなどは標準拡張として足します。</a:t>
             </a:r>
-            <a:endParaRPr lang="ja-JP" sz="1400" dirty="0"/>
+            <a:endParaRPr lang="ja-JP" sz="1600" dirty="0"/>
           </a:p>
         </p:txBody>
       </p:sp>
@@ -2361,8 +2361,8 @@
         </p:nvSpPr>
         <p:spPr>
           <a:xfrm>
-            <a:off x="0" y="6565392"/>
-            <a:ext cx="12191695" cy="292608"/>
+            <a:off x="0" y="6510528"/>
+            <a:ext cx="12191695" cy="347472"/>
           </a:xfrm>
           <a:prstGeom prst="rect">
             <a:avLst/>
@@ -2381,8 +2381,8 @@
         </p:nvSpPr>
         <p:spPr>
           <a:xfrm>
-            <a:off x="411480" y="6565392"/>
-            <a:ext cx="11338560" cy="292608"/>
+            <a:off x="411480" y="6510528"/>
+            <a:ext cx="11338560" cy="347472"/>
           </a:xfrm>
           <a:prstGeom prst="rect">
             <a:avLst/>
@@ -2398,7 +2398,7 @@
               <a:buNone/>
             </a:pPr>
             <a:r>
-              <a:rPr lang="ja-JP" altLang="en-US" sz="1100" dirty="0">
+              <a:rPr lang="ja-JP" altLang="en-US" sz="1400" dirty="0">
                 <a:solidFill>
                   <a:srgbClr val="5C6B7A"/>
                 </a:solidFill>
@@ -2408,7 +2408,7 @@
               </a:rPr>
               <a:t>RISC-V 入門  ·  オープン ISA</a:t>
             </a:r>
-            <a:endParaRPr lang="ja-JP" sz="1100" dirty="0"/>
+            <a:endParaRPr lang="ja-JP" sz="1400" dirty="0"/>
           </a:p>
         </p:txBody>
       </p:sp>
@@ -2420,8 +2420,8 @@
         </p:nvSpPr>
         <p:spPr>
           <a:xfrm>
-            <a:off x="411480" y="54864"/>
-            <a:ext cx="11338560" cy="457200"/>
+            <a:off x="411480" y="45720"/>
+            <a:ext cx="11338560" cy="493776"/>
           </a:xfrm>
           <a:prstGeom prst="rect">
             <a:avLst/>
@@ -2437,7 +2437,7 @@
               <a:buNone/>
             </a:pPr>
             <a:r>
-              <a:rPr lang="ja-JP" altLang="en-US" sz="2200" b="1" dirty="0">
+              <a:rPr lang="ja-JP" altLang="en-US" sz="2600" b="1" dirty="0">
                 <a:solidFill>
                   <a:srgbClr val="1B2430"/>
                 </a:solidFill>
@@ -2447,7 +2447,7 @@
               </a:rPr>
               <a:t>設計思想</a:t>
             </a:r>
-            <a:endParaRPr lang="ja-JP" sz="2200" dirty="0"/>
+            <a:endParaRPr lang="ja-JP" sz="2600" dirty="0"/>
           </a:p>
         </p:txBody>
       </p:sp>
@@ -2484,7 +2484,7 @@
               <a:buNone/>
             </a:pPr>
             <a:r>
-              <a:rPr lang="ja-JP" altLang="en-US" sz="1500" dirty="0">
+              <a:rPr lang="ja-JP" altLang="en-US" sz="1600" dirty="0">
                 <a:solidFill>
                   <a:srgbClr val="1B2430"/>
                 </a:solidFill>
@@ -2494,14 +2494,14 @@
               </a:rPr>
               <a:t>シンプル</a:t>
             </a:r>
-            <a:endParaRPr lang="ja-JP" sz="1500" dirty="0"/>
+            <a:endParaRPr lang="ja-JP" sz="1600" dirty="0"/>
           </a:p>
           <a:p>
             <a:pPr algn="l" indent="0" marL="0">
               <a:buNone/>
             </a:pPr>
             <a:r>
-              <a:rPr lang="ja-JP" altLang="en-US" sz="1500" dirty="0">
+              <a:rPr lang="ja-JP" altLang="en-US" sz="1600" dirty="0">
                 <a:solidFill>
                   <a:srgbClr val="1B2430"/>
                 </a:solidFill>
@@ -2511,7 +2511,7 @@
               </a:rPr>
               <a:t>遅延スロットや条件コードを ISA に載せない。直交した命令と少ない形式。</a:t>
             </a:r>
-            <a:endParaRPr lang="ja-JP" sz="1500" dirty="0"/>
+            <a:endParaRPr lang="ja-JP" sz="1600" dirty="0"/>
           </a:p>
         </p:txBody>
       </p:sp>
@@ -2548,7 +2548,7 @@
               <a:buNone/>
             </a:pPr>
             <a:r>
-              <a:rPr lang="ja-JP" altLang="en-US" sz="1500" dirty="0">
+              <a:rPr lang="ja-JP" altLang="en-US" sz="1600" dirty="0">
                 <a:solidFill>
                   <a:srgbClr val="1B2430"/>
                 </a:solidFill>
@@ -2558,14 +2558,14 @@
               </a:rPr>
               <a:t>モジュール</a:t>
             </a:r>
-            <a:endParaRPr lang="ja-JP" sz="1500" dirty="0"/>
+            <a:endParaRPr lang="ja-JP" sz="1600" dirty="0"/>
           </a:p>
           <a:p>
             <a:pPr algn="l" indent="0" marL="0">
               <a:buNone/>
             </a:pPr>
             <a:r>
-              <a:rPr lang="ja-JP" altLang="en-US" sz="1500" dirty="0">
+              <a:rPr lang="ja-JP" altLang="en-US" sz="1600" dirty="0">
                 <a:solidFill>
                   <a:srgbClr val="1B2430"/>
                 </a:solidFill>
@@ -2575,7 +2575,7 @@
               </a:rPr>
               <a:t>必要な拡張だけを実装する。組み込みは小さく、応用は RV64GC などから広げられる。</a:t>
             </a:r>
-            <a:endParaRPr lang="ja-JP" sz="1500" dirty="0"/>
+            <a:endParaRPr lang="ja-JP" sz="1600" dirty="0"/>
           </a:p>
         </p:txBody>
       </p:sp>
@@ -2612,7 +2612,7 @@
               <a:buNone/>
             </a:pPr>
             <a:r>
-              <a:rPr lang="ja-JP" altLang="en-US" sz="1500" dirty="0">
+              <a:rPr lang="ja-JP" altLang="en-US" sz="1600" dirty="0">
                 <a:solidFill>
                   <a:srgbClr val="1B2430"/>
                 </a:solidFill>
@@ -2622,14 +2622,14 @@
               </a:rPr>
               <a:t>安定</a:t>
             </a:r>
-            <a:endParaRPr lang="ja-JP" sz="1500" dirty="0"/>
+            <a:endParaRPr lang="ja-JP" sz="1600" dirty="0"/>
           </a:p>
           <a:p>
             <a:pPr algn="l" indent="0" marL="0">
               <a:buNone/>
             </a:pPr>
             <a:r>
-              <a:rPr lang="ja-JP" altLang="en-US" sz="1500" dirty="0">
+              <a:rPr lang="ja-JP" altLang="en-US" sz="1600" dirty="0">
                 <a:solidFill>
                   <a:srgbClr val="1B2430"/>
                 </a:solidFill>
@@ -2639,7 +2639,7 @@
               </a:rPr>
               <a:t>批准済みのベース ISA は凍結する。既存のソフトウェアを壊す変更を入れない。</a:t>
             </a:r>
-            <a:endParaRPr lang="ja-JP" sz="1500" dirty="0"/>
+            <a:endParaRPr lang="ja-JP" sz="1600" dirty="0"/>
           </a:p>
         </p:txBody>
       </p:sp>
@@ -2676,7 +2676,7 @@
               <a:buNone/>
             </a:pPr>
             <a:r>
-              <a:rPr lang="ja-JP" altLang="en-US" sz="1500" dirty="0">
+              <a:rPr lang="ja-JP" altLang="en-US" sz="1600" dirty="0">
                 <a:solidFill>
                   <a:srgbClr val="1B2430"/>
                 </a:solidFill>
@@ -2686,14 +2686,14 @@
               </a:rPr>
               <a:t>実装の自由</a:t>
             </a:r>
-            <a:endParaRPr lang="ja-JP" sz="1500" dirty="0"/>
+            <a:endParaRPr lang="ja-JP" sz="1600" dirty="0"/>
           </a:p>
           <a:p>
             <a:pPr algn="l" indent="0" marL="0">
               <a:buNone/>
             </a:pPr>
             <a:r>
-              <a:rPr lang="ja-JP" altLang="en-US" sz="1500" dirty="0">
+              <a:rPr lang="ja-JP" altLang="en-US" sz="1600" dirty="0">
                 <a:solidFill>
                   <a:srgbClr val="1B2430"/>
                 </a:solidFill>
@@ -2703,7 +2703,7 @@
               </a:rPr>
               <a:t>パイプラインやキャッシュの形は ISA が縛りすぎない。ASIC でも FPGA でも同じ命令セット。</a:t>
             </a:r>
-            <a:endParaRPr lang="ja-JP" sz="1500" dirty="0"/>
+            <a:endParaRPr lang="ja-JP" sz="1600" dirty="0"/>
           </a:p>
         </p:txBody>
       </p:sp>
@@ -2787,8 +2787,8 @@
         </p:nvSpPr>
         <p:spPr>
           <a:xfrm>
-            <a:off x="0" y="6565392"/>
-            <a:ext cx="12191695" cy="292608"/>
+            <a:off x="0" y="6510528"/>
+            <a:ext cx="12191695" cy="347472"/>
           </a:xfrm>
           <a:prstGeom prst="rect">
             <a:avLst/>
@@ -2807,8 +2807,8 @@
         </p:nvSpPr>
         <p:spPr>
           <a:xfrm>
-            <a:off x="411480" y="6565392"/>
-            <a:ext cx="11338560" cy="292608"/>
+            <a:off x="411480" y="6510528"/>
+            <a:ext cx="11338560" cy="347472"/>
           </a:xfrm>
           <a:prstGeom prst="rect">
             <a:avLst/>
@@ -2824,7 +2824,7 @@
               <a:buNone/>
             </a:pPr>
             <a:r>
-              <a:rPr lang="ja-JP" altLang="en-US" sz="1100" dirty="0">
+              <a:rPr lang="ja-JP" altLang="en-US" sz="1400" dirty="0">
                 <a:solidFill>
                   <a:srgbClr val="5C6B7A"/>
                 </a:solidFill>
@@ -2834,7 +2834,7 @@
               </a:rPr>
               <a:t>RISC-V 入門  ·  オープン ISA</a:t>
             </a:r>
-            <a:endParaRPr lang="ja-JP" sz="1100" dirty="0"/>
+            <a:endParaRPr lang="ja-JP" sz="1400" dirty="0"/>
           </a:p>
         </p:txBody>
       </p:sp>
@@ -2846,8 +2846,8 @@
         </p:nvSpPr>
         <p:spPr>
           <a:xfrm>
-            <a:off x="411480" y="54864"/>
-            <a:ext cx="11338560" cy="457200"/>
+            <a:off x="411480" y="45720"/>
+            <a:ext cx="11338560" cy="493776"/>
           </a:xfrm>
           <a:prstGeom prst="rect">
             <a:avLst/>
@@ -2863,7 +2863,7 @@
               <a:buNone/>
             </a:pPr>
             <a:r>
-              <a:rPr lang="ja-JP" altLang="en-US" sz="2200" b="1" dirty="0">
+              <a:rPr lang="ja-JP" altLang="en-US" sz="2600" b="1" dirty="0">
                 <a:solidFill>
                   <a:srgbClr val="1B2430"/>
                 </a:solidFill>
@@ -2873,7 +2873,7 @@
               </a:rPr>
               <a:t>ベース整数 ISA</a:t>
             </a:r>
-            <a:endParaRPr lang="ja-JP" sz="2200" dirty="0"/>
+            <a:endParaRPr lang="ja-JP" sz="2600" dirty="0"/>
           </a:p>
         </p:txBody>
       </p:sp>
@@ -2902,7 +2902,7 @@
               <a:buNone/>
             </a:pPr>
             <a:r>
-              <a:rPr lang="ja-JP" altLang="en-US" sz="1500" dirty="0">
+              <a:rPr lang="ja-JP" altLang="en-US" sz="1600" dirty="0">
                 <a:solidFill>
                   <a:srgbClr val="1B2430"/>
                 </a:solidFill>
@@ -2912,7 +2912,7 @@
               </a:rPr>
               <a:t>整数ベースは RV32I / RV64I / RV128I。組み込み向けにレジスタ 16 本の RV32E もあります。命令は基本 32 ビットです。</a:t>
             </a:r>
-            <a:endParaRPr lang="ja-JP" sz="1500" dirty="0"/>
+            <a:endParaRPr lang="ja-JP" sz="1600" dirty="0"/>
           </a:p>
         </p:txBody>
       </p:sp>
@@ -3169,7 +3169,7 @@
               <a:buNone/>
             </a:pPr>
             <a:r>
-              <a:rPr lang="ja-JP" altLang="en-US" sz="1300" dirty="0">
+              <a:rPr lang="ja-JP" altLang="en-US" sz="1600" dirty="0">
                 <a:solidFill>
                   <a:srgbClr val="5C6B7A"/>
                 </a:solidFill>
@@ -3179,7 +3179,7 @@
               </a:rPr>
               <a:t>常に 0。書き込みは捨てられます。</a:t>
             </a:r>
-            <a:endParaRPr lang="ja-JP" sz="1300" dirty="0"/>
+            <a:endParaRPr lang="ja-JP" sz="1600" dirty="0"/>
           </a:p>
         </p:txBody>
       </p:sp>
@@ -3263,7 +3263,7 @@
               <a:buNone/>
             </a:pPr>
             <a:r>
-              <a:rPr lang="ja-JP" altLang="en-US" sz="1300" b="1" dirty="0">
+              <a:rPr lang="ja-JP" altLang="en-US" sz="1600" b="1" dirty="0">
                 <a:solidFill>
                   <a:srgbClr val="1B2430"/>
                 </a:solidFill>
@@ -3273,14 +3273,14 @@
               </a:rPr>
               <a:t>半透明</a:t>
             </a:r>
-            <a:endParaRPr lang="ja-JP" sz="1300" dirty="0"/>
+            <a:endParaRPr lang="ja-JP" sz="1600" dirty="0"/>
           </a:p>
           <a:p>
             <a:pPr algn="ctr" indent="0" marL="0">
               <a:buNone/>
             </a:pPr>
             <a:r>
-              <a:rPr lang="ja-JP" altLang="en-US" sz="1300" b="1" dirty="0">
+              <a:rPr lang="ja-JP" altLang="en-US" sz="1600" b="1" dirty="0">
                 <a:solidFill>
                   <a:srgbClr val="1B2430"/>
                 </a:solidFill>
@@ -3290,7 +3290,7 @@
               </a:rPr>
               <a:t>F/D の fp</a:t>
             </a:r>
-            <a:endParaRPr lang="ja-JP" sz="1300" dirty="0"/>
+            <a:endParaRPr lang="ja-JP" sz="1600" dirty="0"/>
           </a:p>
         </p:txBody>
       </p:sp>
@@ -3319,7 +3319,7 @@
               <a:buNone/>
             </a:pPr>
             <a:r>
-              <a:rPr lang="ja-JP" altLang="en-US" sz="1400" dirty="0">
+              <a:rPr lang="ja-JP" altLang="en-US" sz="1600" dirty="0">
                 <a:solidFill>
                   <a:srgbClr val="5C6B7A"/>
                 </a:solidFill>
@@ -3329,7 +3329,7 @@
               </a:rPr>
               <a:t>ABI 名の例: ra, sp, gp, tp, t0–t6, s0–s11, a0–a7。浮動小数点レジスタは F / D 拡張で別途追加します。</a:t>
             </a:r>
-            <a:endParaRPr lang="ja-JP" sz="1400" dirty="0"/>
+            <a:endParaRPr lang="ja-JP" sz="1600" dirty="0"/>
           </a:p>
         </p:txBody>
       </p:sp>
@@ -3413,8 +3413,8 @@
         </p:nvSpPr>
         <p:spPr>
           <a:xfrm>
-            <a:off x="0" y="6565392"/>
-            <a:ext cx="12191695" cy="292608"/>
+            <a:off x="0" y="6510528"/>
+            <a:ext cx="12191695" cy="347472"/>
           </a:xfrm>
           <a:prstGeom prst="rect">
             <a:avLst/>
@@ -3433,8 +3433,8 @@
         </p:nvSpPr>
         <p:spPr>
           <a:xfrm>
-            <a:off x="411480" y="6565392"/>
-            <a:ext cx="11338560" cy="292608"/>
+            <a:off x="411480" y="6510528"/>
+            <a:ext cx="11338560" cy="347472"/>
           </a:xfrm>
           <a:prstGeom prst="rect">
             <a:avLst/>
@@ -3450,7 +3450,7 @@
               <a:buNone/>
             </a:pPr>
             <a:r>
-              <a:rPr lang="ja-JP" altLang="en-US" sz="1100" dirty="0">
+              <a:rPr lang="ja-JP" altLang="en-US" sz="1400" dirty="0">
                 <a:solidFill>
                   <a:srgbClr val="5C6B7A"/>
                 </a:solidFill>
@@ -3460,7 +3460,7 @@
               </a:rPr>
               <a:t>RISC-V 入門  ·  オープン ISA</a:t>
             </a:r>
-            <a:endParaRPr lang="ja-JP" sz="1100" dirty="0"/>
+            <a:endParaRPr lang="ja-JP" sz="1400" dirty="0"/>
           </a:p>
         </p:txBody>
       </p:sp>
@@ -3472,8 +3472,8 @@
         </p:nvSpPr>
         <p:spPr>
           <a:xfrm>
-            <a:off x="411480" y="54864"/>
-            <a:ext cx="11338560" cy="457200"/>
+            <a:off x="411480" y="45720"/>
+            <a:ext cx="11338560" cy="493776"/>
           </a:xfrm>
           <a:prstGeom prst="rect">
             <a:avLst/>
@@ -3489,7 +3489,7 @@
               <a:buNone/>
             </a:pPr>
             <a:r>
-              <a:rPr lang="ja-JP" altLang="en-US" sz="2200" b="1" dirty="0">
+              <a:rPr lang="ja-JP" altLang="en-US" sz="2600" b="1" dirty="0">
                 <a:solidFill>
                   <a:srgbClr val="1B2430"/>
                 </a:solidFill>
@@ -3499,7 +3499,7 @@
               </a:rPr>
               <a:t>命令フォーマット</a:t>
             </a:r>
-            <a:endParaRPr lang="ja-JP" sz="2200" dirty="0"/>
+            <a:endParaRPr lang="ja-JP" sz="2600" dirty="0"/>
           </a:p>
         </p:txBody>
       </p:sp>
@@ -3528,7 +3528,7 @@
               <a:buNone/>
             </a:pPr>
             <a:r>
-              <a:rPr lang="ja-JP" altLang="en-US" sz="1500" dirty="0">
+              <a:rPr lang="ja-JP" altLang="en-US" sz="1600" dirty="0">
                 <a:solidFill>
                   <a:srgbClr val="1B2430"/>
                 </a:solidFill>
@@ -3538,7 +3538,7 @@
               </a:rPr>
               <a:t>ベース ISA の命令は 32 ビットで、R / I / S / B / U / J の 6 形式です。即値は符号拡張します。</a:t>
             </a:r>
-            <a:endParaRPr lang="ja-JP" sz="1500" dirty="0"/>
+            <a:endParaRPr lang="ja-JP" sz="1600" dirty="0"/>
           </a:p>
         </p:txBody>
       </p:sp>
@@ -3569,7 +3569,7 @@
               <a:buNone/>
             </a:pPr>
             <a:r>
-              <a:rPr lang="ja-JP" altLang="en-US" sz="1300" b="1" dirty="0">
+              <a:rPr lang="ja-JP" altLang="en-US" sz="1600" b="1" dirty="0">
                 <a:solidFill>
                   <a:srgbClr val="FFFFFF"/>
                 </a:solidFill>
@@ -3579,7 +3579,7 @@
               </a:rPr>
               <a:t>opcode</a:t>
             </a:r>
-            <a:endParaRPr lang="ja-JP" sz="1300" dirty="0"/>
+            <a:endParaRPr lang="ja-JP" sz="1600" dirty="0"/>
           </a:p>
         </p:txBody>
       </p:sp>
@@ -3610,7 +3610,7 @@
               <a:buNone/>
             </a:pPr>
             <a:r>
-              <a:rPr lang="ja-JP" altLang="en-US" sz="1300" b="1" dirty="0">
+              <a:rPr lang="ja-JP" altLang="en-US" sz="1600" b="1" dirty="0">
                 <a:solidFill>
                   <a:srgbClr val="FFFFFF"/>
                 </a:solidFill>
@@ -3620,7 +3620,7 @@
               </a:rPr>
               <a:t>rd</a:t>
             </a:r>
-            <a:endParaRPr lang="ja-JP" sz="1300" dirty="0"/>
+            <a:endParaRPr lang="ja-JP" sz="1600" dirty="0"/>
           </a:p>
         </p:txBody>
       </p:sp>
@@ -3651,7 +3651,7 @@
               <a:buNone/>
             </a:pPr>
             <a:r>
-              <a:rPr lang="ja-JP" altLang="en-US" sz="1300" b="1" dirty="0">
+              <a:rPr lang="ja-JP" altLang="en-US" sz="1600" b="1" dirty="0">
                 <a:solidFill>
                   <a:srgbClr val="FFFFFF"/>
                 </a:solidFill>
@@ -3661,7 +3661,7 @@
               </a:rPr>
               <a:t>funct3</a:t>
             </a:r>
-            <a:endParaRPr lang="ja-JP" sz="1300" dirty="0"/>
+            <a:endParaRPr lang="ja-JP" sz="1600" dirty="0"/>
           </a:p>
         </p:txBody>
       </p:sp>
@@ -3692,7 +3692,7 @@
               <a:buNone/>
             </a:pPr>
             <a:r>
-              <a:rPr lang="ja-JP" altLang="en-US" sz="1300" b="1" dirty="0">
+              <a:rPr lang="ja-JP" altLang="en-US" sz="1600" b="1" dirty="0">
                 <a:solidFill>
                   <a:srgbClr val="FFFFFF"/>
                 </a:solidFill>
@@ -3702,7 +3702,7 @@
               </a:rPr>
               <a:t>rs1</a:t>
             </a:r>
-            <a:endParaRPr lang="ja-JP" sz="1300" dirty="0"/>
+            <a:endParaRPr lang="ja-JP" sz="1600" dirty="0"/>
           </a:p>
         </p:txBody>
       </p:sp>
@@ -3733,7 +3733,7 @@
               <a:buNone/>
             </a:pPr>
             <a:r>
-              <a:rPr lang="ja-JP" altLang="en-US" sz="1300" b="1" dirty="0">
+              <a:rPr lang="ja-JP" altLang="en-US" sz="1600" b="1" dirty="0">
                 <a:solidFill>
                   <a:srgbClr val="FFFFFF"/>
                 </a:solidFill>
@@ -3743,7 +3743,7 @@
               </a:rPr>
               <a:t>rs2</a:t>
             </a:r>
-            <a:endParaRPr lang="ja-JP" sz="1300" dirty="0"/>
+            <a:endParaRPr lang="ja-JP" sz="1600" dirty="0"/>
           </a:p>
         </p:txBody>
       </p:sp>
@@ -3774,7 +3774,7 @@
               <a:buNone/>
             </a:pPr>
             <a:r>
-              <a:rPr lang="ja-JP" altLang="en-US" sz="1300" b="1" dirty="0">
+              <a:rPr lang="ja-JP" altLang="en-US" sz="1600" b="1" dirty="0">
                 <a:solidFill>
                   <a:srgbClr val="FFFFFF"/>
                 </a:solidFill>
@@ -3784,7 +3784,7 @@
               </a:rPr>
               <a:t>funct7 / imm</a:t>
             </a:r>
-            <a:endParaRPr lang="ja-JP" sz="1300" dirty="0"/>
+            <a:endParaRPr lang="ja-JP" sz="1600" dirty="0"/>
           </a:p>
         </p:txBody>
       </p:sp>
@@ -3833,7 +3833,7 @@
               <a:buNone/>
             </a:pPr>
             <a:r>
-              <a:rPr lang="ja-JP" altLang="en-US" sz="1300" dirty="0">
+              <a:rPr lang="ja-JP" altLang="en-US" sz="1600" dirty="0">
                 <a:solidFill>
                   <a:srgbClr val="C97800"/>
                 </a:solidFill>
@@ -3843,7 +3843,7 @@
               </a:rPr>
               <a:t>即値は形式ごとにビット配置が違う</a:t>
             </a:r>
-            <a:endParaRPr lang="ja-JP" sz="1300" dirty="0"/>
+            <a:endParaRPr lang="ja-JP" sz="1600" dirty="0"/>
           </a:p>
         </p:txBody>
       </p:sp>
@@ -3880,7 +3880,7 @@
               <a:buNone/>
             </a:pPr>
             <a:r>
-              <a:rPr lang="ja-JP" altLang="en-US" sz="1400" dirty="0">
+              <a:rPr lang="ja-JP" altLang="en-US" sz="1600" dirty="0">
                 <a:solidFill>
                   <a:srgbClr val="1B2430"/>
                 </a:solidFill>
@@ -3890,14 +3890,14 @@
               </a:rPr>
               <a:t>R  レジスタ演算</a:t>
             </a:r>
-            <a:endParaRPr lang="ja-JP" sz="1400" dirty="0"/>
+            <a:endParaRPr lang="ja-JP" sz="1600" dirty="0"/>
           </a:p>
           <a:p>
             <a:pPr algn="l" indent="0" marL="0">
               <a:buNone/>
             </a:pPr>
             <a:r>
-              <a:rPr lang="ja-JP" altLang="en-US" sz="1400" dirty="0">
+              <a:rPr lang="ja-JP" altLang="en-US" sz="1600" dirty="0">
                 <a:solidFill>
                   <a:srgbClr val="1B2430"/>
                 </a:solidFill>
@@ -3907,7 +3907,7 @@
               </a:rPr>
               <a:t>add, sub, and, or, xor</a:t>
             </a:r>
-            <a:endParaRPr lang="ja-JP" sz="1400" dirty="0"/>
+            <a:endParaRPr lang="ja-JP" sz="1600" dirty="0"/>
           </a:p>
         </p:txBody>
       </p:sp>
@@ -3944,7 +3944,7 @@
               <a:buNone/>
             </a:pPr>
             <a:r>
-              <a:rPr lang="ja-JP" altLang="en-US" sz="1400" dirty="0">
+              <a:rPr lang="ja-JP" altLang="en-US" sz="1600" dirty="0">
                 <a:solidFill>
                   <a:srgbClr val="1B2430"/>
                 </a:solidFill>
@@ -3954,14 +3954,14 @@
               </a:rPr>
               <a:t>I  即値・ロード</a:t>
             </a:r>
-            <a:endParaRPr lang="ja-JP" sz="1400" dirty="0"/>
+            <a:endParaRPr lang="ja-JP" sz="1600" dirty="0"/>
           </a:p>
           <a:p>
             <a:pPr algn="l" indent="0" marL="0">
               <a:buNone/>
             </a:pPr>
             <a:r>
-              <a:rPr lang="ja-JP" altLang="en-US" sz="1400" dirty="0">
+              <a:rPr lang="ja-JP" altLang="en-US" sz="1600" dirty="0">
                 <a:solidFill>
                   <a:srgbClr val="1B2430"/>
                 </a:solidFill>
@@ -3971,7 +3971,7 @@
               </a:rPr>
               <a:t>addi, lw, jalr, シフト</a:t>
             </a:r>
-            <a:endParaRPr lang="ja-JP" sz="1400" dirty="0"/>
+            <a:endParaRPr lang="ja-JP" sz="1600" dirty="0"/>
           </a:p>
         </p:txBody>
       </p:sp>
@@ -4008,7 +4008,7 @@
               <a:buNone/>
             </a:pPr>
             <a:r>
-              <a:rPr lang="ja-JP" altLang="en-US" sz="1400" dirty="0">
+              <a:rPr lang="ja-JP" altLang="en-US" sz="1600" dirty="0">
                 <a:solidFill>
                   <a:srgbClr val="1B2430"/>
                 </a:solidFill>
@@ -4018,14 +4018,14 @@
               </a:rPr>
               <a:t>S  ストア</a:t>
             </a:r>
-            <a:endParaRPr lang="ja-JP" sz="1400" dirty="0"/>
+            <a:endParaRPr lang="ja-JP" sz="1600" dirty="0"/>
           </a:p>
           <a:p>
             <a:pPr algn="l" indent="0" marL="0">
               <a:buNone/>
             </a:pPr>
             <a:r>
-              <a:rPr lang="ja-JP" altLang="en-US" sz="1400" dirty="0">
+              <a:rPr lang="ja-JP" altLang="en-US" sz="1600" dirty="0">
                 <a:solidFill>
                   <a:srgbClr val="1B2430"/>
                 </a:solidFill>
@@ -4035,7 +4035,7 @@
               </a:rPr>
               <a:t>sw, sh, sb</a:t>
             </a:r>
-            <a:endParaRPr lang="ja-JP" sz="1400" dirty="0"/>
+            <a:endParaRPr lang="ja-JP" sz="1600" dirty="0"/>
           </a:p>
         </p:txBody>
       </p:sp>
@@ -4072,7 +4072,7 @@
               <a:buNone/>
             </a:pPr>
             <a:r>
-              <a:rPr lang="ja-JP" altLang="en-US" sz="1400" dirty="0">
+              <a:rPr lang="ja-JP" altLang="en-US" sz="1600" dirty="0">
                 <a:solidFill>
                   <a:srgbClr val="1B2430"/>
                 </a:solidFill>
@@ -4082,14 +4082,14 @@
               </a:rPr>
               <a:t>B  条件分岐</a:t>
             </a:r>
-            <a:endParaRPr lang="ja-JP" sz="1400" dirty="0"/>
+            <a:endParaRPr lang="ja-JP" sz="1600" dirty="0"/>
           </a:p>
           <a:p>
             <a:pPr algn="l" indent="0" marL="0">
               <a:buNone/>
             </a:pPr>
             <a:r>
-              <a:rPr lang="ja-JP" altLang="en-US" sz="1400" dirty="0">
+              <a:rPr lang="ja-JP" altLang="en-US" sz="1600" dirty="0">
                 <a:solidFill>
                   <a:srgbClr val="1B2430"/>
                 </a:solidFill>
@@ -4099,7 +4099,7 @@
               </a:rPr>
               <a:t>beq, bne, blt, bge</a:t>
             </a:r>
-            <a:endParaRPr lang="ja-JP" sz="1400" dirty="0"/>
+            <a:endParaRPr lang="ja-JP" sz="1600" dirty="0"/>
           </a:p>
         </p:txBody>
       </p:sp>
@@ -4136,7 +4136,7 @@
               <a:buNone/>
             </a:pPr>
             <a:r>
-              <a:rPr lang="ja-JP" altLang="en-US" sz="1400" dirty="0">
+              <a:rPr lang="ja-JP" altLang="en-US" sz="1600" dirty="0">
                 <a:solidFill>
                   <a:srgbClr val="1B2430"/>
                 </a:solidFill>
@@ -4146,14 +4146,14 @@
               </a:rPr>
               <a:t>U  上位即値</a:t>
             </a:r>
-            <a:endParaRPr lang="ja-JP" sz="1400" dirty="0"/>
+            <a:endParaRPr lang="ja-JP" sz="1600" dirty="0"/>
           </a:p>
           <a:p>
             <a:pPr algn="l" indent="0" marL="0">
               <a:buNone/>
             </a:pPr>
             <a:r>
-              <a:rPr lang="ja-JP" altLang="en-US" sz="1400" dirty="0">
+              <a:rPr lang="ja-JP" altLang="en-US" sz="1600" dirty="0">
                 <a:solidFill>
                   <a:srgbClr val="1B2430"/>
                 </a:solidFill>
@@ -4163,7 +4163,7 @@
               </a:rPr>
               <a:t>lui, auipc</a:t>
             </a:r>
-            <a:endParaRPr lang="ja-JP" sz="1400" dirty="0"/>
+            <a:endParaRPr lang="ja-JP" sz="1600" dirty="0"/>
           </a:p>
         </p:txBody>
       </p:sp>
@@ -4200,7 +4200,7 @@
               <a:buNone/>
             </a:pPr>
             <a:r>
-              <a:rPr lang="ja-JP" altLang="en-US" sz="1400" dirty="0">
+              <a:rPr lang="ja-JP" altLang="en-US" sz="1600" dirty="0">
                 <a:solidFill>
                   <a:srgbClr val="1B2430"/>
                 </a:solidFill>
@@ -4210,14 +4210,14 @@
               </a:rPr>
               <a:t>J  ジャンプ</a:t>
             </a:r>
-            <a:endParaRPr lang="ja-JP" sz="1400" dirty="0"/>
+            <a:endParaRPr lang="ja-JP" sz="1600" dirty="0"/>
           </a:p>
           <a:p>
             <a:pPr algn="l" indent="0" marL="0">
               <a:buNone/>
             </a:pPr>
             <a:r>
-              <a:rPr lang="ja-JP" altLang="en-US" sz="1400" dirty="0">
+              <a:rPr lang="ja-JP" altLang="en-US" sz="1600" dirty="0">
                 <a:solidFill>
                   <a:srgbClr val="1B2430"/>
                 </a:solidFill>
@@ -4227,7 +4227,7 @@
               </a:rPr>
               <a:t>jal</a:t>
             </a:r>
-            <a:endParaRPr lang="ja-JP" sz="1400" dirty="0"/>
+            <a:endParaRPr lang="ja-JP" sz="1600" dirty="0"/>
           </a:p>
         </p:txBody>
       </p:sp>
@@ -4311,8 +4311,8 @@
         </p:nvSpPr>
         <p:spPr>
           <a:xfrm>
-            <a:off x="0" y="6565392"/>
-            <a:ext cx="12191695" cy="292608"/>
+            <a:off x="0" y="6510528"/>
+            <a:ext cx="12191695" cy="347472"/>
           </a:xfrm>
           <a:prstGeom prst="rect">
             <a:avLst/>
@@ -4331,8 +4331,8 @@
         </p:nvSpPr>
         <p:spPr>
           <a:xfrm>
-            <a:off x="411480" y="6565392"/>
-            <a:ext cx="11338560" cy="292608"/>
+            <a:off x="411480" y="6510528"/>
+            <a:ext cx="11338560" cy="347472"/>
           </a:xfrm>
           <a:prstGeom prst="rect">
             <a:avLst/>
@@ -4348,7 +4348,7 @@
               <a:buNone/>
             </a:pPr>
             <a:r>
-              <a:rPr lang="ja-JP" altLang="en-US" sz="1100" dirty="0">
+              <a:rPr lang="ja-JP" altLang="en-US" sz="1400" dirty="0">
                 <a:solidFill>
                   <a:srgbClr val="5C6B7A"/>
                 </a:solidFill>
@@ -4358,7 +4358,7 @@
               </a:rPr>
               <a:t>RISC-V 入門  ·  オープン ISA</a:t>
             </a:r>
-            <a:endParaRPr lang="ja-JP" sz="1100" dirty="0"/>
+            <a:endParaRPr lang="ja-JP" sz="1400" dirty="0"/>
           </a:p>
         </p:txBody>
       </p:sp>
@@ -4370,8 +4370,8 @@
         </p:nvSpPr>
         <p:spPr>
           <a:xfrm>
-            <a:off x="411480" y="54864"/>
-            <a:ext cx="11338560" cy="457200"/>
+            <a:off x="411480" y="45720"/>
+            <a:ext cx="11338560" cy="493776"/>
           </a:xfrm>
           <a:prstGeom prst="rect">
             <a:avLst/>
@@ -4387,7 +4387,7 @@
               <a:buNone/>
             </a:pPr>
             <a:r>
-              <a:rPr lang="ja-JP" altLang="en-US" sz="2200" b="1" dirty="0">
+              <a:rPr lang="ja-JP" altLang="en-US" sz="2600" b="1" dirty="0">
                 <a:solidFill>
                   <a:srgbClr val="1B2430"/>
                 </a:solidFill>
@@ -4397,7 +4397,7 @@
               </a:rPr>
               <a:t>標準拡張</a:t>
             </a:r>
-            <a:endParaRPr lang="ja-JP" sz="2200" dirty="0"/>
+            <a:endParaRPr lang="ja-JP" sz="2600" dirty="0"/>
           </a:p>
         </p:txBody>
       </p:sp>
@@ -4472,8 +4472,8 @@
         </p:nvSpPr>
         <p:spPr>
           <a:xfrm>
-            <a:off x="3383280" y="1874520"/>
-            <a:ext cx="1371600" cy="320040"/>
+            <a:off x="3246120" y="1783080"/>
+            <a:ext cx="1554480" cy="502920"/>
           </a:xfrm>
           <a:prstGeom prst="rect">
             <a:avLst/>
@@ -4489,7 +4489,7 @@
               <a:buNone/>
             </a:pPr>
             <a:r>
-              <a:rPr lang="ja-JP" altLang="en-US" sz="1100" dirty="0">
+              <a:rPr lang="ja-JP" altLang="en-US" sz="1400" dirty="0">
                 <a:solidFill>
                   <a:srgbClr val="5C6B7A"/>
                 </a:solidFill>
@@ -4499,7 +4499,7 @@
               </a:rPr>
               <a:t>必要なものだけを足す</a:t>
             </a:r>
-            <a:endParaRPr lang="ja-JP" sz="1100" dirty="0"/>
+            <a:endParaRPr lang="ja-JP" sz="1400" dirty="0"/>
           </a:p>
         </p:txBody>
       </p:sp>
@@ -4759,7 +4759,7 @@
               <a:buNone/>
             </a:pPr>
             <a:r>
-              <a:rPr lang="ja-JP" altLang="en-US" sz="1500" dirty="0">
+              <a:rPr lang="ja-JP" altLang="en-US" sz="1600" dirty="0">
                 <a:solidFill>
                   <a:srgbClr val="1B2430"/>
                 </a:solidFill>
@@ -4769,14 +4769,14 @@
               </a:rPr>
               <a:t>M  整数の乗算・除算</a:t>
             </a:r>
-            <a:endParaRPr lang="ja-JP" sz="1500" dirty="0"/>
+            <a:endParaRPr lang="ja-JP" sz="1600" dirty="0"/>
           </a:p>
           <a:p>
             <a:pPr algn="l" indent="0" marL="0">
               <a:buNone/>
             </a:pPr>
             <a:r>
-              <a:rPr lang="ja-JP" altLang="en-US" sz="1500" dirty="0">
+              <a:rPr lang="ja-JP" altLang="en-US" sz="1600" dirty="0">
                 <a:solidFill>
                   <a:srgbClr val="1B2430"/>
                 </a:solidFill>
@@ -4786,14 +4786,14 @@
               </a:rPr>
               <a:t>A  アトミック（A 拡張）</a:t>
             </a:r>
-            <a:endParaRPr lang="ja-JP" sz="1500" dirty="0"/>
+            <a:endParaRPr lang="ja-JP" sz="1600" dirty="0"/>
           </a:p>
           <a:p>
             <a:pPr algn="l" indent="0" marL="0">
               <a:buNone/>
             </a:pPr>
             <a:r>
-              <a:rPr lang="ja-JP" altLang="en-US" sz="1500" dirty="0">
+              <a:rPr lang="ja-JP" altLang="en-US" sz="1600" dirty="0">
                 <a:solidFill>
                   <a:srgbClr val="1B2430"/>
                 </a:solidFill>
@@ -4803,14 +4803,14 @@
               </a:rPr>
               <a:t>F  単精度浮動小数点</a:t>
             </a:r>
-            <a:endParaRPr lang="ja-JP" sz="1500" dirty="0"/>
+            <a:endParaRPr lang="ja-JP" sz="1600" dirty="0"/>
           </a:p>
           <a:p>
             <a:pPr algn="l" indent="0" marL="0">
               <a:buNone/>
             </a:pPr>
             <a:r>
-              <a:rPr lang="ja-JP" altLang="en-US" sz="1500" dirty="0">
+              <a:rPr lang="ja-JP" altLang="en-US" sz="1600" dirty="0">
                 <a:solidFill>
                   <a:srgbClr val="1B2430"/>
                 </a:solidFill>
@@ -4820,7 +4820,7 @@
               </a:rPr>
               <a:t>D  倍精度浮動小数点</a:t>
             </a:r>
-            <a:endParaRPr lang="ja-JP" sz="1500" dirty="0"/>
+            <a:endParaRPr lang="ja-JP" sz="1600" dirty="0"/>
           </a:p>
         </p:txBody>
       </p:sp>
@@ -4855,7 +4855,7 @@
               <a:buNone/>
             </a:pPr>
             <a:r>
-              <a:rPr lang="ja-JP" altLang="en-US" sz="1500" dirty="0">
+              <a:rPr lang="ja-JP" altLang="en-US" sz="1600" dirty="0">
                 <a:solidFill>
                   <a:srgbClr val="1B2430"/>
                 </a:solidFill>
@@ -4865,14 +4865,14 @@
               </a:rPr>
               <a:t>C  16 ビット圧縮符号化</a:t>
             </a:r>
-            <a:endParaRPr lang="ja-JP" sz="1500" dirty="0"/>
+            <a:endParaRPr lang="ja-JP" sz="1600" dirty="0"/>
           </a:p>
           <a:p>
             <a:pPr algn="l" indent="0" marL="0">
               <a:buNone/>
             </a:pPr>
             <a:r>
-              <a:rPr lang="ja-JP" altLang="en-US" sz="1500" dirty="0">
+              <a:rPr lang="ja-JP" altLang="en-US" sz="1600" dirty="0">
                 <a:solidFill>
                   <a:srgbClr val="1B2430"/>
                 </a:solidFill>
@@ -4882,14 +4882,14 @@
               </a:rPr>
               <a:t>V  ベクトル（批准済み）</a:t>
             </a:r>
-            <a:endParaRPr lang="ja-JP" sz="1500" dirty="0"/>
+            <a:endParaRPr lang="ja-JP" sz="1600" dirty="0"/>
           </a:p>
           <a:p>
             <a:pPr algn="l" indent="0" marL="0">
               <a:buNone/>
             </a:pPr>
             <a:r>
-              <a:rPr lang="ja-JP" altLang="en-US" sz="1500" dirty="0">
+              <a:rPr lang="ja-JP" altLang="en-US" sz="1600" dirty="0">
                 <a:solidFill>
                   <a:srgbClr val="1B2430"/>
                 </a:solidFill>
@@ -4899,14 +4899,14 @@
               </a:rPr>
               <a:t>Zicsr / Zifencei  など</a:t>
             </a:r>
-            <a:endParaRPr lang="ja-JP" sz="1500" dirty="0"/>
+            <a:endParaRPr lang="ja-JP" sz="1600" dirty="0"/>
           </a:p>
           <a:p>
             <a:pPr algn="l" indent="0" marL="0">
               <a:buNone/>
             </a:pPr>
             <a:r>
-              <a:rPr lang="ja-JP" altLang="en-US" sz="1500" dirty="0">
+              <a:rPr lang="ja-JP" altLang="en-US" sz="1600" dirty="0">
                 <a:solidFill>
                   <a:srgbClr val="1B2430"/>
                 </a:solidFill>
@@ -4916,7 +4916,7 @@
               </a:rPr>
               <a:t>B  ビット操作 ほか</a:t>
             </a:r>
-            <a:endParaRPr lang="ja-JP" sz="1500" dirty="0"/>
+            <a:endParaRPr lang="ja-JP" sz="1600" dirty="0"/>
           </a:p>
         </p:txBody>
       </p:sp>
@@ -5104,8 +5104,8 @@
         </p:nvSpPr>
         <p:spPr>
           <a:xfrm>
-            <a:off x="0" y="6565392"/>
-            <a:ext cx="12191695" cy="292608"/>
+            <a:off x="0" y="6510528"/>
+            <a:ext cx="12191695" cy="347472"/>
           </a:xfrm>
           <a:prstGeom prst="rect">
             <a:avLst/>
@@ -5124,8 +5124,8 @@
         </p:nvSpPr>
         <p:spPr>
           <a:xfrm>
-            <a:off x="411480" y="6565392"/>
-            <a:ext cx="11338560" cy="292608"/>
+            <a:off x="411480" y="6510528"/>
+            <a:ext cx="11338560" cy="347472"/>
           </a:xfrm>
           <a:prstGeom prst="rect">
             <a:avLst/>
@@ -5141,7 +5141,7 @@
               <a:buNone/>
             </a:pPr>
             <a:r>
-              <a:rPr lang="ja-JP" altLang="en-US" sz="1100" dirty="0">
+              <a:rPr lang="ja-JP" altLang="en-US" sz="1400" dirty="0">
                 <a:solidFill>
                   <a:srgbClr val="5C6B7A"/>
                 </a:solidFill>
@@ -5151,7 +5151,7 @@
               </a:rPr>
               <a:t>RISC-V 入門  ·  オープン ISA</a:t>
             </a:r>
-            <a:endParaRPr lang="ja-JP" sz="1100" dirty="0"/>
+            <a:endParaRPr lang="ja-JP" sz="1400" dirty="0"/>
           </a:p>
         </p:txBody>
       </p:sp>
@@ -5163,8 +5163,8 @@
         </p:nvSpPr>
         <p:spPr>
           <a:xfrm>
-            <a:off x="411480" y="54864"/>
-            <a:ext cx="11338560" cy="457200"/>
+            <a:off x="411480" y="45720"/>
+            <a:ext cx="11338560" cy="493776"/>
           </a:xfrm>
           <a:prstGeom prst="rect">
             <a:avLst/>
@@ -5180,7 +5180,7 @@
               <a:buNone/>
             </a:pPr>
             <a:r>
-              <a:rPr lang="ja-JP" altLang="en-US" sz="2200" b="1" dirty="0">
+              <a:rPr lang="ja-JP" altLang="en-US" sz="2600" b="1" dirty="0">
                 <a:solidFill>
                   <a:srgbClr val="1B2430"/>
                 </a:solidFill>
@@ -5190,7 +5190,7 @@
               </a:rPr>
               <a:t>特権レベル</a:t>
             </a:r>
-            <a:endParaRPr lang="ja-JP" sz="2200" dirty="0"/>
+            <a:endParaRPr lang="ja-JP" sz="2600" dirty="0"/>
           </a:p>
         </p:txBody>
       </p:sp>
@@ -5460,7 +5460,7 @@
               <a:buNone/>
             </a:pPr>
             <a:r>
-              <a:rPr lang="ja-JP" altLang="en-US" sz="1400" dirty="0">
+              <a:rPr lang="ja-JP" altLang="en-US" sz="1600" dirty="0">
                 <a:solidFill>
                   <a:srgbClr val="1B2430"/>
                 </a:solidFill>
@@ -5470,20 +5470,20 @@
               </a:rPr>
               <a:t>M-mode はすべての実装に必要です。</a:t>
             </a:r>
-            <a:endParaRPr lang="ja-JP" sz="1400" dirty="0"/>
+            <a:endParaRPr lang="ja-JP" sz="1600" dirty="0"/>
           </a:p>
           <a:p>
             <a:pPr indent="0" marL="0">
               <a:buNone/>
             </a:pPr>
-            <a:endParaRPr lang="ja-JP" sz="1400" dirty="0"/>
+            <a:endParaRPr lang="ja-JP" sz="1600" dirty="0"/>
           </a:p>
           <a:p>
             <a:pPr indent="0" marL="0">
               <a:buNone/>
             </a:pPr>
             <a:r>
-              <a:rPr lang="ja-JP" altLang="en-US" sz="1400" dirty="0">
+              <a:rPr lang="ja-JP" altLang="en-US" sz="1600" dirty="0">
                 <a:solidFill>
                   <a:srgbClr val="1B2430"/>
                 </a:solidFill>
@@ -5493,20 +5493,20 @@
               </a:rPr>
               <a:t>Unix 系 OS は S-mode と U-mode を載せます。</a:t>
             </a:r>
-            <a:endParaRPr lang="ja-JP" sz="1400" dirty="0"/>
+            <a:endParaRPr lang="ja-JP" sz="1600" dirty="0"/>
           </a:p>
           <a:p>
             <a:pPr indent="0" marL="0">
               <a:buNone/>
             </a:pPr>
-            <a:endParaRPr lang="ja-JP" sz="1400" dirty="0"/>
+            <a:endParaRPr lang="ja-JP" sz="1600" dirty="0"/>
           </a:p>
           <a:p>
             <a:pPr indent="0" marL="0">
               <a:buNone/>
             </a:pPr>
             <a:r>
-              <a:rPr lang="ja-JP" altLang="en-US" sz="1400" dirty="0">
+              <a:rPr lang="ja-JP" altLang="en-US" sz="1600" dirty="0">
                 <a:solidFill>
                   <a:srgbClr val="1B2430"/>
                 </a:solidFill>
@@ -5516,20 +5516,20 @@
               </a:rPr>
               <a:t>仮想化は Hypervisor（H）拡張です。</a:t>
             </a:r>
-            <a:endParaRPr lang="ja-JP" sz="1400" dirty="0"/>
+            <a:endParaRPr lang="ja-JP" sz="1600" dirty="0"/>
           </a:p>
           <a:p>
             <a:pPr indent="0" marL="0">
               <a:buNone/>
             </a:pPr>
-            <a:endParaRPr lang="ja-JP" sz="1400" dirty="0"/>
+            <a:endParaRPr lang="ja-JP" sz="1600" dirty="0"/>
           </a:p>
           <a:p>
             <a:pPr indent="0" marL="0">
               <a:buNone/>
             </a:pPr>
             <a:r>
-              <a:rPr lang="ja-JP" altLang="en-US" sz="1400" dirty="0">
+              <a:rPr lang="ja-JP" altLang="en-US" sz="1600" dirty="0">
                 <a:solidFill>
                   <a:srgbClr val="1B2430"/>
                 </a:solidFill>
@@ -5539,7 +5539,7 @@
               </a:rPr>
               <a:t>トラップはより高い特権へ渡り、mret / sret で戻ります。</a:t>
             </a:r>
-            <a:endParaRPr lang="ja-JP" sz="1400" dirty="0"/>
+            <a:endParaRPr lang="ja-JP" sz="1600" dirty="0"/>
           </a:p>
         </p:txBody>
       </p:sp>
@@ -5603,8 +5603,8 @@
         </p:nvSpPr>
         <p:spPr>
           <a:xfrm>
-            <a:off x="0" y="6565392"/>
-            <a:ext cx="12191695" cy="292608"/>
+            <a:off x="0" y="6510528"/>
+            <a:ext cx="12191695" cy="347472"/>
           </a:xfrm>
           <a:prstGeom prst="rect">
             <a:avLst/>
@@ -5623,7 +5623,7 @@
         </p:nvSpPr>
         <p:spPr>
           <a:xfrm>
-            <a:off x="0" y="6510528"/>
+            <a:off x="0" y="6455664"/>
             <a:ext cx="12191695" cy="54864"/>
           </a:xfrm>
           <a:prstGeom prst="rect">
@@ -5643,8 +5643,8 @@
         </p:nvSpPr>
         <p:spPr>
           <a:xfrm>
-            <a:off x="411480" y="6565392"/>
-            <a:ext cx="11338560" cy="292608"/>
+            <a:off x="411480" y="6510528"/>
+            <a:ext cx="11338560" cy="347472"/>
           </a:xfrm>
           <a:prstGeom prst="rect">
             <a:avLst/>
@@ -5660,7 +5660,7 @@
               <a:buNone/>
             </a:pPr>
             <a:r>
-              <a:rPr lang="ja-JP" altLang="en-US" sz="1100" dirty="0">
+              <a:rPr lang="ja-JP" altLang="en-US" sz="1400" dirty="0">
                 <a:solidFill>
                   <a:srgbClr val="5C6B7A"/>
                 </a:solidFill>
@@ -5670,7 +5670,7 @@
               </a:rPr>
               <a:t>RISC-V 入門  ·  まとめ</a:t>
             </a:r>
-            <a:endParaRPr lang="ja-JP" sz="1100" dirty="0"/>
+            <a:endParaRPr lang="ja-JP" sz="1400" dirty="0"/>
           </a:p>
         </p:txBody>
       </p:sp>
@@ -5699,7 +5699,7 @@
               <a:buNone/>
             </a:pPr>
             <a:r>
-              <a:rPr lang="ja-JP" altLang="en-US" sz="3200" b="1" dirty="0">
+              <a:rPr lang="ja-JP" altLang="en-US" sz="3600" b="1" dirty="0">
                 <a:solidFill>
                   <a:srgbClr val="1B2430"/>
                 </a:solidFill>
@@ -5709,7 +5709,7 @@
               </a:rPr>
               <a:t>まとめ</a:t>
             </a:r>
-            <a:endParaRPr lang="ja-JP" sz="3200" dirty="0"/>
+            <a:endParaRPr lang="ja-JP" sz="3600" dirty="0"/>
           </a:p>
         </p:txBody>
       </p:sp>
@@ -5768,7 +5768,7 @@
               <a:buNone/>
             </a:pPr>
             <a:r>
-              <a:rPr lang="ja-JP" altLang="en-US" sz="1600" dirty="0">
+              <a:rPr lang="ja-JP" altLang="en-US" sz="1800" dirty="0">
                 <a:solidFill>
                   <a:srgbClr val="1B2430"/>
                 </a:solidFill>
@@ -5778,7 +5778,7 @@
               </a:rPr>
               <a:t>オープン標準。仕様にロイヤリティは不要です。</a:t>
             </a:r>
-            <a:endParaRPr lang="ja-JP" sz="1600" dirty="0"/>
+            <a:endParaRPr lang="ja-JP" sz="1800" dirty="0"/>
           </a:p>
         </p:txBody>
       </p:sp>
@@ -5815,7 +5815,7 @@
               <a:buNone/>
             </a:pPr>
             <a:r>
-              <a:rPr lang="ja-JP" altLang="en-US" sz="1600" dirty="0">
+              <a:rPr lang="ja-JP" altLang="en-US" sz="1800" dirty="0">
                 <a:solidFill>
                   <a:srgbClr val="1B2430"/>
                 </a:solidFill>
@@ -5825,7 +5825,7 @@
               </a:rPr>
               <a:t>ベース ISA を小さく凍結し、機能は M / A / F / D / C / V などの拡張で足します。</a:t>
             </a:r>
-            <a:endParaRPr lang="ja-JP" sz="1600" dirty="0"/>
+            <a:endParaRPr lang="ja-JP" sz="1800" dirty="0"/>
           </a:p>
         </p:txBody>
       </p:sp>
@@ -5862,7 +5862,7 @@
               <a:buNone/>
             </a:pPr>
             <a:r>
-              <a:rPr lang="ja-JP" altLang="en-US" sz="1600" dirty="0">
+              <a:rPr lang="ja-JP" altLang="en-US" sz="1800" dirty="0">
                 <a:solidFill>
                   <a:srgbClr val="1B2430"/>
                 </a:solidFill>
@@ -5872,7 +5872,7 @@
               </a:rPr>
               <a:t>汎用の出発点は RV64GC。特権は M（必須）に加え、OS 向けに S と U を載せます。</a:t>
             </a:r>
-            <a:endParaRPr lang="ja-JP" sz="1600" dirty="0"/>
+            <a:endParaRPr lang="ja-JP" sz="1800" dirty="0"/>
           </a:p>
         </p:txBody>
       </p:sp>
@@ -5901,7 +5901,7 @@
               <a:buNone/>
             </a:pPr>
             <a:r>
-              <a:rPr lang="ja-JP" altLang="en-US" sz="2200" b="1" dirty="0">
+              <a:rPr lang="ja-JP" altLang="en-US" sz="2600" b="1" dirty="0">
                 <a:solidFill>
                   <a:srgbClr val="0B6BCB"/>
                 </a:solidFill>
@@ -5911,7 +5911,7 @@
               </a:rPr>
               <a:t>ご清聴ありがとうございました</a:t>
             </a:r>
-            <a:endParaRPr lang="ja-JP" sz="2200" dirty="0"/>
+            <a:endParaRPr lang="ja-JP" sz="2600" dirty="0"/>
           </a:p>
         </p:txBody>
       </p:sp>

</xml_diff>

<commit_message>
Put template chrome on pptxgenjs slide masters
Move background, header/footer bars, and static footer labels onto defineSlideMaster layouts. Slide YAML still supplies titles and content. Page numbers stay current / total via render-time {{page}} / {{pages}} injection because pptxgenjs slideNumber is current-page only.

Co-authored-by: shotaminato <shotaminato@users.noreply.github.com>
</commit_message>
<xml_diff>
--- a/examples/sample-deck.pptx
+++ b/examples/sample-deck.pptx
@@ -1197,6 +1197,389 @@
 </p:sldLayout>
 </file>
 
+<file path=ppt/slideLayouts/slideLayout2.xml><?xml version="1.0" encoding="utf-8"?>
+<p:sldLayout xmlns:a="http://schemas.openxmlformats.org/drawingml/2006/main" xmlns:r="http://schemas.openxmlformats.org/officeDocument/2006/relationships" xmlns:p="http://schemas.openxmlformats.org/presentationml/2006/main" preserve="1">
+  <p:cSld name="title">
+    <p:bg>
+      <p:bgPr>
+        <a:solidFill>
+          <a:srgbClr val="FFFEFA"/>
+        </a:solidFill>
+      </p:bgPr>
+    </p:bg>
+    <p:spTree>
+      <p:nvGrpSpPr>
+        <p:cNvPr id="1" name=""/>
+        <p:cNvGrpSpPr/>
+        <p:nvPr/>
+      </p:nvGrpSpPr>
+      <p:grpSpPr>
+        <a:xfrm>
+          <a:off x="0" y="0"/>
+          <a:ext cx="0" cy="0"/>
+          <a:chOff x="0" y="0"/>
+          <a:chExt cx="0" cy="0"/>
+        </a:xfrm>
+      </p:grpSpPr>
+      <p:sp>
+        <p:nvSpPr>
+          <p:cNvPr id="2" name="Shape 0"/>
+          <p:cNvSpPr/>
+          <p:nvPr/>
+        </p:nvSpPr>
+        <p:spPr>
+          <a:xfrm>
+            <a:off x="0" y="0"/>
+            <a:ext cx="146304" cy="6858000"/>
+          </a:xfrm>
+          <a:prstGeom prst="rect">
+            <a:avLst/>
+          </a:prstGeom>
+          <a:solidFill>
+            <a:srgbClr val="0B6BCB"/>
+          </a:solidFill>
+          <a:ln/>
+        </p:spPr>
+      </p:sp>
+      <p:sp>
+        <p:nvSpPr>
+          <p:cNvPr id="3" name="Shape 1"/>
+          <p:cNvSpPr/>
+          <p:nvPr/>
+        </p:nvSpPr>
+        <p:spPr>
+          <a:xfrm>
+            <a:off x="0" y="6510528"/>
+            <a:ext cx="12191695" cy="347472"/>
+          </a:xfrm>
+          <a:prstGeom prst="rect">
+            <a:avLst/>
+          </a:prstGeom>
+          <a:solidFill>
+            <a:srgbClr val="F3F1EA"/>
+          </a:solidFill>
+          <a:ln/>
+        </p:spPr>
+      </p:sp>
+      <p:sp>
+        <p:nvSpPr>
+          <p:cNvPr id="4" name="Text 2"/>
+          <p:cNvSpPr/>
+          <p:nvPr/>
+        </p:nvSpPr>
+        <p:spPr>
+          <a:xfrm>
+            <a:off x="502920" y="6510528"/>
+            <a:ext cx="9235440" cy="347472"/>
+          </a:xfrm>
+          <a:prstGeom prst="rect">
+            <a:avLst/>
+          </a:prstGeom>
+          <a:noFill/>
+          <a:ln/>
+        </p:spPr>
+        <p:txBody>
+          <a:bodyPr wrap="square" lIns="0" tIns="0" rIns="0" bIns="0" rtlCol="0" anchor="ctr"/>
+          <a:lstStyle/>
+          <a:p>
+            <a:pPr indent="0" marL="0">
+              <a:buNone/>
+            </a:pPr>
+            <a:r>
+              <a:rPr lang="ja-JP" altLang="en-US" sz="1400" dirty="0">
+                <a:solidFill>
+                  <a:srgbClr val="5C6B7A"/>
+                </a:solidFill>
+                <a:latin typeface="Yu Gothic UI" pitchFamily="34" charset="0"/>
+                <a:ea typeface="Yu Gothic UI" pitchFamily="34" charset="-122"/>
+                <a:cs typeface="Yu Gothic UI" pitchFamily="34" charset="-120"/>
+              </a:rPr>
+              <a:t>RISC-V 入門  ·  オープン ISA</a:t>
+            </a:r>
+            <a:endParaRPr lang="ja-JP" sz="1400" dirty="0"/>
+          </a:p>
+        </p:txBody>
+      </p:sp>
+    </p:spTree>
+  </p:cSld>
+  <p:clrMapOvr>
+    <a:masterClrMapping/>
+  </p:clrMapOvr>
+</p:sldLayout>
+</file>
+
+<file path=ppt/slideLayouts/slideLayout3.xml><?xml version="1.0" encoding="utf-8"?>
+<p:sldLayout xmlns:a="http://schemas.openxmlformats.org/drawingml/2006/main" xmlns:r="http://schemas.openxmlformats.org/officeDocument/2006/relationships" xmlns:p="http://schemas.openxmlformats.org/presentationml/2006/main" preserve="1">
+  <p:cSld name="content">
+    <p:bg>
+      <p:bgPr>
+        <a:solidFill>
+          <a:srgbClr val="FFFEFA"/>
+        </a:solidFill>
+      </p:bgPr>
+    </p:bg>
+    <p:spTree>
+      <p:nvGrpSpPr>
+        <p:cNvPr id="1" name=""/>
+        <p:cNvGrpSpPr/>
+        <p:nvPr/>
+      </p:nvGrpSpPr>
+      <p:grpSpPr>
+        <a:xfrm>
+          <a:off x="0" y="0"/>
+          <a:ext cx="0" cy="0"/>
+          <a:chOff x="0" y="0"/>
+          <a:chExt cx="0" cy="0"/>
+        </a:xfrm>
+      </p:grpSpPr>
+      <p:sp>
+        <p:nvSpPr>
+          <p:cNvPr id="2" name="Shape 0"/>
+          <p:cNvSpPr/>
+          <p:nvPr/>
+        </p:nvSpPr>
+        <p:spPr>
+          <a:xfrm>
+            <a:off x="0" y="0"/>
+            <a:ext cx="12191695" cy="566928"/>
+          </a:xfrm>
+          <a:prstGeom prst="rect">
+            <a:avLst/>
+          </a:prstGeom>
+          <a:solidFill>
+            <a:srgbClr val="E8F3FF"/>
+          </a:solidFill>
+          <a:ln/>
+        </p:spPr>
+      </p:sp>
+      <p:sp>
+        <p:nvSpPr>
+          <p:cNvPr id="3" name="Shape 1"/>
+          <p:cNvSpPr/>
+          <p:nvPr/>
+        </p:nvSpPr>
+        <p:spPr>
+          <a:xfrm>
+            <a:off x="0" y="566928"/>
+            <a:ext cx="12191695" cy="50292"/>
+          </a:xfrm>
+          <a:prstGeom prst="rect">
+            <a:avLst/>
+          </a:prstGeom>
+          <a:solidFill>
+            <a:srgbClr val="0B6BCB"/>
+          </a:solidFill>
+          <a:ln/>
+        </p:spPr>
+      </p:sp>
+      <p:sp>
+        <p:nvSpPr>
+          <p:cNvPr id="4" name="Shape 2"/>
+          <p:cNvSpPr/>
+          <p:nvPr/>
+        </p:nvSpPr>
+        <p:spPr>
+          <a:xfrm>
+            <a:off x="0" y="6510528"/>
+            <a:ext cx="12191695" cy="347472"/>
+          </a:xfrm>
+          <a:prstGeom prst="rect">
+            <a:avLst/>
+          </a:prstGeom>
+          <a:solidFill>
+            <a:srgbClr val="F3F1EA"/>
+          </a:solidFill>
+          <a:ln/>
+        </p:spPr>
+      </p:sp>
+      <p:sp>
+        <p:nvSpPr>
+          <p:cNvPr id="5" name="Text 3"/>
+          <p:cNvSpPr/>
+          <p:nvPr/>
+        </p:nvSpPr>
+        <p:spPr>
+          <a:xfrm>
+            <a:off x="411480" y="6510528"/>
+            <a:ext cx="9326880" cy="347472"/>
+          </a:xfrm>
+          <a:prstGeom prst="rect">
+            <a:avLst/>
+          </a:prstGeom>
+          <a:noFill/>
+          <a:ln/>
+        </p:spPr>
+        <p:txBody>
+          <a:bodyPr wrap="square" lIns="0" tIns="0" rIns="0" bIns="0" rtlCol="0" anchor="ctr"/>
+          <a:lstStyle/>
+          <a:p>
+            <a:pPr indent="0" marL="0">
+              <a:buNone/>
+            </a:pPr>
+            <a:r>
+              <a:rPr lang="ja-JP" altLang="en-US" sz="1400" dirty="0">
+                <a:solidFill>
+                  <a:srgbClr val="5C6B7A"/>
+                </a:solidFill>
+                <a:latin typeface="Yu Gothic UI" pitchFamily="34" charset="0"/>
+                <a:ea typeface="Yu Gothic UI" pitchFamily="34" charset="-122"/>
+                <a:cs typeface="Yu Gothic UI" pitchFamily="34" charset="-120"/>
+              </a:rPr>
+              <a:t>RISC-V 入門  ·  オープン ISA</a:t>
+            </a:r>
+            <a:endParaRPr lang="ja-JP" sz="1400" dirty="0"/>
+          </a:p>
+        </p:txBody>
+      </p:sp>
+    </p:spTree>
+  </p:cSld>
+  <p:clrMapOvr>
+    <a:masterClrMapping/>
+  </p:clrMapOvr>
+</p:sldLayout>
+</file>
+
+<file path=ppt/slideLayouts/slideLayout4.xml><?xml version="1.0" encoding="utf-8"?>
+<p:sldLayout xmlns:a="http://schemas.openxmlformats.org/drawingml/2006/main" xmlns:r="http://schemas.openxmlformats.org/officeDocument/2006/relationships" xmlns:p="http://schemas.openxmlformats.org/presentationml/2006/main" preserve="1">
+  <p:cSld name="conclusion">
+    <p:bg>
+      <p:bgPr>
+        <a:solidFill>
+          <a:srgbClr val="FFFEFA"/>
+        </a:solidFill>
+      </p:bgPr>
+    </p:bg>
+    <p:spTree>
+      <p:nvGrpSpPr>
+        <p:cNvPr id="1" name=""/>
+        <p:cNvGrpSpPr/>
+        <p:nvPr/>
+      </p:nvGrpSpPr>
+      <p:grpSpPr>
+        <a:xfrm>
+          <a:off x="0" y="0"/>
+          <a:ext cx="0" cy="0"/>
+          <a:chOff x="0" y="0"/>
+          <a:chExt cx="0" cy="0"/>
+        </a:xfrm>
+      </p:grpSpPr>
+      <p:sp>
+        <p:nvSpPr>
+          <p:cNvPr id="2" name="Text 0"/>
+          <p:cNvSpPr/>
+          <p:nvPr/>
+        </p:nvSpPr>
+        <p:spPr>
+          <a:xfrm>
+            <a:off x="10698480" y="-777240"/>
+            <a:ext cx="2377440" cy="2377440"/>
+          </a:xfrm>
+          <a:prstGeom prst="ellipse">
+            <a:avLst/>
+          </a:prstGeom>
+          <a:solidFill>
+            <a:srgbClr val="E8F3FF"/>
+          </a:solidFill>
+          <a:ln/>
+        </p:spPr>
+        <p:txBody>
+          <a:bodyPr wrap="square" lIns="50800" tIns="50800" rIns="50800" bIns="50800" rtlCol="0" anchor="ctr"/>
+          <a:lstStyle/>
+          <a:p>
+            <a:pPr algn="ctr" indent="0" marL="0">
+              <a:buNone/>
+            </a:pPr>
+            <a:endParaRPr lang="ja-JP" dirty="0"/>
+          </a:p>
+        </p:txBody>
+      </p:sp>
+      <p:sp>
+        <p:nvSpPr>
+          <p:cNvPr id="3" name="Shape 1"/>
+          <p:cNvSpPr/>
+          <p:nvPr/>
+        </p:nvSpPr>
+        <p:spPr>
+          <a:xfrm>
+            <a:off x="0" y="6510528"/>
+            <a:ext cx="12191695" cy="347472"/>
+          </a:xfrm>
+          <a:prstGeom prst="rect">
+            <a:avLst/>
+          </a:prstGeom>
+          <a:solidFill>
+            <a:srgbClr val="F3F1EA"/>
+          </a:solidFill>
+          <a:ln/>
+        </p:spPr>
+      </p:sp>
+      <p:sp>
+        <p:nvSpPr>
+          <p:cNvPr id="4" name="Shape 2"/>
+          <p:cNvSpPr/>
+          <p:nvPr/>
+        </p:nvSpPr>
+        <p:spPr>
+          <a:xfrm>
+            <a:off x="0" y="6455664"/>
+            <a:ext cx="12191695" cy="54864"/>
+          </a:xfrm>
+          <a:prstGeom prst="rect">
+            <a:avLst/>
+          </a:prstGeom>
+          <a:solidFill>
+            <a:srgbClr val="0B6BCB"/>
+          </a:solidFill>
+          <a:ln/>
+        </p:spPr>
+      </p:sp>
+      <p:sp>
+        <p:nvSpPr>
+          <p:cNvPr id="5" name="Text 3"/>
+          <p:cNvSpPr/>
+          <p:nvPr/>
+        </p:nvSpPr>
+        <p:spPr>
+          <a:xfrm>
+            <a:off x="411480" y="6510528"/>
+            <a:ext cx="9326880" cy="347472"/>
+          </a:xfrm>
+          <a:prstGeom prst="rect">
+            <a:avLst/>
+          </a:prstGeom>
+          <a:noFill/>
+          <a:ln/>
+        </p:spPr>
+        <p:txBody>
+          <a:bodyPr wrap="square" lIns="0" tIns="0" rIns="0" bIns="0" rtlCol="0" anchor="ctr"/>
+          <a:lstStyle/>
+          <a:p>
+            <a:pPr indent="0" marL="0">
+              <a:buNone/>
+            </a:pPr>
+            <a:r>
+              <a:rPr lang="ja-JP" altLang="en-US" sz="1400" dirty="0">
+                <a:solidFill>
+                  <a:srgbClr val="5C6B7A"/>
+                </a:solidFill>
+                <a:latin typeface="Yu Gothic UI" pitchFamily="34" charset="0"/>
+                <a:ea typeface="Yu Gothic UI" pitchFamily="34" charset="-122"/>
+                <a:cs typeface="Yu Gothic UI" pitchFamily="34" charset="-120"/>
+              </a:rPr>
+              <a:t>RISC-V 入門  ·  まとめ</a:t>
+            </a:r>
+            <a:endParaRPr lang="ja-JP" sz="1400" dirty="0"/>
+          </a:p>
+        </p:txBody>
+      </p:sp>
+    </p:spTree>
+  </p:cSld>
+  <p:clrMapOvr>
+    <a:masterClrMapping/>
+  </p:clrMapOvr>
+</p:sldLayout>
+</file>
+
 <file path=ppt/slideMasters/slideMaster1.xml><?xml version="1.0" encoding="utf-8"?>
 <p:sldMaster xmlns:a="http://schemas.openxmlformats.org/drawingml/2006/main" xmlns:r="http://schemas.openxmlformats.org/officeDocument/2006/relationships" xmlns:p="http://schemas.openxmlformats.org/presentationml/2006/main">
   <p:cSld>
@@ -1219,6 +1602,9 @@
   <p:clrMap bg1="lt1" tx1="dk1" bg2="lt2" tx2="dk2" accent1="accent1" accent2="accent2" accent3="accent3" accent4="accent4" accent5="accent5" accent6="accent6" hlink="hlink" folHlink="folHlink"/>
   <p:sldLayoutIdLst>
     <p:sldLayoutId id="2147483649" r:id="rId1"/>
+    <p:sldLayoutId id="2147483650" r:id="rId2"/>
+    <p:sldLayoutId id="2147483651" r:id="rId3"/>
+    <p:sldLayoutId id="2147483652" r:id="rId4"/>
   </p:sldLayoutIdLst>
   <p:hf sldNum="0" hdr="0" ftr="0" dt="0"/>
   <p:txStyles>
@@ -1477,13 +1863,6 @@
 <file path=ppt/slides/slide1.xml><?xml version="1.0" encoding="utf-8"?>
 <p:sld xmlns:a="http://schemas.openxmlformats.org/drawingml/2006/main" xmlns:r="http://schemas.openxmlformats.org/officeDocument/2006/relationships" xmlns:p="http://schemas.openxmlformats.org/presentationml/2006/main">
   <p:cSld name="Slide 1">
-    <p:bg>
-      <p:bgPr>
-        <a:solidFill>
-          <a:srgbClr val="FFFEFA"/>
-        </a:solidFill>
-      </p:bgPr>
-    </p:bg>
     <p:spTree>
       <p:nvGrpSpPr>
         <p:cNvPr id="1" name=""/>
@@ -1500,54 +1879,14 @@
       </p:grpSpPr>
       <p:sp>
         <p:nvSpPr>
-          <p:cNvPr id="3" name="Shape 0"/>
-          <p:cNvSpPr/>
-          <p:nvPr/>
-        </p:nvSpPr>
-        <p:spPr>
-          <a:xfrm>
-            <a:off x="0" y="0"/>
-            <a:ext cx="146304" cy="6858000"/>
-          </a:xfrm>
-          <a:prstGeom prst="rect">
-            <a:avLst/>
-          </a:prstGeom>
-          <a:solidFill>
-            <a:srgbClr val="0B6BCB"/>
-          </a:solidFill>
-          <a:ln/>
-        </p:spPr>
-      </p:sp>
-      <p:sp>
-        <p:nvSpPr>
-          <p:cNvPr id="4" name="Shape 1"/>
-          <p:cNvSpPr/>
-          <p:nvPr/>
-        </p:nvSpPr>
-        <p:spPr>
-          <a:xfrm>
-            <a:off x="0" y="6510528"/>
-            <a:ext cx="12191695" cy="347472"/>
-          </a:xfrm>
-          <a:prstGeom prst="rect">
-            <a:avLst/>
-          </a:prstGeom>
-          <a:solidFill>
-            <a:srgbClr val="F3F1EA"/>
-          </a:solidFill>
-          <a:ln/>
-        </p:spPr>
-      </p:sp>
-      <p:sp>
-        <p:nvSpPr>
-          <p:cNvPr id="5" name="Text 2"/>
-          <p:cNvSpPr/>
-          <p:nvPr/>
-        </p:nvSpPr>
-        <p:spPr>
-          <a:xfrm>
-            <a:off x="502920" y="6510528"/>
-            <a:ext cx="11247120" cy="347472"/>
+          <p:cNvPr id="3" name="Text 0"/>
+          <p:cNvSpPr/>
+          <p:nvPr/>
+        </p:nvSpPr>
+        <p:spPr>
+          <a:xfrm>
+            <a:off x="9875520" y="6510528"/>
+            <a:ext cx="1920240" cy="347472"/>
           </a:xfrm>
           <a:prstGeom prst="rect">
             <a:avLst/>
@@ -1559,7 +1898,7 @@
           <a:bodyPr wrap="square" lIns="0" tIns="0" rIns="0" bIns="0" rtlCol="0" anchor="ctr"/>
           <a:lstStyle/>
           <a:p>
-            <a:pPr indent="0" marL="0">
+            <a:pPr algn="r" indent="0" marL="0">
               <a:buNone/>
             </a:pPr>
             <a:r>
@@ -1571,7 +1910,7 @@
                 <a:ea typeface="Yu Gothic UI" pitchFamily="34" charset="-122"/>
                 <a:cs typeface="Yu Gothic UI" pitchFamily="34" charset="-120"/>
               </a:rPr>
-              <a:t>RISC-V 入門  ·  オープン ISA</a:t>
+              <a:t>1 / 8</a:t>
             </a:r>
             <a:endParaRPr lang="ja-JP" sz="1400" dirty="0"/>
           </a:p>
@@ -1579,7 +1918,7 @@
       </p:sp>
       <p:pic>
         <p:nvPicPr>
-          <p:cNvPr id="6" name="Image 0" descr="create-slides logo">    </p:cNvPr>
+          <p:cNvPr id="4" name="Image 0" descr="create-slides logo">    </p:cNvPr>
           <p:cNvPicPr>
             <a:picLocks noChangeAspect="1"/>
           </p:cNvPicPr>
@@ -1603,7 +1942,7 @@
       </p:pic>
       <p:sp>
         <p:nvSpPr>
-          <p:cNvPr id="7" name="Text 3"/>
+          <p:cNvPr id="5" name="Text 1"/>
           <p:cNvSpPr/>
           <p:nvPr/>
         </p:nvSpPr>
@@ -1642,7 +1981,7 @@
       </p:sp>
       <p:sp>
         <p:nvSpPr>
-          <p:cNvPr id="8" name="Text 4"/>
+          <p:cNvPr id="6" name="Text 2"/>
           <p:cNvSpPr/>
           <p:nvPr/>
         </p:nvSpPr>
@@ -1681,7 +2020,7 @@
       </p:sp>
       <p:sp>
         <p:nvSpPr>
-          <p:cNvPr id="9" name="Shape 5"/>
+          <p:cNvPr id="7" name="Shape 3"/>
           <p:cNvSpPr/>
           <p:nvPr/>
         </p:nvSpPr>
@@ -1703,7 +2042,7 @@
       </p:sp>
       <p:sp>
         <p:nvSpPr>
-          <p:cNvPr id="10" name="Text 6"/>
+          <p:cNvPr id="8" name="Text 4"/>
           <p:cNvSpPr/>
           <p:nvPr/>
         </p:nvSpPr>
@@ -1751,13 +2090,6 @@
 <file path=ppt/slides/slide2.xml><?xml version="1.0" encoding="utf-8"?>
 <p:sld xmlns:a="http://schemas.openxmlformats.org/drawingml/2006/main" xmlns:r="http://schemas.openxmlformats.org/officeDocument/2006/relationships" xmlns:p="http://schemas.openxmlformats.org/presentationml/2006/main">
   <p:cSld name="Slide 2">
-    <p:bg>
-      <p:bgPr>
-        <a:solidFill>
-          <a:srgbClr val="FFFEFA"/>
-        </a:solidFill>
-      </p:bgPr>
-    </p:bg>
     <p:spTree>
       <p:nvGrpSpPr>
         <p:cNvPr id="1" name=""/>
@@ -1774,74 +2106,14 @@
       </p:grpSpPr>
       <p:sp>
         <p:nvSpPr>
-          <p:cNvPr id="3" name="Shape 0"/>
-          <p:cNvSpPr/>
-          <p:nvPr/>
-        </p:nvSpPr>
-        <p:spPr>
-          <a:xfrm>
-            <a:off x="0" y="0"/>
-            <a:ext cx="12191695" cy="566928"/>
-          </a:xfrm>
-          <a:prstGeom prst="rect">
-            <a:avLst/>
-          </a:prstGeom>
-          <a:solidFill>
-            <a:srgbClr val="E8F3FF"/>
-          </a:solidFill>
-          <a:ln/>
-        </p:spPr>
-      </p:sp>
-      <p:sp>
-        <p:nvSpPr>
-          <p:cNvPr id="4" name="Shape 1"/>
-          <p:cNvSpPr/>
-          <p:nvPr/>
-        </p:nvSpPr>
-        <p:spPr>
-          <a:xfrm>
-            <a:off x="0" y="566928"/>
-            <a:ext cx="12191695" cy="50292"/>
-          </a:xfrm>
-          <a:prstGeom prst="rect">
-            <a:avLst/>
-          </a:prstGeom>
-          <a:solidFill>
-            <a:srgbClr val="0B6BCB"/>
-          </a:solidFill>
-          <a:ln/>
-        </p:spPr>
-      </p:sp>
-      <p:sp>
-        <p:nvSpPr>
-          <p:cNvPr id="5" name="Shape 2"/>
-          <p:cNvSpPr/>
-          <p:nvPr/>
-        </p:nvSpPr>
-        <p:spPr>
-          <a:xfrm>
-            <a:off x="0" y="6510528"/>
-            <a:ext cx="12191695" cy="347472"/>
-          </a:xfrm>
-          <a:prstGeom prst="rect">
-            <a:avLst/>
-          </a:prstGeom>
-          <a:solidFill>
-            <a:srgbClr val="F3F1EA"/>
-          </a:solidFill>
-          <a:ln/>
-        </p:spPr>
-      </p:sp>
-      <p:sp>
-        <p:nvSpPr>
-          <p:cNvPr id="6" name="Text 3"/>
-          <p:cNvSpPr/>
-          <p:nvPr/>
-        </p:nvSpPr>
-        <p:spPr>
-          <a:xfrm>
-            <a:off x="411480" y="6510528"/>
-            <a:ext cx="11338560" cy="347472"/>
+          <p:cNvPr id="3" name="Text 0"/>
+          <p:cNvSpPr/>
+          <p:nvPr/>
+        </p:nvSpPr>
+        <p:spPr>
+          <a:xfrm>
+            <a:off x="9875520" y="6510528"/>
+            <a:ext cx="1920240" cy="347472"/>
           </a:xfrm>
           <a:prstGeom prst="rect">
             <a:avLst/>
@@ -1853,7 +2125,7 @@
           <a:bodyPr wrap="square" lIns="0" tIns="0" rIns="0" bIns="0" rtlCol="0" anchor="ctr"/>
           <a:lstStyle/>
           <a:p>
-            <a:pPr indent="0" marL="0">
+            <a:pPr algn="r" indent="0" marL="0">
               <a:buNone/>
             </a:pPr>
             <a:r>
@@ -1865,7 +2137,7 @@
                 <a:ea typeface="Yu Gothic UI" pitchFamily="34" charset="-122"/>
                 <a:cs typeface="Yu Gothic UI" pitchFamily="34" charset="-120"/>
               </a:rPr>
-              <a:t>RISC-V 入門  ·  オープン ISA</a:t>
+              <a:t>2 / 8</a:t>
             </a:r>
             <a:endParaRPr lang="ja-JP" sz="1400" dirty="0"/>
           </a:p>
@@ -1873,7 +2145,7 @@
       </p:sp>
       <p:sp>
         <p:nvSpPr>
-          <p:cNvPr id="7" name="Text 4"/>
+          <p:cNvPr id="4" name="Text 1"/>
           <p:cNvSpPr/>
           <p:nvPr/>
         </p:nvSpPr>
@@ -1912,7 +2184,7 @@
       </p:sp>
       <p:sp>
         <p:nvSpPr>
-          <p:cNvPr id="8" name="Text 5"/>
+          <p:cNvPr id="5" name="Text 2"/>
           <p:cNvSpPr/>
           <p:nvPr/>
         </p:nvSpPr>
@@ -1951,7 +2223,7 @@
       </p:sp>
       <p:sp>
         <p:nvSpPr>
-          <p:cNvPr id="9" name="Shape 6"/>
+          <p:cNvPr id="6" name="Shape 3"/>
           <p:cNvSpPr/>
           <p:nvPr/>
         </p:nvSpPr>
@@ -1978,7 +2250,7 @@
       </p:sp>
       <p:sp>
         <p:nvSpPr>
-          <p:cNvPr id="10" name="Text 7"/>
+          <p:cNvPr id="7" name="Text 4"/>
           <p:cNvSpPr/>
           <p:nvPr/>
         </p:nvSpPr>
@@ -2017,7 +2289,7 @@
       </p:sp>
       <p:sp>
         <p:nvSpPr>
-          <p:cNvPr id="11" name="Text 8"/>
+          <p:cNvPr id="8" name="Text 5"/>
           <p:cNvSpPr/>
           <p:nvPr/>
         </p:nvSpPr>
@@ -2073,7 +2345,7 @@
       </p:sp>
       <p:sp>
         <p:nvSpPr>
-          <p:cNvPr id="12" name="Shape 9"/>
+          <p:cNvPr id="9" name="Shape 6"/>
           <p:cNvSpPr/>
           <p:nvPr/>
         </p:nvSpPr>
@@ -2100,7 +2372,7 @@
       </p:sp>
       <p:sp>
         <p:nvSpPr>
-          <p:cNvPr id="13" name="Text 10"/>
+          <p:cNvPr id="10" name="Text 7"/>
           <p:cNvSpPr/>
           <p:nvPr/>
         </p:nvSpPr>
@@ -2139,7 +2411,7 @@
       </p:sp>
       <p:sp>
         <p:nvSpPr>
-          <p:cNvPr id="14" name="Text 11"/>
+          <p:cNvPr id="11" name="Text 8"/>
           <p:cNvSpPr/>
           <p:nvPr/>
         </p:nvSpPr>
@@ -2178,7 +2450,7 @@
       </p:sp>
       <p:sp>
         <p:nvSpPr>
-          <p:cNvPr id="15" name="Shape 12"/>
+          <p:cNvPr id="12" name="Shape 9"/>
           <p:cNvSpPr/>
           <p:nvPr/>
         </p:nvSpPr>
@@ -2205,7 +2477,7 @@
       </p:sp>
       <p:sp>
         <p:nvSpPr>
-          <p:cNvPr id="16" name="Text 13"/>
+          <p:cNvPr id="13" name="Text 10"/>
           <p:cNvSpPr/>
           <p:nvPr/>
         </p:nvSpPr>
@@ -2244,7 +2516,7 @@
       </p:sp>
       <p:sp>
         <p:nvSpPr>
-          <p:cNvPr id="17" name="Text 14"/>
+          <p:cNvPr id="14" name="Text 11"/>
           <p:cNvSpPr/>
           <p:nvPr/>
         </p:nvSpPr>
@@ -2292,13 +2564,6 @@
 <file path=ppt/slides/slide3.xml><?xml version="1.0" encoding="utf-8"?>
 <p:sld xmlns:a="http://schemas.openxmlformats.org/drawingml/2006/main" xmlns:r="http://schemas.openxmlformats.org/officeDocument/2006/relationships" xmlns:p="http://schemas.openxmlformats.org/presentationml/2006/main">
   <p:cSld name="Slide 3">
-    <p:bg>
-      <p:bgPr>
-        <a:solidFill>
-          <a:srgbClr val="FFFEFA"/>
-        </a:solidFill>
-      </p:bgPr>
-    </p:bg>
     <p:spTree>
       <p:nvGrpSpPr>
         <p:cNvPr id="1" name=""/>
@@ -2315,74 +2580,14 @@
       </p:grpSpPr>
       <p:sp>
         <p:nvSpPr>
-          <p:cNvPr id="3" name="Shape 0"/>
-          <p:cNvSpPr/>
-          <p:nvPr/>
-        </p:nvSpPr>
-        <p:spPr>
-          <a:xfrm>
-            <a:off x="0" y="0"/>
-            <a:ext cx="12191695" cy="566928"/>
-          </a:xfrm>
-          <a:prstGeom prst="rect">
-            <a:avLst/>
-          </a:prstGeom>
-          <a:solidFill>
-            <a:srgbClr val="E8F3FF"/>
-          </a:solidFill>
-          <a:ln/>
-        </p:spPr>
-      </p:sp>
-      <p:sp>
-        <p:nvSpPr>
-          <p:cNvPr id="4" name="Shape 1"/>
-          <p:cNvSpPr/>
-          <p:nvPr/>
-        </p:nvSpPr>
-        <p:spPr>
-          <a:xfrm>
-            <a:off x="0" y="566928"/>
-            <a:ext cx="12191695" cy="50292"/>
-          </a:xfrm>
-          <a:prstGeom prst="rect">
-            <a:avLst/>
-          </a:prstGeom>
-          <a:solidFill>
-            <a:srgbClr val="0B6BCB"/>
-          </a:solidFill>
-          <a:ln/>
-        </p:spPr>
-      </p:sp>
-      <p:sp>
-        <p:nvSpPr>
-          <p:cNvPr id="5" name="Shape 2"/>
-          <p:cNvSpPr/>
-          <p:nvPr/>
-        </p:nvSpPr>
-        <p:spPr>
-          <a:xfrm>
-            <a:off x="0" y="6510528"/>
-            <a:ext cx="12191695" cy="347472"/>
-          </a:xfrm>
-          <a:prstGeom prst="rect">
-            <a:avLst/>
-          </a:prstGeom>
-          <a:solidFill>
-            <a:srgbClr val="F3F1EA"/>
-          </a:solidFill>
-          <a:ln/>
-        </p:spPr>
-      </p:sp>
-      <p:sp>
-        <p:nvSpPr>
-          <p:cNvPr id="6" name="Text 3"/>
-          <p:cNvSpPr/>
-          <p:nvPr/>
-        </p:nvSpPr>
-        <p:spPr>
-          <a:xfrm>
-            <a:off x="411480" y="6510528"/>
-            <a:ext cx="11338560" cy="347472"/>
+          <p:cNvPr id="3" name="Text 0"/>
+          <p:cNvSpPr/>
+          <p:nvPr/>
+        </p:nvSpPr>
+        <p:spPr>
+          <a:xfrm>
+            <a:off x="9875520" y="6510528"/>
+            <a:ext cx="1920240" cy="347472"/>
           </a:xfrm>
           <a:prstGeom prst="rect">
             <a:avLst/>
@@ -2394,7 +2599,7 @@
           <a:bodyPr wrap="square" lIns="0" tIns="0" rIns="0" bIns="0" rtlCol="0" anchor="ctr"/>
           <a:lstStyle/>
           <a:p>
-            <a:pPr indent="0" marL="0">
+            <a:pPr algn="r" indent="0" marL="0">
               <a:buNone/>
             </a:pPr>
             <a:r>
@@ -2406,7 +2611,7 @@
                 <a:ea typeface="Yu Gothic UI" pitchFamily="34" charset="-122"/>
                 <a:cs typeface="Yu Gothic UI" pitchFamily="34" charset="-120"/>
               </a:rPr>
-              <a:t>RISC-V 入門  ·  オープン ISA</a:t>
+              <a:t>3 / 8</a:t>
             </a:r>
             <a:endParaRPr lang="ja-JP" sz="1400" dirty="0"/>
           </a:p>
@@ -2414,7 +2619,7 @@
       </p:sp>
       <p:sp>
         <p:nvSpPr>
-          <p:cNvPr id="7" name="Text 4"/>
+          <p:cNvPr id="4" name="Text 1"/>
           <p:cNvSpPr/>
           <p:nvPr/>
         </p:nvSpPr>
@@ -2453,7 +2658,7 @@
       </p:sp>
       <p:sp>
         <p:nvSpPr>
-          <p:cNvPr id="8" name="Text 5"/>
+          <p:cNvPr id="5" name="Text 2"/>
           <p:cNvSpPr/>
           <p:nvPr/>
         </p:nvSpPr>
@@ -2517,7 +2722,7 @@
       </p:sp>
       <p:sp>
         <p:nvSpPr>
-          <p:cNvPr id="9" name="Text 6"/>
+          <p:cNvPr id="6" name="Text 3"/>
           <p:cNvSpPr/>
           <p:nvPr/>
         </p:nvSpPr>
@@ -2581,7 +2786,7 @@
       </p:sp>
       <p:sp>
         <p:nvSpPr>
-          <p:cNvPr id="10" name="Text 7"/>
+          <p:cNvPr id="7" name="Text 4"/>
           <p:cNvSpPr/>
           <p:nvPr/>
         </p:nvSpPr>
@@ -2645,7 +2850,7 @@
       </p:sp>
       <p:sp>
         <p:nvSpPr>
-          <p:cNvPr id="11" name="Text 8"/>
+          <p:cNvPr id="8" name="Text 5"/>
           <p:cNvSpPr/>
           <p:nvPr/>
         </p:nvSpPr>
@@ -2718,13 +2923,6 @@
 <file path=ppt/slides/slide4.xml><?xml version="1.0" encoding="utf-8"?>
 <p:sld xmlns:a="http://schemas.openxmlformats.org/drawingml/2006/main" xmlns:r="http://schemas.openxmlformats.org/officeDocument/2006/relationships" xmlns:p="http://schemas.openxmlformats.org/presentationml/2006/main">
   <p:cSld name="Slide 4">
-    <p:bg>
-      <p:bgPr>
-        <a:solidFill>
-          <a:srgbClr val="FFFEFA"/>
-        </a:solidFill>
-      </p:bgPr>
-    </p:bg>
     <p:spTree>
       <p:nvGrpSpPr>
         <p:cNvPr id="1" name=""/>
@@ -2741,74 +2939,14 @@
       </p:grpSpPr>
       <p:sp>
         <p:nvSpPr>
-          <p:cNvPr id="3" name="Shape 0"/>
-          <p:cNvSpPr/>
-          <p:nvPr/>
-        </p:nvSpPr>
-        <p:spPr>
-          <a:xfrm>
-            <a:off x="0" y="0"/>
-            <a:ext cx="12191695" cy="566928"/>
-          </a:xfrm>
-          <a:prstGeom prst="rect">
-            <a:avLst/>
-          </a:prstGeom>
-          <a:solidFill>
-            <a:srgbClr val="E8F3FF"/>
-          </a:solidFill>
-          <a:ln/>
-        </p:spPr>
-      </p:sp>
-      <p:sp>
-        <p:nvSpPr>
-          <p:cNvPr id="4" name="Shape 1"/>
-          <p:cNvSpPr/>
-          <p:nvPr/>
-        </p:nvSpPr>
-        <p:spPr>
-          <a:xfrm>
-            <a:off x="0" y="566928"/>
-            <a:ext cx="12191695" cy="50292"/>
-          </a:xfrm>
-          <a:prstGeom prst="rect">
-            <a:avLst/>
-          </a:prstGeom>
-          <a:solidFill>
-            <a:srgbClr val="0B6BCB"/>
-          </a:solidFill>
-          <a:ln/>
-        </p:spPr>
-      </p:sp>
-      <p:sp>
-        <p:nvSpPr>
-          <p:cNvPr id="5" name="Shape 2"/>
-          <p:cNvSpPr/>
-          <p:nvPr/>
-        </p:nvSpPr>
-        <p:spPr>
-          <a:xfrm>
-            <a:off x="0" y="6510528"/>
-            <a:ext cx="12191695" cy="347472"/>
-          </a:xfrm>
-          <a:prstGeom prst="rect">
-            <a:avLst/>
-          </a:prstGeom>
-          <a:solidFill>
-            <a:srgbClr val="F3F1EA"/>
-          </a:solidFill>
-          <a:ln/>
-        </p:spPr>
-      </p:sp>
-      <p:sp>
-        <p:nvSpPr>
-          <p:cNvPr id="6" name="Text 3"/>
-          <p:cNvSpPr/>
-          <p:nvPr/>
-        </p:nvSpPr>
-        <p:spPr>
-          <a:xfrm>
-            <a:off x="411480" y="6510528"/>
-            <a:ext cx="11338560" cy="347472"/>
+          <p:cNvPr id="3" name="Text 0"/>
+          <p:cNvSpPr/>
+          <p:nvPr/>
+        </p:nvSpPr>
+        <p:spPr>
+          <a:xfrm>
+            <a:off x="9875520" y="6510528"/>
+            <a:ext cx="1920240" cy="347472"/>
           </a:xfrm>
           <a:prstGeom prst="rect">
             <a:avLst/>
@@ -2820,7 +2958,7 @@
           <a:bodyPr wrap="square" lIns="0" tIns="0" rIns="0" bIns="0" rtlCol="0" anchor="ctr"/>
           <a:lstStyle/>
           <a:p>
-            <a:pPr indent="0" marL="0">
+            <a:pPr algn="r" indent="0" marL="0">
               <a:buNone/>
             </a:pPr>
             <a:r>
@@ -2832,7 +2970,7 @@
                 <a:ea typeface="Yu Gothic UI" pitchFamily="34" charset="-122"/>
                 <a:cs typeface="Yu Gothic UI" pitchFamily="34" charset="-120"/>
               </a:rPr>
-              <a:t>RISC-V 入門  ·  オープン ISA</a:t>
+              <a:t>4 / 8</a:t>
             </a:r>
             <a:endParaRPr lang="ja-JP" sz="1400" dirty="0"/>
           </a:p>
@@ -2840,7 +2978,7 @@
       </p:sp>
       <p:sp>
         <p:nvSpPr>
-          <p:cNvPr id="7" name="Text 4"/>
+          <p:cNvPr id="4" name="Text 1"/>
           <p:cNvSpPr/>
           <p:nvPr/>
         </p:nvSpPr>
@@ -2879,7 +3017,7 @@
       </p:sp>
       <p:sp>
         <p:nvSpPr>
-          <p:cNvPr id="8" name="Text 5"/>
+          <p:cNvPr id="5" name="Text 2"/>
           <p:cNvSpPr/>
           <p:nvPr/>
         </p:nvSpPr>
@@ -2918,7 +3056,7 @@
       </p:sp>
       <p:sp>
         <p:nvSpPr>
-          <p:cNvPr id="9" name="Text 6"/>
+          <p:cNvPr id="6" name="Text 3"/>
           <p:cNvSpPr/>
           <p:nvPr/>
         </p:nvSpPr>
@@ -2959,7 +3097,7 @@
       </p:sp>
       <p:sp>
         <p:nvSpPr>
-          <p:cNvPr id="10" name="Text 7"/>
+          <p:cNvPr id="7" name="Text 4"/>
           <p:cNvSpPr/>
           <p:nvPr/>
         </p:nvSpPr>
@@ -3000,7 +3138,7 @@
       </p:sp>
       <p:sp>
         <p:nvSpPr>
-          <p:cNvPr id="11" name="Text 8"/>
+          <p:cNvPr id="8" name="Text 5"/>
           <p:cNvSpPr/>
           <p:nvPr/>
         </p:nvSpPr>
@@ -3041,7 +3179,7 @@
       </p:sp>
       <p:sp>
         <p:nvSpPr>
-          <p:cNvPr id="12" name="Text 9"/>
+          <p:cNvPr id="9" name="Text 6"/>
           <p:cNvSpPr/>
           <p:nvPr/>
         </p:nvSpPr>
@@ -3084,7 +3222,7 @@
       </p:sp>
       <p:sp>
         <p:nvSpPr>
-          <p:cNvPr id="13" name="Text 10"/>
+          <p:cNvPr id="10" name="Text 7"/>
           <p:cNvSpPr/>
           <p:nvPr/>
         </p:nvSpPr>
@@ -3146,7 +3284,7 @@
       </p:sp>
       <p:sp>
         <p:nvSpPr>
-          <p:cNvPr id="14" name="Text 11"/>
+          <p:cNvPr id="11" name="Text 8"/>
           <p:cNvSpPr/>
           <p:nvPr/>
         </p:nvSpPr>
@@ -3185,7 +3323,7 @@
       </p:sp>
       <p:sp>
         <p:nvSpPr>
-          <p:cNvPr id="15" name="Text 12"/>
+          <p:cNvPr id="12" name="Text 9"/>
           <p:cNvSpPr/>
           <p:nvPr/>
         </p:nvSpPr>
@@ -3230,7 +3368,7 @@
       </p:sp>
       <p:sp>
         <p:nvSpPr>
-          <p:cNvPr id="16" name="Text 13"/>
+          <p:cNvPr id="13" name="Text 10"/>
           <p:cNvSpPr/>
           <p:nvPr/>
         </p:nvSpPr>
@@ -3296,7 +3434,7 @@
       </p:sp>
       <p:sp>
         <p:nvSpPr>
-          <p:cNvPr id="17" name="Text 14"/>
+          <p:cNvPr id="14" name="Text 11"/>
           <p:cNvSpPr/>
           <p:nvPr/>
         </p:nvSpPr>
@@ -3344,13 +3482,6 @@
 <file path=ppt/slides/slide5.xml><?xml version="1.0" encoding="utf-8"?>
 <p:sld xmlns:a="http://schemas.openxmlformats.org/drawingml/2006/main" xmlns:r="http://schemas.openxmlformats.org/officeDocument/2006/relationships" xmlns:p="http://schemas.openxmlformats.org/presentationml/2006/main">
   <p:cSld name="Slide 5">
-    <p:bg>
-      <p:bgPr>
-        <a:solidFill>
-          <a:srgbClr val="FFFEFA"/>
-        </a:solidFill>
-      </p:bgPr>
-    </p:bg>
     <p:spTree>
       <p:nvGrpSpPr>
         <p:cNvPr id="1" name=""/>
@@ -3367,74 +3498,14 @@
       </p:grpSpPr>
       <p:sp>
         <p:nvSpPr>
-          <p:cNvPr id="3" name="Shape 0"/>
-          <p:cNvSpPr/>
-          <p:nvPr/>
-        </p:nvSpPr>
-        <p:spPr>
-          <a:xfrm>
-            <a:off x="0" y="0"/>
-            <a:ext cx="12191695" cy="566928"/>
-          </a:xfrm>
-          <a:prstGeom prst="rect">
-            <a:avLst/>
-          </a:prstGeom>
-          <a:solidFill>
-            <a:srgbClr val="E8F3FF"/>
-          </a:solidFill>
-          <a:ln/>
-        </p:spPr>
-      </p:sp>
-      <p:sp>
-        <p:nvSpPr>
-          <p:cNvPr id="4" name="Shape 1"/>
-          <p:cNvSpPr/>
-          <p:nvPr/>
-        </p:nvSpPr>
-        <p:spPr>
-          <a:xfrm>
-            <a:off x="0" y="566928"/>
-            <a:ext cx="12191695" cy="50292"/>
-          </a:xfrm>
-          <a:prstGeom prst="rect">
-            <a:avLst/>
-          </a:prstGeom>
-          <a:solidFill>
-            <a:srgbClr val="0B6BCB"/>
-          </a:solidFill>
-          <a:ln/>
-        </p:spPr>
-      </p:sp>
-      <p:sp>
-        <p:nvSpPr>
-          <p:cNvPr id="5" name="Shape 2"/>
-          <p:cNvSpPr/>
-          <p:nvPr/>
-        </p:nvSpPr>
-        <p:spPr>
-          <a:xfrm>
-            <a:off x="0" y="6510528"/>
-            <a:ext cx="12191695" cy="347472"/>
-          </a:xfrm>
-          <a:prstGeom prst="rect">
-            <a:avLst/>
-          </a:prstGeom>
-          <a:solidFill>
-            <a:srgbClr val="F3F1EA"/>
-          </a:solidFill>
-          <a:ln/>
-        </p:spPr>
-      </p:sp>
-      <p:sp>
-        <p:nvSpPr>
-          <p:cNvPr id="6" name="Text 3"/>
-          <p:cNvSpPr/>
-          <p:nvPr/>
-        </p:nvSpPr>
-        <p:spPr>
-          <a:xfrm>
-            <a:off x="411480" y="6510528"/>
-            <a:ext cx="11338560" cy="347472"/>
+          <p:cNvPr id="3" name="Text 0"/>
+          <p:cNvSpPr/>
+          <p:nvPr/>
+        </p:nvSpPr>
+        <p:spPr>
+          <a:xfrm>
+            <a:off x="9875520" y="6510528"/>
+            <a:ext cx="1920240" cy="347472"/>
           </a:xfrm>
           <a:prstGeom prst="rect">
             <a:avLst/>
@@ -3446,7 +3517,7 @@
           <a:bodyPr wrap="square" lIns="0" tIns="0" rIns="0" bIns="0" rtlCol="0" anchor="ctr"/>
           <a:lstStyle/>
           <a:p>
-            <a:pPr indent="0" marL="0">
+            <a:pPr algn="r" indent="0" marL="0">
               <a:buNone/>
             </a:pPr>
             <a:r>
@@ -3458,7 +3529,7 @@
                 <a:ea typeface="Yu Gothic UI" pitchFamily="34" charset="-122"/>
                 <a:cs typeface="Yu Gothic UI" pitchFamily="34" charset="-120"/>
               </a:rPr>
-              <a:t>RISC-V 入門  ·  オープン ISA</a:t>
+              <a:t>5 / 8</a:t>
             </a:r>
             <a:endParaRPr lang="ja-JP" sz="1400" dirty="0"/>
           </a:p>
@@ -3466,7 +3537,7 @@
       </p:sp>
       <p:sp>
         <p:nvSpPr>
-          <p:cNvPr id="7" name="Text 4"/>
+          <p:cNvPr id="4" name="Text 1"/>
           <p:cNvSpPr/>
           <p:nvPr/>
         </p:nvSpPr>
@@ -3505,7 +3576,7 @@
       </p:sp>
       <p:sp>
         <p:nvSpPr>
-          <p:cNvPr id="8" name="Text 5"/>
+          <p:cNvPr id="5" name="Text 2"/>
           <p:cNvSpPr/>
           <p:nvPr/>
         </p:nvSpPr>
@@ -3544,7 +3615,7 @@
       </p:sp>
       <p:sp>
         <p:nvSpPr>
-          <p:cNvPr id="9" name="Text 6"/>
+          <p:cNvPr id="6" name="Text 3"/>
           <p:cNvSpPr/>
           <p:nvPr/>
         </p:nvSpPr>
@@ -3585,7 +3656,7 @@
       </p:sp>
       <p:sp>
         <p:nvSpPr>
-          <p:cNvPr id="10" name="Text 7"/>
+          <p:cNvPr id="7" name="Text 4"/>
           <p:cNvSpPr/>
           <p:nvPr/>
         </p:nvSpPr>
@@ -3626,7 +3697,7 @@
       </p:sp>
       <p:sp>
         <p:nvSpPr>
-          <p:cNvPr id="11" name="Text 8"/>
+          <p:cNvPr id="8" name="Text 5"/>
           <p:cNvSpPr/>
           <p:nvPr/>
         </p:nvSpPr>
@@ -3667,7 +3738,7 @@
       </p:sp>
       <p:sp>
         <p:nvSpPr>
-          <p:cNvPr id="12" name="Text 9"/>
+          <p:cNvPr id="9" name="Text 6"/>
           <p:cNvSpPr/>
           <p:nvPr/>
         </p:nvSpPr>
@@ -3708,7 +3779,7 @@
       </p:sp>
       <p:sp>
         <p:nvSpPr>
-          <p:cNvPr id="13" name="Text 10"/>
+          <p:cNvPr id="10" name="Text 7"/>
           <p:cNvSpPr/>
           <p:nvPr/>
         </p:nvSpPr>
@@ -3749,7 +3820,7 @@
       </p:sp>
       <p:sp>
         <p:nvSpPr>
-          <p:cNvPr id="14" name="Text 11"/>
+          <p:cNvPr id="11" name="Text 8"/>
           <p:cNvSpPr/>
           <p:nvPr/>
         </p:nvSpPr>
@@ -3790,7 +3861,7 @@
       </p:sp>
       <p:sp>
         <p:nvSpPr>
-          <p:cNvPr id="15" name="Shape 12"/>
+          <p:cNvPr id="12" name="Shape 9"/>
           <p:cNvSpPr/>
           <p:nvPr/>
         </p:nvSpPr>
@@ -3810,7 +3881,7 @@
       </p:sp>
       <p:sp>
         <p:nvSpPr>
-          <p:cNvPr id="16" name="Text 13"/>
+          <p:cNvPr id="13" name="Text 10"/>
           <p:cNvSpPr/>
           <p:nvPr/>
         </p:nvSpPr>
@@ -3849,7 +3920,7 @@
       </p:sp>
       <p:sp>
         <p:nvSpPr>
-          <p:cNvPr id="17" name="Text 14"/>
+          <p:cNvPr id="14" name="Text 11"/>
           <p:cNvSpPr/>
           <p:nvPr/>
         </p:nvSpPr>
@@ -3913,7 +3984,7 @@
       </p:sp>
       <p:sp>
         <p:nvSpPr>
-          <p:cNvPr id="18" name="Text 15"/>
+          <p:cNvPr id="15" name="Text 12"/>
           <p:cNvSpPr/>
           <p:nvPr/>
         </p:nvSpPr>
@@ -3977,7 +4048,7 @@
       </p:sp>
       <p:sp>
         <p:nvSpPr>
-          <p:cNvPr id="19" name="Text 16"/>
+          <p:cNvPr id="16" name="Text 13"/>
           <p:cNvSpPr/>
           <p:nvPr/>
         </p:nvSpPr>
@@ -4041,7 +4112,7 @@
       </p:sp>
       <p:sp>
         <p:nvSpPr>
-          <p:cNvPr id="20" name="Text 17"/>
+          <p:cNvPr id="17" name="Text 14"/>
           <p:cNvSpPr/>
           <p:nvPr/>
         </p:nvSpPr>
@@ -4105,7 +4176,7 @@
       </p:sp>
       <p:sp>
         <p:nvSpPr>
-          <p:cNvPr id="21" name="Text 18"/>
+          <p:cNvPr id="18" name="Text 15"/>
           <p:cNvSpPr/>
           <p:nvPr/>
         </p:nvSpPr>
@@ -4169,7 +4240,7 @@
       </p:sp>
       <p:sp>
         <p:nvSpPr>
-          <p:cNvPr id="22" name="Text 19"/>
+          <p:cNvPr id="19" name="Text 16"/>
           <p:cNvSpPr/>
           <p:nvPr/>
         </p:nvSpPr>
@@ -4242,13 +4313,6 @@
 <file path=ppt/slides/slide6.xml><?xml version="1.0" encoding="utf-8"?>
 <p:sld xmlns:a="http://schemas.openxmlformats.org/drawingml/2006/main" xmlns:r="http://schemas.openxmlformats.org/officeDocument/2006/relationships" xmlns:p="http://schemas.openxmlformats.org/presentationml/2006/main">
   <p:cSld name="Slide 6">
-    <p:bg>
-      <p:bgPr>
-        <a:solidFill>
-          <a:srgbClr val="FFFEFA"/>
-        </a:solidFill>
-      </p:bgPr>
-    </p:bg>
     <p:spTree>
       <p:nvGrpSpPr>
         <p:cNvPr id="1" name=""/>
@@ -4265,74 +4329,14 @@
       </p:grpSpPr>
       <p:sp>
         <p:nvSpPr>
-          <p:cNvPr id="3" name="Shape 0"/>
-          <p:cNvSpPr/>
-          <p:nvPr/>
-        </p:nvSpPr>
-        <p:spPr>
-          <a:xfrm>
-            <a:off x="0" y="0"/>
-            <a:ext cx="12191695" cy="566928"/>
-          </a:xfrm>
-          <a:prstGeom prst="rect">
-            <a:avLst/>
-          </a:prstGeom>
-          <a:solidFill>
-            <a:srgbClr val="E8F3FF"/>
-          </a:solidFill>
-          <a:ln/>
-        </p:spPr>
-      </p:sp>
-      <p:sp>
-        <p:nvSpPr>
-          <p:cNvPr id="4" name="Shape 1"/>
-          <p:cNvSpPr/>
-          <p:nvPr/>
-        </p:nvSpPr>
-        <p:spPr>
-          <a:xfrm>
-            <a:off x="0" y="566928"/>
-            <a:ext cx="12191695" cy="50292"/>
-          </a:xfrm>
-          <a:prstGeom prst="rect">
-            <a:avLst/>
-          </a:prstGeom>
-          <a:solidFill>
-            <a:srgbClr val="0B6BCB"/>
-          </a:solidFill>
-          <a:ln/>
-        </p:spPr>
-      </p:sp>
-      <p:sp>
-        <p:nvSpPr>
-          <p:cNvPr id="5" name="Shape 2"/>
-          <p:cNvSpPr/>
-          <p:nvPr/>
-        </p:nvSpPr>
-        <p:spPr>
-          <a:xfrm>
-            <a:off x="0" y="6510528"/>
-            <a:ext cx="12191695" cy="347472"/>
-          </a:xfrm>
-          <a:prstGeom prst="rect">
-            <a:avLst/>
-          </a:prstGeom>
-          <a:solidFill>
-            <a:srgbClr val="F3F1EA"/>
-          </a:solidFill>
-          <a:ln/>
-        </p:spPr>
-      </p:sp>
-      <p:sp>
-        <p:nvSpPr>
-          <p:cNvPr id="6" name="Text 3"/>
-          <p:cNvSpPr/>
-          <p:nvPr/>
-        </p:nvSpPr>
-        <p:spPr>
-          <a:xfrm>
-            <a:off x="411480" y="6510528"/>
-            <a:ext cx="11338560" cy="347472"/>
+          <p:cNvPr id="3" name="Text 0"/>
+          <p:cNvSpPr/>
+          <p:nvPr/>
+        </p:nvSpPr>
+        <p:spPr>
+          <a:xfrm>
+            <a:off x="9875520" y="6510528"/>
+            <a:ext cx="1920240" cy="347472"/>
           </a:xfrm>
           <a:prstGeom prst="rect">
             <a:avLst/>
@@ -4344,7 +4348,7 @@
           <a:bodyPr wrap="square" lIns="0" tIns="0" rIns="0" bIns="0" rtlCol="0" anchor="ctr"/>
           <a:lstStyle/>
           <a:p>
-            <a:pPr indent="0" marL="0">
+            <a:pPr algn="r" indent="0" marL="0">
               <a:buNone/>
             </a:pPr>
             <a:r>
@@ -4356,7 +4360,7 @@
                 <a:ea typeface="Yu Gothic UI" pitchFamily="34" charset="-122"/>
                 <a:cs typeface="Yu Gothic UI" pitchFamily="34" charset="-120"/>
               </a:rPr>
-              <a:t>RISC-V 入門  ·  オープン ISA</a:t>
+              <a:t>6 / 8</a:t>
             </a:r>
             <a:endParaRPr lang="ja-JP" sz="1400" dirty="0"/>
           </a:p>
@@ -4364,7 +4368,7 @@
       </p:sp>
       <p:sp>
         <p:nvSpPr>
-          <p:cNvPr id="7" name="Text 4"/>
+          <p:cNvPr id="4" name="Text 1"/>
           <p:cNvSpPr/>
           <p:nvPr/>
         </p:nvSpPr>
@@ -4403,7 +4407,7 @@
       </p:sp>
       <p:sp>
         <p:nvSpPr>
-          <p:cNvPr id="8" name="Text 5"/>
+          <p:cNvPr id="5" name="Text 2"/>
           <p:cNvSpPr/>
           <p:nvPr/>
         </p:nvSpPr>
@@ -4446,7 +4450,7 @@
       </p:sp>
       <p:sp>
         <p:nvSpPr>
-          <p:cNvPr id="9" name="Shape 6"/>
+          <p:cNvPr id="6" name="Shape 3"/>
           <p:cNvSpPr/>
           <p:nvPr/>
         </p:nvSpPr>
@@ -4466,7 +4470,7 @@
       </p:sp>
       <p:sp>
         <p:nvSpPr>
-          <p:cNvPr id="10" name="Text 7"/>
+          <p:cNvPr id="7" name="Text 4"/>
           <p:cNvSpPr/>
           <p:nvPr/>
         </p:nvSpPr>
@@ -4505,7 +4509,7 @@
       </p:sp>
       <p:sp>
         <p:nvSpPr>
-          <p:cNvPr id="11" name="Text 8"/>
+          <p:cNvPr id="8" name="Text 5"/>
           <p:cNvSpPr/>
           <p:nvPr/>
         </p:nvSpPr>
@@ -4550,7 +4554,7 @@
       </p:sp>
       <p:sp>
         <p:nvSpPr>
-          <p:cNvPr id="12" name="Text 9"/>
+          <p:cNvPr id="9" name="Text 6"/>
           <p:cNvSpPr/>
           <p:nvPr/>
         </p:nvSpPr>
@@ -4595,7 +4599,7 @@
       </p:sp>
       <p:sp>
         <p:nvSpPr>
-          <p:cNvPr id="13" name="Text 10"/>
+          <p:cNvPr id="10" name="Text 7"/>
           <p:cNvSpPr/>
           <p:nvPr/>
         </p:nvSpPr>
@@ -4640,7 +4644,7 @@
       </p:sp>
       <p:sp>
         <p:nvSpPr>
-          <p:cNvPr id="14" name="Text 11"/>
+          <p:cNvPr id="11" name="Text 8"/>
           <p:cNvSpPr/>
           <p:nvPr/>
         </p:nvSpPr>
@@ -4685,7 +4689,7 @@
       </p:sp>
       <p:sp>
         <p:nvSpPr>
-          <p:cNvPr id="15" name="Text 12"/>
+          <p:cNvPr id="12" name="Text 9"/>
           <p:cNvSpPr/>
           <p:nvPr/>
         </p:nvSpPr>
@@ -4730,7 +4734,7 @@
       </p:sp>
       <p:sp>
         <p:nvSpPr>
-          <p:cNvPr id="16" name="Text 13"/>
+          <p:cNvPr id="13" name="Text 10"/>
           <p:cNvSpPr/>
           <p:nvPr/>
         </p:nvSpPr>
@@ -4826,7 +4830,7 @@
       </p:sp>
       <p:sp>
         <p:nvSpPr>
-          <p:cNvPr id="17" name="Text 14"/>
+          <p:cNvPr id="14" name="Text 11"/>
           <p:cNvSpPr/>
           <p:nvPr/>
         </p:nvSpPr>
@@ -4922,7 +4926,7 @@
       </p:sp>
       <p:sp>
         <p:nvSpPr>
-          <p:cNvPr id="18" name="Text 15"/>
+          <p:cNvPr id="15" name="Text 12"/>
           <p:cNvSpPr/>
           <p:nvPr/>
         </p:nvSpPr>
@@ -5035,13 +5039,6 @@
 <file path=ppt/slides/slide7.xml><?xml version="1.0" encoding="utf-8"?>
 <p:sld xmlns:a="http://schemas.openxmlformats.org/drawingml/2006/main" xmlns:r="http://schemas.openxmlformats.org/officeDocument/2006/relationships" xmlns:p="http://schemas.openxmlformats.org/presentationml/2006/main">
   <p:cSld name="Slide 7">
-    <p:bg>
-      <p:bgPr>
-        <a:solidFill>
-          <a:srgbClr val="FFFEFA"/>
-        </a:solidFill>
-      </p:bgPr>
-    </p:bg>
     <p:spTree>
       <p:nvGrpSpPr>
         <p:cNvPr id="1" name=""/>
@@ -5058,74 +5055,14 @@
       </p:grpSpPr>
       <p:sp>
         <p:nvSpPr>
-          <p:cNvPr id="3" name="Shape 0"/>
-          <p:cNvSpPr/>
-          <p:nvPr/>
-        </p:nvSpPr>
-        <p:spPr>
-          <a:xfrm>
-            <a:off x="0" y="0"/>
-            <a:ext cx="12191695" cy="566928"/>
-          </a:xfrm>
-          <a:prstGeom prst="rect">
-            <a:avLst/>
-          </a:prstGeom>
-          <a:solidFill>
-            <a:srgbClr val="E8F3FF"/>
-          </a:solidFill>
-          <a:ln/>
-        </p:spPr>
-      </p:sp>
-      <p:sp>
-        <p:nvSpPr>
-          <p:cNvPr id="4" name="Shape 1"/>
-          <p:cNvSpPr/>
-          <p:nvPr/>
-        </p:nvSpPr>
-        <p:spPr>
-          <a:xfrm>
-            <a:off x="0" y="566928"/>
-            <a:ext cx="12191695" cy="50292"/>
-          </a:xfrm>
-          <a:prstGeom prst="rect">
-            <a:avLst/>
-          </a:prstGeom>
-          <a:solidFill>
-            <a:srgbClr val="0B6BCB"/>
-          </a:solidFill>
-          <a:ln/>
-        </p:spPr>
-      </p:sp>
-      <p:sp>
-        <p:nvSpPr>
-          <p:cNvPr id="5" name="Shape 2"/>
-          <p:cNvSpPr/>
-          <p:nvPr/>
-        </p:nvSpPr>
-        <p:spPr>
-          <a:xfrm>
-            <a:off x="0" y="6510528"/>
-            <a:ext cx="12191695" cy="347472"/>
-          </a:xfrm>
-          <a:prstGeom prst="rect">
-            <a:avLst/>
-          </a:prstGeom>
-          <a:solidFill>
-            <a:srgbClr val="F3F1EA"/>
-          </a:solidFill>
-          <a:ln/>
-        </p:spPr>
-      </p:sp>
-      <p:sp>
-        <p:nvSpPr>
-          <p:cNvPr id="6" name="Text 3"/>
-          <p:cNvSpPr/>
-          <p:nvPr/>
-        </p:nvSpPr>
-        <p:spPr>
-          <a:xfrm>
-            <a:off x="411480" y="6510528"/>
-            <a:ext cx="11338560" cy="347472"/>
+          <p:cNvPr id="3" name="Text 0"/>
+          <p:cNvSpPr/>
+          <p:nvPr/>
+        </p:nvSpPr>
+        <p:spPr>
+          <a:xfrm>
+            <a:off x="9875520" y="6510528"/>
+            <a:ext cx="1920240" cy="347472"/>
           </a:xfrm>
           <a:prstGeom prst="rect">
             <a:avLst/>
@@ -5137,7 +5074,7 @@
           <a:bodyPr wrap="square" lIns="0" tIns="0" rIns="0" bIns="0" rtlCol="0" anchor="ctr"/>
           <a:lstStyle/>
           <a:p>
-            <a:pPr indent="0" marL="0">
+            <a:pPr algn="r" indent="0" marL="0">
               <a:buNone/>
             </a:pPr>
             <a:r>
@@ -5149,7 +5086,7 @@
                 <a:ea typeface="Yu Gothic UI" pitchFamily="34" charset="-122"/>
                 <a:cs typeface="Yu Gothic UI" pitchFamily="34" charset="-120"/>
               </a:rPr>
-              <a:t>RISC-V 入門  ·  オープン ISA</a:t>
+              <a:t>7 / 8</a:t>
             </a:r>
             <a:endParaRPr lang="ja-JP" sz="1400" dirty="0"/>
           </a:p>
@@ -5157,7 +5094,7 @@
       </p:sp>
       <p:sp>
         <p:nvSpPr>
-          <p:cNvPr id="7" name="Text 4"/>
+          <p:cNvPr id="4" name="Text 1"/>
           <p:cNvSpPr/>
           <p:nvPr/>
         </p:nvSpPr>
@@ -5196,7 +5133,7 @@
       </p:sp>
       <p:sp>
         <p:nvSpPr>
-          <p:cNvPr id="8" name="Text 5"/>
+          <p:cNvPr id="5" name="Text 2"/>
           <p:cNvSpPr/>
           <p:nvPr/>
         </p:nvSpPr>
@@ -5241,7 +5178,7 @@
       </p:sp>
       <p:sp>
         <p:nvSpPr>
-          <p:cNvPr id="9" name="Shape 6"/>
+          <p:cNvPr id="6" name="Shape 3"/>
           <p:cNvSpPr/>
           <p:nvPr/>
         </p:nvSpPr>
@@ -5261,7 +5198,7 @@
       </p:sp>
       <p:sp>
         <p:nvSpPr>
-          <p:cNvPr id="10" name="Text 7"/>
+          <p:cNvPr id="7" name="Text 4"/>
           <p:cNvSpPr/>
           <p:nvPr/>
         </p:nvSpPr>
@@ -5306,7 +5243,7 @@
       </p:sp>
       <p:sp>
         <p:nvSpPr>
-          <p:cNvPr id="11" name="Shape 8"/>
+          <p:cNvPr id="8" name="Shape 5"/>
           <p:cNvSpPr/>
           <p:nvPr/>
         </p:nvSpPr>
@@ -5326,7 +5263,7 @@
       </p:sp>
       <p:sp>
         <p:nvSpPr>
-          <p:cNvPr id="12" name="Text 9"/>
+          <p:cNvPr id="9" name="Text 6"/>
           <p:cNvSpPr/>
           <p:nvPr/>
         </p:nvSpPr>
@@ -5371,7 +5308,7 @@
       </p:sp>
       <p:sp>
         <p:nvSpPr>
-          <p:cNvPr id="13" name="Shape 10"/>
+          <p:cNvPr id="10" name="Shape 7"/>
           <p:cNvSpPr/>
           <p:nvPr/>
         </p:nvSpPr>
@@ -5398,7 +5335,7 @@
       </p:sp>
       <p:sp>
         <p:nvSpPr>
-          <p:cNvPr id="14" name="Text 11"/>
+          <p:cNvPr id="11" name="Text 8"/>
           <p:cNvSpPr/>
           <p:nvPr/>
         </p:nvSpPr>
@@ -5437,7 +5374,7 @@
       </p:sp>
       <p:sp>
         <p:nvSpPr>
-          <p:cNvPr id="15" name="Text 12"/>
+          <p:cNvPr id="12" name="Text 9"/>
           <p:cNvSpPr/>
           <p:nvPr/>
         </p:nvSpPr>
@@ -5554,13 +5491,6 @@
 <file path=ppt/slides/slide8.xml><?xml version="1.0" encoding="utf-8"?>
 <p:sld xmlns:a="http://schemas.openxmlformats.org/drawingml/2006/main" xmlns:r="http://schemas.openxmlformats.org/officeDocument/2006/relationships" xmlns:p="http://schemas.openxmlformats.org/presentationml/2006/main">
   <p:cSld name="Slide 8">
-    <p:bg>
-      <p:bgPr>
-        <a:solidFill>
-          <a:srgbClr val="FFFEFA"/>
-        </a:solidFill>
-      </p:bgPr>
-    </p:bg>
     <p:spTree>
       <p:nvGrpSpPr>
         <p:cNvPr id="1" name=""/>
@@ -5577,74 +5507,14 @@
       </p:grpSpPr>
       <p:sp>
         <p:nvSpPr>
-          <p:cNvPr id="3" name="Shape 0"/>
-          <p:cNvSpPr/>
-          <p:nvPr/>
-        </p:nvSpPr>
-        <p:spPr>
-          <a:xfrm>
-            <a:off x="10698480" y="-777240"/>
-            <a:ext cx="2377440" cy="2377440"/>
-          </a:xfrm>
-          <a:prstGeom prst="ellipse">
-            <a:avLst/>
-          </a:prstGeom>
-          <a:solidFill>
-            <a:srgbClr val="E8F3FF"/>
-          </a:solidFill>
-          <a:ln/>
-        </p:spPr>
-      </p:sp>
-      <p:sp>
-        <p:nvSpPr>
-          <p:cNvPr id="4" name="Shape 1"/>
-          <p:cNvSpPr/>
-          <p:nvPr/>
-        </p:nvSpPr>
-        <p:spPr>
-          <a:xfrm>
-            <a:off x="0" y="6510528"/>
-            <a:ext cx="12191695" cy="347472"/>
-          </a:xfrm>
-          <a:prstGeom prst="rect">
-            <a:avLst/>
-          </a:prstGeom>
-          <a:solidFill>
-            <a:srgbClr val="F3F1EA"/>
-          </a:solidFill>
-          <a:ln/>
-        </p:spPr>
-      </p:sp>
-      <p:sp>
-        <p:nvSpPr>
-          <p:cNvPr id="5" name="Shape 2"/>
-          <p:cNvSpPr/>
-          <p:nvPr/>
-        </p:nvSpPr>
-        <p:spPr>
-          <a:xfrm>
-            <a:off x="0" y="6455664"/>
-            <a:ext cx="12191695" cy="54864"/>
-          </a:xfrm>
-          <a:prstGeom prst="rect">
-            <a:avLst/>
-          </a:prstGeom>
-          <a:solidFill>
-            <a:srgbClr val="0B6BCB"/>
-          </a:solidFill>
-          <a:ln/>
-        </p:spPr>
-      </p:sp>
-      <p:sp>
-        <p:nvSpPr>
-          <p:cNvPr id="6" name="Text 3"/>
-          <p:cNvSpPr/>
-          <p:nvPr/>
-        </p:nvSpPr>
-        <p:spPr>
-          <a:xfrm>
-            <a:off x="411480" y="6510528"/>
-            <a:ext cx="11338560" cy="347472"/>
+          <p:cNvPr id="3" name="Text 0"/>
+          <p:cNvSpPr/>
+          <p:nvPr/>
+        </p:nvSpPr>
+        <p:spPr>
+          <a:xfrm>
+            <a:off x="9875520" y="6510528"/>
+            <a:ext cx="1920240" cy="347472"/>
           </a:xfrm>
           <a:prstGeom prst="rect">
             <a:avLst/>
@@ -5656,7 +5526,7 @@
           <a:bodyPr wrap="square" lIns="0" tIns="0" rIns="0" bIns="0" rtlCol="0" anchor="ctr"/>
           <a:lstStyle/>
           <a:p>
-            <a:pPr indent="0" marL="0">
+            <a:pPr algn="r" indent="0" marL="0">
               <a:buNone/>
             </a:pPr>
             <a:r>
@@ -5668,7 +5538,7 @@
                 <a:ea typeface="Yu Gothic UI" pitchFamily="34" charset="-122"/>
                 <a:cs typeface="Yu Gothic UI" pitchFamily="34" charset="-120"/>
               </a:rPr>
-              <a:t>RISC-V 入門  ·  まとめ</a:t>
+              <a:t>8 / 8</a:t>
             </a:r>
             <a:endParaRPr lang="ja-JP" sz="1400" dirty="0"/>
           </a:p>
@@ -5676,7 +5546,7 @@
       </p:sp>
       <p:sp>
         <p:nvSpPr>
-          <p:cNvPr id="7" name="Text 4"/>
+          <p:cNvPr id="4" name="Text 1"/>
           <p:cNvSpPr/>
           <p:nvPr/>
         </p:nvSpPr>
@@ -5715,7 +5585,7 @@
       </p:sp>
       <p:sp>
         <p:nvSpPr>
-          <p:cNvPr id="8" name="Shape 5"/>
+          <p:cNvPr id="5" name="Shape 2"/>
           <p:cNvSpPr/>
           <p:nvPr/>
         </p:nvSpPr>
@@ -5737,7 +5607,7 @@
       </p:sp>
       <p:sp>
         <p:nvSpPr>
-          <p:cNvPr id="9" name="Text 6"/>
+          <p:cNvPr id="6" name="Text 3"/>
           <p:cNvSpPr/>
           <p:nvPr/>
         </p:nvSpPr>
@@ -5784,7 +5654,7 @@
       </p:sp>
       <p:sp>
         <p:nvSpPr>
-          <p:cNvPr id="10" name="Text 7"/>
+          <p:cNvPr id="7" name="Text 4"/>
           <p:cNvSpPr/>
           <p:nvPr/>
         </p:nvSpPr>
@@ -5831,7 +5701,7 @@
       </p:sp>
       <p:sp>
         <p:nvSpPr>
-          <p:cNvPr id="11" name="Text 8"/>
+          <p:cNvPr id="8" name="Text 5"/>
           <p:cNvSpPr/>
           <p:nvPr/>
         </p:nvSpPr>
@@ -5878,7 +5748,7 @@
       </p:sp>
       <p:sp>
         <p:nvSpPr>
-          <p:cNvPr id="12" name="Text 9"/>
+          <p:cNvPr id="9" name="Text 6"/>
           <p:cNvSpPr/>
           <p:nvPr/>
         </p:nvSpPr>

</xml_diff>

<commit_message>
Enlarge RISC-V sample fonts for on-screen reading
Bump body and labels to 20pt, content titles to 32pt, title slide to 52/28/22, footer and page numbers to 18pt. Widen a few boxes so the larger type still fits. Slide-master chrome and current/total page numbers are unchanged in structure.

Co-authored-by: shotaminato <shotaminato@users.noreply.github.com>
</commit_message>
<xml_diff>
--- a/examples/sample-deck.pptx
+++ b/examples/sample-deck.pptx
@@ -1249,8 +1249,8 @@
         </p:nvSpPr>
         <p:spPr>
           <a:xfrm>
-            <a:off x="0" y="6510528"/>
-            <a:ext cx="12191695" cy="347472"/>
+            <a:off x="0" y="6419088"/>
+            <a:ext cx="12191695" cy="438912"/>
           </a:xfrm>
           <a:prstGeom prst="rect">
             <a:avLst/>
@@ -1269,8 +1269,8 @@
         </p:nvSpPr>
         <p:spPr>
           <a:xfrm>
-            <a:off x="502920" y="6510528"/>
-            <a:ext cx="9235440" cy="347472"/>
+            <a:off x="502920" y="6419088"/>
+            <a:ext cx="9235440" cy="438912"/>
           </a:xfrm>
           <a:prstGeom prst="rect">
             <a:avLst/>
@@ -1286,7 +1286,7 @@
               <a:buNone/>
             </a:pPr>
             <a:r>
-              <a:rPr lang="ja-JP" altLang="en-US" sz="1400" dirty="0">
+              <a:rPr lang="ja-JP" altLang="en-US" sz="1800" dirty="0">
                 <a:solidFill>
                   <a:srgbClr val="5C6B7A"/>
                 </a:solidFill>
@@ -1296,7 +1296,7 @@
               </a:rPr>
               <a:t>RISC-V 入門  ·  オープン ISA</a:t>
             </a:r>
-            <a:endParaRPr lang="ja-JP" sz="1400" dirty="0"/>
+            <a:endParaRPr lang="ja-JP" sz="1800" dirty="0"/>
           </a:p>
         </p:txBody>
       </p:sp>
@@ -1341,7 +1341,7 @@
         <p:spPr>
           <a:xfrm>
             <a:off x="0" y="0"/>
-            <a:ext cx="12191695" cy="566928"/>
+            <a:ext cx="12191695" cy="658368"/>
           </a:xfrm>
           <a:prstGeom prst="rect">
             <a:avLst/>
@@ -1360,7 +1360,7 @@
         </p:nvSpPr>
         <p:spPr>
           <a:xfrm>
-            <a:off x="0" y="566928"/>
+            <a:off x="0" y="658368"/>
             <a:ext cx="12191695" cy="50292"/>
           </a:xfrm>
           <a:prstGeom prst="rect">
@@ -1380,8 +1380,8 @@
         </p:nvSpPr>
         <p:spPr>
           <a:xfrm>
-            <a:off x="0" y="6510528"/>
-            <a:ext cx="12191695" cy="347472"/>
+            <a:off x="0" y="6419088"/>
+            <a:ext cx="12191695" cy="438912"/>
           </a:xfrm>
           <a:prstGeom prst="rect">
             <a:avLst/>
@@ -1400,8 +1400,8 @@
         </p:nvSpPr>
         <p:spPr>
           <a:xfrm>
-            <a:off x="411480" y="6510528"/>
-            <a:ext cx="9326880" cy="347472"/>
+            <a:off x="411480" y="6419088"/>
+            <a:ext cx="9326880" cy="438912"/>
           </a:xfrm>
           <a:prstGeom prst="rect">
             <a:avLst/>
@@ -1417,7 +1417,7 @@
               <a:buNone/>
             </a:pPr>
             <a:r>
-              <a:rPr lang="ja-JP" altLang="en-US" sz="1400" dirty="0">
+              <a:rPr lang="ja-JP" altLang="en-US" sz="1800" dirty="0">
                 <a:solidFill>
                   <a:srgbClr val="5C6B7A"/>
                 </a:solidFill>
@@ -1427,7 +1427,7 @@
               </a:rPr>
               <a:t>RISC-V 入門  ·  オープン ISA</a:t>
             </a:r>
-            <a:endParaRPr lang="ja-JP" sz="1400" dirty="0"/>
+            <a:endParaRPr lang="ja-JP" sz="1800" dirty="0"/>
           </a:p>
         </p:txBody>
       </p:sp>
@@ -1501,8 +1501,8 @@
         </p:nvSpPr>
         <p:spPr>
           <a:xfrm>
-            <a:off x="0" y="6510528"/>
-            <a:ext cx="12191695" cy="347472"/>
+            <a:off x="0" y="6419088"/>
+            <a:ext cx="12191695" cy="438912"/>
           </a:xfrm>
           <a:prstGeom prst="rect">
             <a:avLst/>
@@ -1521,7 +1521,7 @@
         </p:nvSpPr>
         <p:spPr>
           <a:xfrm>
-            <a:off x="0" y="6455664"/>
+            <a:off x="0" y="6364224"/>
             <a:ext cx="12191695" cy="54864"/>
           </a:xfrm>
           <a:prstGeom prst="rect">
@@ -1541,8 +1541,8 @@
         </p:nvSpPr>
         <p:spPr>
           <a:xfrm>
-            <a:off x="411480" y="6510528"/>
-            <a:ext cx="9326880" cy="347472"/>
+            <a:off x="411480" y="6419088"/>
+            <a:ext cx="9326880" cy="438912"/>
           </a:xfrm>
           <a:prstGeom prst="rect">
             <a:avLst/>
@@ -1558,7 +1558,7 @@
               <a:buNone/>
             </a:pPr>
             <a:r>
-              <a:rPr lang="ja-JP" altLang="en-US" sz="1400" dirty="0">
+              <a:rPr lang="ja-JP" altLang="en-US" sz="1800" dirty="0">
                 <a:solidFill>
                   <a:srgbClr val="5C6B7A"/>
                 </a:solidFill>
@@ -1568,7 +1568,7 @@
               </a:rPr>
               <a:t>RISC-V 入門  ·  まとめ</a:t>
             </a:r>
-            <a:endParaRPr lang="ja-JP" sz="1400" dirty="0"/>
+            <a:endParaRPr lang="ja-JP" sz="1800" dirty="0"/>
           </a:p>
         </p:txBody>
       </p:sp>
@@ -1885,8 +1885,8 @@
         </p:nvSpPr>
         <p:spPr>
           <a:xfrm>
-            <a:off x="9875520" y="6510528"/>
-            <a:ext cx="1920240" cy="347472"/>
+            <a:off x="9875520" y="6419088"/>
+            <a:ext cx="1920240" cy="438912"/>
           </a:xfrm>
           <a:prstGeom prst="rect">
             <a:avLst/>
@@ -1902,7 +1902,7 @@
               <a:buNone/>
             </a:pPr>
             <a:r>
-              <a:rPr lang="ja-JP" altLang="en-US" sz="1400" dirty="0">
+              <a:rPr lang="ja-JP" altLang="en-US" sz="1800" dirty="0">
                 <a:solidFill>
                   <a:srgbClr val="5C6B7A"/>
                 </a:solidFill>
@@ -1912,7 +1912,7 @@
               </a:rPr>
               <a:t>1 / 8</a:t>
             </a:r>
-            <a:endParaRPr lang="ja-JP" sz="1400" dirty="0"/>
+            <a:endParaRPr lang="ja-JP" sz="1800" dirty="0"/>
           </a:p>
         </p:txBody>
       </p:sp>
@@ -1932,8 +1932,8 @@
         </p:blipFill>
         <p:spPr>
           <a:xfrm>
-            <a:off x="640080" y="1874520"/>
-            <a:ext cx="960120" cy="960120"/>
+            <a:off x="640080" y="1737360"/>
+            <a:ext cx="1051560" cy="1051560"/>
           </a:xfrm>
           <a:prstGeom prst="rect">
             <a:avLst/>
@@ -1948,8 +1948,8 @@
         </p:nvSpPr>
         <p:spPr>
           <a:xfrm>
-            <a:off x="1828800" y="1783080"/>
-            <a:ext cx="9601200" cy="640080"/>
+            <a:off x="1874520" y="1645920"/>
+            <a:ext cx="9601200" cy="804672"/>
           </a:xfrm>
           <a:prstGeom prst="rect">
             <a:avLst/>
@@ -1965,7 +1965,7 @@
               <a:buNone/>
             </a:pPr>
             <a:r>
-              <a:rPr lang="ja-JP" altLang="en-US" sz="4400" b="1" dirty="0">
+              <a:rPr lang="ja-JP" altLang="en-US" sz="5200" b="1" dirty="0">
                 <a:solidFill>
                   <a:srgbClr val="1B2430"/>
                 </a:solidFill>
@@ -1975,7 +1975,7 @@
               </a:rPr>
               <a:t>RISC-V 入門</a:t>
             </a:r>
-            <a:endParaRPr lang="ja-JP" sz="4400" dirty="0"/>
+            <a:endParaRPr lang="ja-JP" sz="5200" dirty="0"/>
           </a:p>
         </p:txBody>
       </p:sp>
@@ -1987,8 +1987,8 @@
         </p:nvSpPr>
         <p:spPr>
           <a:xfrm>
-            <a:off x="1828800" y="2423160"/>
-            <a:ext cx="9601200" cy="411480"/>
+            <a:off x="1874520" y="2468880"/>
+            <a:ext cx="9601200" cy="475488"/>
           </a:xfrm>
           <a:prstGeom prst="rect">
             <a:avLst/>
@@ -2004,7 +2004,7 @@
               <a:buNone/>
             </a:pPr>
             <a:r>
-              <a:rPr lang="ja-JP" altLang="en-US" sz="2200" dirty="0">
+              <a:rPr lang="ja-JP" altLang="en-US" sz="2800" dirty="0">
                 <a:solidFill>
                   <a:srgbClr val="5C6B7A"/>
                 </a:solidFill>
@@ -2014,7 +2014,7 @@
               </a:rPr>
               <a:t>オープンな命令セットアーキテクチャ</a:t>
             </a:r>
-            <a:endParaRPr lang="ja-JP" sz="2200" dirty="0"/>
+            <a:endParaRPr lang="ja-JP" sz="2800" dirty="0"/>
           </a:p>
         </p:txBody>
       </p:sp>
@@ -2026,7 +2026,7 @@
         </p:nvSpPr>
         <p:spPr>
           <a:xfrm>
-            <a:off x="1828800" y="3017520"/>
+            <a:off x="1874520" y="3072384"/>
             <a:ext cx="502920" cy="91440"/>
           </a:xfrm>
           <a:prstGeom prst="roundRect">
@@ -2048,8 +2048,8 @@
         </p:nvSpPr>
         <p:spPr>
           <a:xfrm>
-            <a:off x="1828800" y="3246120"/>
-            <a:ext cx="9601200" cy="365760"/>
+            <a:off x="1874520" y="3273552"/>
+            <a:ext cx="9601200" cy="411480"/>
           </a:xfrm>
           <a:prstGeom prst="rect">
             <a:avLst/>
@@ -2065,7 +2065,7 @@
               <a:buNone/>
             </a:pPr>
             <a:r>
-              <a:rPr lang="ja-JP" altLang="en-US" sz="1800" dirty="0">
+              <a:rPr lang="ja-JP" altLang="en-US" sz="2200" dirty="0">
                 <a:solidFill>
                   <a:srgbClr val="0B6BCB"/>
                 </a:solidFill>
@@ -2075,7 +2075,7 @@
               </a:rPr>
               <a:t>基本 ISA  ·  標準拡張  ·  特権レベル</a:t>
             </a:r>
-            <a:endParaRPr lang="ja-JP" sz="1800" dirty="0"/>
+            <a:endParaRPr lang="ja-JP" sz="2200" dirty="0"/>
           </a:p>
         </p:txBody>
       </p:sp>
@@ -2112,8 +2112,8 @@
         </p:nvSpPr>
         <p:spPr>
           <a:xfrm>
-            <a:off x="9875520" y="6510528"/>
-            <a:ext cx="1920240" cy="347472"/>
+            <a:off x="9875520" y="6419088"/>
+            <a:ext cx="1920240" cy="438912"/>
           </a:xfrm>
           <a:prstGeom prst="rect">
             <a:avLst/>
@@ -2129,7 +2129,7 @@
               <a:buNone/>
             </a:pPr>
             <a:r>
-              <a:rPr lang="ja-JP" altLang="en-US" sz="1400" dirty="0">
+              <a:rPr lang="ja-JP" altLang="en-US" sz="1800" dirty="0">
                 <a:solidFill>
                   <a:srgbClr val="5C6B7A"/>
                 </a:solidFill>
@@ -2139,7 +2139,7 @@
               </a:rPr>
               <a:t>2 / 8</a:t>
             </a:r>
-            <a:endParaRPr lang="ja-JP" sz="1400" dirty="0"/>
+            <a:endParaRPr lang="ja-JP" sz="1800" dirty="0"/>
           </a:p>
         </p:txBody>
       </p:sp>
@@ -2151,8 +2151,8 @@
         </p:nvSpPr>
         <p:spPr>
           <a:xfrm>
-            <a:off x="411480" y="45720"/>
-            <a:ext cx="11338560" cy="493776"/>
+            <a:off x="411480" y="36576"/>
+            <a:ext cx="11338560" cy="585216"/>
           </a:xfrm>
           <a:prstGeom prst="rect">
             <a:avLst/>
@@ -2168,7 +2168,7 @@
               <a:buNone/>
             </a:pPr>
             <a:r>
-              <a:rPr lang="ja-JP" altLang="en-US" sz="2600" b="1" dirty="0">
+              <a:rPr lang="ja-JP" altLang="en-US" sz="3200" b="1" dirty="0">
                 <a:solidFill>
                   <a:srgbClr val="1B2430"/>
                 </a:solidFill>
@@ -2178,7 +2178,7 @@
               </a:rPr>
               <a:t>RISC-V とは</a:t>
             </a:r>
-            <a:endParaRPr lang="ja-JP" sz="2600" dirty="0"/>
+            <a:endParaRPr lang="ja-JP" sz="3200" dirty="0"/>
           </a:p>
         </p:txBody>
       </p:sp>
@@ -2190,8 +2190,8 @@
         </p:nvSpPr>
         <p:spPr>
           <a:xfrm>
-            <a:off x="457200" y="822960"/>
-            <a:ext cx="11247120" cy="640080"/>
+            <a:off x="457200" y="804672"/>
+            <a:ext cx="11247120" cy="749808"/>
           </a:xfrm>
           <a:prstGeom prst="rect">
             <a:avLst/>
@@ -2207,7 +2207,7 @@
               <a:buNone/>
             </a:pPr>
             <a:r>
-              <a:rPr lang="ja-JP" altLang="en-US" sz="1600" dirty="0">
+              <a:rPr lang="ja-JP" altLang="en-US" sz="2000" dirty="0">
                 <a:solidFill>
                   <a:srgbClr val="1B2430"/>
                 </a:solidFill>
@@ -2217,7 +2217,7 @@
               </a:rPr>
               <a:t>命令セットアーキテクチャ（ISA）のオープン標準です。2010 年に UC Berkeley で始まり、仕様は RISC-V International が維持しています。</a:t>
             </a:r>
-            <a:endParaRPr lang="ja-JP" sz="1600" dirty="0"/>
+            <a:endParaRPr lang="ja-JP" sz="2000" dirty="0"/>
           </a:p>
         </p:txBody>
       </p:sp>
@@ -2257,7 +2257,7 @@
         <p:spPr>
           <a:xfrm>
             <a:off x="640080" y="1828800"/>
-            <a:ext cx="3200400" cy="365760"/>
+            <a:ext cx="3200400" cy="438912"/>
           </a:xfrm>
           <a:prstGeom prst="rect">
             <a:avLst/>
@@ -2273,7 +2273,7 @@
               <a:buNone/>
             </a:pPr>
             <a:r>
-              <a:rPr lang="ja-JP" altLang="en-US" sz="1600" b="1" dirty="0">
+              <a:rPr lang="ja-JP" altLang="en-US" sz="2000" b="1" dirty="0">
                 <a:solidFill>
                   <a:srgbClr val="0B6BCB"/>
                 </a:solidFill>
@@ -2283,7 +2283,7 @@
               </a:rPr>
               <a:t>オープン</a:t>
             </a:r>
-            <a:endParaRPr lang="ja-JP" sz="1600" dirty="0"/>
+            <a:endParaRPr lang="ja-JP" sz="2000" dirty="0"/>
           </a:p>
         </p:txBody>
       </p:sp>
@@ -2312,7 +2312,7 @@
               <a:buNone/>
             </a:pPr>
             <a:r>
-              <a:rPr lang="ja-JP" altLang="en-US" sz="1600" dirty="0">
+              <a:rPr lang="ja-JP" altLang="en-US" sz="2000" dirty="0">
                 <a:solidFill>
                   <a:srgbClr val="1B2430"/>
                 </a:solidFill>
@@ -2322,14 +2322,14 @@
               </a:rPr>
               <a:t>仕様にライセンス料はかかりません。</a:t>
             </a:r>
-            <a:endParaRPr lang="ja-JP" sz="1600" dirty="0"/>
+            <a:endParaRPr lang="ja-JP" sz="2000" dirty="0"/>
           </a:p>
           <a:p>
             <a:pPr indent="0" marL="0">
               <a:buNone/>
             </a:pPr>
             <a:r>
-              <a:rPr lang="ja-JP" altLang="en-US" sz="1600" dirty="0">
+              <a:rPr lang="ja-JP" altLang="en-US" sz="2000" dirty="0">
                 <a:solidFill>
                   <a:srgbClr val="1B2430"/>
                 </a:solidFill>
@@ -2339,7 +2339,7 @@
               </a:rPr>
               <a:t>実装はオープンソースでも、プロプライエタリでも構いません。</a:t>
             </a:r>
-            <a:endParaRPr lang="ja-JP" sz="1600" dirty="0"/>
+            <a:endParaRPr lang="ja-JP" sz="2000" dirty="0"/>
           </a:p>
         </p:txBody>
       </p:sp>
@@ -2379,7 +2379,7 @@
         <p:spPr>
           <a:xfrm>
             <a:off x="4480560" y="1828800"/>
-            <a:ext cx="3200400" cy="365760"/>
+            <a:ext cx="3200400" cy="438912"/>
           </a:xfrm>
           <a:prstGeom prst="rect">
             <a:avLst/>
@@ -2395,7 +2395,7 @@
               <a:buNone/>
             </a:pPr>
             <a:r>
-              <a:rPr lang="ja-JP" altLang="en-US" sz="1600" b="1" dirty="0">
+              <a:rPr lang="ja-JP" altLang="en-US" sz="2000" b="1" dirty="0">
                 <a:solidFill>
                   <a:srgbClr val="0B6BCB"/>
                 </a:solidFill>
@@ -2405,7 +2405,7 @@
               </a:rPr>
               <a:t>RISC の基本</a:t>
             </a:r>
-            <a:endParaRPr lang="ja-JP" sz="1600" dirty="0"/>
+            <a:endParaRPr lang="ja-JP" sz="2000" dirty="0"/>
           </a:p>
         </p:txBody>
       </p:sp>
@@ -2434,7 +2434,7 @@
               <a:buNone/>
             </a:pPr>
             <a:r>
-              <a:rPr lang="ja-JP" altLang="en-US" sz="1600" dirty="0">
+              <a:rPr lang="ja-JP" altLang="en-US" sz="2000" dirty="0">
                 <a:solidFill>
                   <a:srgbClr val="1B2430"/>
                 </a:solidFill>
@@ -2444,7 +2444,7 @@
               </a:rPr>
               <a:t>ロードストア型。演算はレジスタ間で行い、メモリは load / store 経由です。エンディアンはリトルエンディアンです。</a:t>
             </a:r>
-            <a:endParaRPr lang="ja-JP" sz="1600" dirty="0"/>
+            <a:endParaRPr lang="ja-JP" sz="2000" dirty="0"/>
           </a:p>
         </p:txBody>
       </p:sp>
@@ -2484,7 +2484,7 @@
         <p:spPr>
           <a:xfrm>
             <a:off x="8321040" y="1828800"/>
-            <a:ext cx="3200400" cy="365760"/>
+            <a:ext cx="3200400" cy="438912"/>
           </a:xfrm>
           <a:prstGeom prst="rect">
             <a:avLst/>
@@ -2500,7 +2500,7 @@
               <a:buNone/>
             </a:pPr>
             <a:r>
-              <a:rPr lang="ja-JP" altLang="en-US" sz="1600" b="1" dirty="0">
+              <a:rPr lang="ja-JP" altLang="en-US" sz="2000" b="1" dirty="0">
                 <a:solidFill>
                   <a:srgbClr val="0B6BCB"/>
                 </a:solidFill>
@@ -2510,7 +2510,7 @@
               </a:rPr>
               <a:t>モジュール</a:t>
             </a:r>
-            <a:endParaRPr lang="ja-JP" sz="1600" dirty="0"/>
+            <a:endParaRPr lang="ja-JP" sz="2000" dirty="0"/>
           </a:p>
         </p:txBody>
       </p:sp>
@@ -2539,7 +2539,7 @@
               <a:buNone/>
             </a:pPr>
             <a:r>
-              <a:rPr lang="ja-JP" altLang="en-US" sz="1600" dirty="0">
+              <a:rPr lang="ja-JP" altLang="en-US" sz="2000" dirty="0">
                 <a:solidFill>
                   <a:srgbClr val="1B2430"/>
                 </a:solidFill>
@@ -2549,7 +2549,7 @@
               </a:rPr>
               <a:t>整数ベース ISA を凍結し、乗除・浮動小数点・圧縮・ベクトルなどは標準拡張として足します。</a:t>
             </a:r>
-            <a:endParaRPr lang="ja-JP" sz="1600" dirty="0"/>
+            <a:endParaRPr lang="ja-JP" sz="2000" dirty="0"/>
           </a:p>
         </p:txBody>
       </p:sp>
@@ -2586,8 +2586,8 @@
         </p:nvSpPr>
         <p:spPr>
           <a:xfrm>
-            <a:off x="9875520" y="6510528"/>
-            <a:ext cx="1920240" cy="347472"/>
+            <a:off x="9875520" y="6419088"/>
+            <a:ext cx="1920240" cy="438912"/>
           </a:xfrm>
           <a:prstGeom prst="rect">
             <a:avLst/>
@@ -2603,7 +2603,7 @@
               <a:buNone/>
             </a:pPr>
             <a:r>
-              <a:rPr lang="ja-JP" altLang="en-US" sz="1400" dirty="0">
+              <a:rPr lang="ja-JP" altLang="en-US" sz="1800" dirty="0">
                 <a:solidFill>
                   <a:srgbClr val="5C6B7A"/>
                 </a:solidFill>
@@ -2613,7 +2613,7 @@
               </a:rPr>
               <a:t>3 / 8</a:t>
             </a:r>
-            <a:endParaRPr lang="ja-JP" sz="1400" dirty="0"/>
+            <a:endParaRPr lang="ja-JP" sz="1800" dirty="0"/>
           </a:p>
         </p:txBody>
       </p:sp>
@@ -2625,8 +2625,8 @@
         </p:nvSpPr>
         <p:spPr>
           <a:xfrm>
-            <a:off x="411480" y="45720"/>
-            <a:ext cx="11338560" cy="493776"/>
+            <a:off x="411480" y="36576"/>
+            <a:ext cx="11338560" cy="585216"/>
           </a:xfrm>
           <a:prstGeom prst="rect">
             <a:avLst/>
@@ -2642,7 +2642,7 @@
               <a:buNone/>
             </a:pPr>
             <a:r>
-              <a:rPr lang="ja-JP" altLang="en-US" sz="2600" b="1" dirty="0">
+              <a:rPr lang="ja-JP" altLang="en-US" sz="3200" b="1" dirty="0">
                 <a:solidFill>
                   <a:srgbClr val="1B2430"/>
                 </a:solidFill>
@@ -2652,7 +2652,7 @@
               </a:rPr>
               <a:t>設計思想</a:t>
             </a:r>
-            <a:endParaRPr lang="ja-JP" sz="2600" dirty="0"/>
+            <a:endParaRPr lang="ja-JP" sz="3200" dirty="0"/>
           </a:p>
         </p:txBody>
       </p:sp>
@@ -2689,7 +2689,7 @@
               <a:buNone/>
             </a:pPr>
             <a:r>
-              <a:rPr lang="ja-JP" altLang="en-US" sz="1600" dirty="0">
+              <a:rPr lang="ja-JP" altLang="en-US" sz="2000" dirty="0">
                 <a:solidFill>
                   <a:srgbClr val="1B2430"/>
                 </a:solidFill>
@@ -2699,14 +2699,14 @@
               </a:rPr>
               <a:t>シンプル</a:t>
             </a:r>
-            <a:endParaRPr lang="ja-JP" sz="1600" dirty="0"/>
+            <a:endParaRPr lang="ja-JP" sz="2000" dirty="0"/>
           </a:p>
           <a:p>
             <a:pPr algn="l" indent="0" marL="0">
               <a:buNone/>
             </a:pPr>
             <a:r>
-              <a:rPr lang="ja-JP" altLang="en-US" sz="1600" dirty="0">
+              <a:rPr lang="ja-JP" altLang="en-US" sz="2000" dirty="0">
                 <a:solidFill>
                   <a:srgbClr val="1B2430"/>
                 </a:solidFill>
@@ -2716,7 +2716,7 @@
               </a:rPr>
               <a:t>遅延スロットや条件コードを ISA に載せない。直交した命令と少ない形式。</a:t>
             </a:r>
-            <a:endParaRPr lang="ja-JP" sz="1600" dirty="0"/>
+            <a:endParaRPr lang="ja-JP" sz="2000" dirty="0"/>
           </a:p>
         </p:txBody>
       </p:sp>
@@ -2753,7 +2753,7 @@
               <a:buNone/>
             </a:pPr>
             <a:r>
-              <a:rPr lang="ja-JP" altLang="en-US" sz="1600" dirty="0">
+              <a:rPr lang="ja-JP" altLang="en-US" sz="2000" dirty="0">
                 <a:solidFill>
                   <a:srgbClr val="1B2430"/>
                 </a:solidFill>
@@ -2763,14 +2763,14 @@
               </a:rPr>
               <a:t>モジュール</a:t>
             </a:r>
-            <a:endParaRPr lang="ja-JP" sz="1600" dirty="0"/>
+            <a:endParaRPr lang="ja-JP" sz="2000" dirty="0"/>
           </a:p>
           <a:p>
             <a:pPr algn="l" indent="0" marL="0">
               <a:buNone/>
             </a:pPr>
             <a:r>
-              <a:rPr lang="ja-JP" altLang="en-US" sz="1600" dirty="0">
+              <a:rPr lang="ja-JP" altLang="en-US" sz="2000" dirty="0">
                 <a:solidFill>
                   <a:srgbClr val="1B2430"/>
                 </a:solidFill>
@@ -2780,7 +2780,7 @@
               </a:rPr>
               <a:t>必要な拡張だけを実装する。組み込みは小さく、応用は RV64GC などから広げられる。</a:t>
             </a:r>
-            <a:endParaRPr lang="ja-JP" sz="1600" dirty="0"/>
+            <a:endParaRPr lang="ja-JP" sz="2000" dirty="0"/>
           </a:p>
         </p:txBody>
       </p:sp>
@@ -2817,7 +2817,7 @@
               <a:buNone/>
             </a:pPr>
             <a:r>
-              <a:rPr lang="ja-JP" altLang="en-US" sz="1600" dirty="0">
+              <a:rPr lang="ja-JP" altLang="en-US" sz="2000" dirty="0">
                 <a:solidFill>
                   <a:srgbClr val="1B2430"/>
                 </a:solidFill>
@@ -2827,14 +2827,14 @@
               </a:rPr>
               <a:t>安定</a:t>
             </a:r>
-            <a:endParaRPr lang="ja-JP" sz="1600" dirty="0"/>
+            <a:endParaRPr lang="ja-JP" sz="2000" dirty="0"/>
           </a:p>
           <a:p>
             <a:pPr algn="l" indent="0" marL="0">
               <a:buNone/>
             </a:pPr>
             <a:r>
-              <a:rPr lang="ja-JP" altLang="en-US" sz="1600" dirty="0">
+              <a:rPr lang="ja-JP" altLang="en-US" sz="2000" dirty="0">
                 <a:solidFill>
                   <a:srgbClr val="1B2430"/>
                 </a:solidFill>
@@ -2844,7 +2844,7 @@
               </a:rPr>
               <a:t>批准済みのベース ISA は凍結する。既存のソフトウェアを壊す変更を入れない。</a:t>
             </a:r>
-            <a:endParaRPr lang="ja-JP" sz="1600" dirty="0"/>
+            <a:endParaRPr lang="ja-JP" sz="2000" dirty="0"/>
           </a:p>
         </p:txBody>
       </p:sp>
@@ -2881,7 +2881,7 @@
               <a:buNone/>
             </a:pPr>
             <a:r>
-              <a:rPr lang="ja-JP" altLang="en-US" sz="1600" dirty="0">
+              <a:rPr lang="ja-JP" altLang="en-US" sz="2000" dirty="0">
                 <a:solidFill>
                   <a:srgbClr val="1B2430"/>
                 </a:solidFill>
@@ -2891,14 +2891,14 @@
               </a:rPr>
               <a:t>実装の自由</a:t>
             </a:r>
-            <a:endParaRPr lang="ja-JP" sz="1600" dirty="0"/>
+            <a:endParaRPr lang="ja-JP" sz="2000" dirty="0"/>
           </a:p>
           <a:p>
             <a:pPr algn="l" indent="0" marL="0">
               <a:buNone/>
             </a:pPr>
             <a:r>
-              <a:rPr lang="ja-JP" altLang="en-US" sz="1600" dirty="0">
+              <a:rPr lang="ja-JP" altLang="en-US" sz="2000" dirty="0">
                 <a:solidFill>
                   <a:srgbClr val="1B2430"/>
                 </a:solidFill>
@@ -2908,7 +2908,7 @@
               </a:rPr>
               <a:t>パイプラインやキャッシュの形は ISA が縛りすぎない。ASIC でも FPGA でも同じ命令セット。</a:t>
             </a:r>
-            <a:endParaRPr lang="ja-JP" sz="1600" dirty="0"/>
+            <a:endParaRPr lang="ja-JP" sz="2000" dirty="0"/>
           </a:p>
         </p:txBody>
       </p:sp>
@@ -2945,8 +2945,8 @@
         </p:nvSpPr>
         <p:spPr>
           <a:xfrm>
-            <a:off x="9875520" y="6510528"/>
-            <a:ext cx="1920240" cy="347472"/>
+            <a:off x="9875520" y="6419088"/>
+            <a:ext cx="1920240" cy="438912"/>
           </a:xfrm>
           <a:prstGeom prst="rect">
             <a:avLst/>
@@ -2962,7 +2962,7 @@
               <a:buNone/>
             </a:pPr>
             <a:r>
-              <a:rPr lang="ja-JP" altLang="en-US" sz="1400" dirty="0">
+              <a:rPr lang="ja-JP" altLang="en-US" sz="1800" dirty="0">
                 <a:solidFill>
                   <a:srgbClr val="5C6B7A"/>
                 </a:solidFill>
@@ -2972,7 +2972,7 @@
               </a:rPr>
               <a:t>4 / 8</a:t>
             </a:r>
-            <a:endParaRPr lang="ja-JP" sz="1400" dirty="0"/>
+            <a:endParaRPr lang="ja-JP" sz="1800" dirty="0"/>
           </a:p>
         </p:txBody>
       </p:sp>
@@ -2984,8 +2984,8 @@
         </p:nvSpPr>
         <p:spPr>
           <a:xfrm>
-            <a:off x="411480" y="45720"/>
-            <a:ext cx="11338560" cy="493776"/>
+            <a:off x="411480" y="36576"/>
+            <a:ext cx="11338560" cy="585216"/>
           </a:xfrm>
           <a:prstGeom prst="rect">
             <a:avLst/>
@@ -3001,7 +3001,7 @@
               <a:buNone/>
             </a:pPr>
             <a:r>
-              <a:rPr lang="ja-JP" altLang="en-US" sz="2600" b="1" dirty="0">
+              <a:rPr lang="ja-JP" altLang="en-US" sz="3200" b="1" dirty="0">
                 <a:solidFill>
                   <a:srgbClr val="1B2430"/>
                 </a:solidFill>
@@ -3011,7 +3011,7 @@
               </a:rPr>
               <a:t>ベース整数 ISA</a:t>
             </a:r>
-            <a:endParaRPr lang="ja-JP" sz="2600" dirty="0"/>
+            <a:endParaRPr lang="ja-JP" sz="3200" dirty="0"/>
           </a:p>
         </p:txBody>
       </p:sp>
@@ -3023,8 +3023,8 @@
         </p:nvSpPr>
         <p:spPr>
           <a:xfrm>
-            <a:off x="457200" y="777240"/>
-            <a:ext cx="11247120" cy="502920"/>
+            <a:off x="457200" y="768096"/>
+            <a:ext cx="11247120" cy="621792"/>
           </a:xfrm>
           <a:prstGeom prst="rect">
             <a:avLst/>
@@ -3040,7 +3040,7 @@
               <a:buNone/>
             </a:pPr>
             <a:r>
-              <a:rPr lang="ja-JP" altLang="en-US" sz="1600" dirty="0">
+              <a:rPr lang="ja-JP" altLang="en-US" sz="2000" dirty="0">
                 <a:solidFill>
                   <a:srgbClr val="1B2430"/>
                 </a:solidFill>
@@ -3050,7 +3050,7 @@
               </a:rPr>
               <a:t>整数ベースは RV32I / RV64I / RV128I。組み込み向けにレジスタ 16 本の RV32E もあります。命令は基本 32 ビットです。</a:t>
             </a:r>
-            <a:endParaRPr lang="ja-JP" sz="1600" dirty="0"/>
+            <a:endParaRPr lang="ja-JP" sz="2000" dirty="0"/>
           </a:p>
         </p:txBody>
       </p:sp>
@@ -3062,7 +3062,7 @@
         </p:nvSpPr>
         <p:spPr>
           <a:xfrm>
-            <a:off x="457200" y="1417320"/>
+            <a:off x="457200" y="1481328"/>
             <a:ext cx="2651760" cy="1051560"/>
           </a:xfrm>
           <a:prstGeom prst="rect">
@@ -3081,7 +3081,7 @@
               <a:buNone/>
             </a:pPr>
             <a:r>
-              <a:rPr lang="ja-JP" altLang="en-US" sz="1800" b="1" dirty="0">
+              <a:rPr lang="ja-JP" altLang="en-US" sz="2200" b="1" dirty="0">
                 <a:solidFill>
                   <a:srgbClr val="FFFFFF"/>
                 </a:solidFill>
@@ -3091,7 +3091,7 @@
               </a:rPr>
               <a:t>RV32I</a:t>
             </a:r>
-            <a:endParaRPr lang="ja-JP" sz="1800" dirty="0"/>
+            <a:endParaRPr lang="ja-JP" sz="2200" dirty="0"/>
           </a:p>
         </p:txBody>
       </p:sp>
@@ -3103,7 +3103,7 @@
         </p:nvSpPr>
         <p:spPr>
           <a:xfrm>
-            <a:off x="3291840" y="1417320"/>
+            <a:off x="3291840" y="1481328"/>
             <a:ext cx="2651760" cy="1051560"/>
           </a:xfrm>
           <a:prstGeom prst="rect">
@@ -3122,7 +3122,7 @@
               <a:buNone/>
             </a:pPr>
             <a:r>
-              <a:rPr lang="ja-JP" altLang="en-US" sz="1800" b="1" dirty="0">
+              <a:rPr lang="ja-JP" altLang="en-US" sz="2200" b="1" dirty="0">
                 <a:solidFill>
                   <a:srgbClr val="FFFFFF"/>
                 </a:solidFill>
@@ -3132,7 +3132,7 @@
               </a:rPr>
               <a:t>RV64I</a:t>
             </a:r>
-            <a:endParaRPr lang="ja-JP" sz="1800" dirty="0"/>
+            <a:endParaRPr lang="ja-JP" sz="2200" dirty="0"/>
           </a:p>
         </p:txBody>
       </p:sp>
@@ -3144,7 +3144,7 @@
         </p:nvSpPr>
         <p:spPr>
           <a:xfrm>
-            <a:off x="6126480" y="1417320"/>
+            <a:off x="6126480" y="1481328"/>
             <a:ext cx="2651760" cy="1051560"/>
           </a:xfrm>
           <a:prstGeom prst="rect">
@@ -3163,7 +3163,7 @@
               <a:buNone/>
             </a:pPr>
             <a:r>
-              <a:rPr lang="ja-JP" altLang="en-US" sz="1800" b="1" dirty="0">
+              <a:rPr lang="ja-JP" altLang="en-US" sz="2200" b="1" dirty="0">
                 <a:solidFill>
                   <a:srgbClr val="FFFFFF"/>
                 </a:solidFill>
@@ -3173,7 +3173,7 @@
               </a:rPr>
               <a:t>RV128I</a:t>
             </a:r>
-            <a:endParaRPr lang="ja-JP" sz="1800" dirty="0"/>
+            <a:endParaRPr lang="ja-JP" sz="2200" dirty="0"/>
           </a:p>
         </p:txBody>
       </p:sp>
@@ -3185,7 +3185,7 @@
         </p:nvSpPr>
         <p:spPr>
           <a:xfrm>
-            <a:off x="8961120" y="1417320"/>
+            <a:off x="8961120" y="1481328"/>
             <a:ext cx="2697480" cy="1051560"/>
           </a:xfrm>
           <a:prstGeom prst="roundRect">
@@ -3206,7 +3206,7 @@
               <a:buNone/>
             </a:pPr>
             <a:r>
-              <a:rPr lang="ja-JP" altLang="en-US" sz="1600" b="1" dirty="0">
+              <a:rPr lang="ja-JP" altLang="en-US" sz="2000" b="1" dirty="0">
                 <a:solidFill>
                   <a:srgbClr val="FFFFFF"/>
                 </a:solidFill>
@@ -3216,7 +3216,7 @@
               </a:rPr>
               <a:t>RV32E（16本）</a:t>
             </a:r>
-            <a:endParaRPr lang="ja-JP" sz="1600" dirty="0"/>
+            <a:endParaRPr lang="ja-JP" sz="2000" dirty="0"/>
           </a:p>
         </p:txBody>
       </p:sp>
@@ -3251,7 +3251,7 @@
               <a:buNone/>
             </a:pPr>
             <a:r>
-              <a:rPr lang="ja-JP" altLang="en-US" sz="1600" b="1" dirty="0">
+              <a:rPr lang="ja-JP" altLang="en-US" sz="2000" b="1" dirty="0">
                 <a:solidFill>
                   <a:srgbClr val="0B6BCB"/>
                 </a:solidFill>
@@ -3261,14 +3261,14 @@
               </a:rPr>
               <a:t>x0</a:t>
             </a:r>
-            <a:endParaRPr lang="ja-JP" sz="1600" dirty="0"/>
+            <a:endParaRPr lang="ja-JP" sz="2000" dirty="0"/>
           </a:p>
           <a:p>
             <a:pPr algn="ctr" indent="0" marL="0">
               <a:buNone/>
             </a:pPr>
             <a:r>
-              <a:rPr lang="ja-JP" altLang="en-US" sz="1600" b="1" dirty="0">
+              <a:rPr lang="ja-JP" altLang="en-US" sz="2000" b="1" dirty="0">
                 <a:solidFill>
                   <a:srgbClr val="0B6BCB"/>
                 </a:solidFill>
@@ -3278,7 +3278,7 @@
               </a:rPr>
               <a:t>zero</a:t>
             </a:r>
-            <a:endParaRPr lang="ja-JP" sz="1600" dirty="0"/>
+            <a:endParaRPr lang="ja-JP" sz="2000" dirty="0"/>
           </a:p>
         </p:txBody>
       </p:sp>
@@ -3307,7 +3307,7 @@
               <a:buNone/>
             </a:pPr>
             <a:r>
-              <a:rPr lang="ja-JP" altLang="en-US" sz="1600" dirty="0">
+              <a:rPr lang="ja-JP" altLang="en-US" sz="2000" dirty="0">
                 <a:solidFill>
                   <a:srgbClr val="5C6B7A"/>
                 </a:solidFill>
@@ -3317,7 +3317,7 @@
               </a:rPr>
               <a:t>常に 0。書き込みは捨てられます。</a:t>
             </a:r>
-            <a:endParaRPr lang="ja-JP" sz="1600" dirty="0"/>
+            <a:endParaRPr lang="ja-JP" sz="2000" dirty="0"/>
           </a:p>
         </p:txBody>
       </p:sp>
@@ -3352,7 +3352,7 @@
               <a:buNone/>
             </a:pPr>
             <a:r>
-              <a:rPr lang="ja-JP" altLang="en-US" sz="1600" b="1" dirty="0">
+              <a:rPr lang="ja-JP" altLang="en-US" sz="2000" b="1" dirty="0">
                 <a:solidFill>
                   <a:srgbClr val="1B2430"/>
                 </a:solidFill>
@@ -3362,7 +3362,7 @@
               </a:rPr>
               <a:t>x1 … x31   整数汎用レジスタ（32 ビットまたは 64 ビット）</a:t>
             </a:r>
-            <a:endParaRPr lang="ja-JP" sz="1600" dirty="0"/>
+            <a:endParaRPr lang="ja-JP" sz="2000" dirty="0"/>
           </a:p>
         </p:txBody>
       </p:sp>
@@ -3401,7 +3401,7 @@
               <a:buNone/>
             </a:pPr>
             <a:r>
-              <a:rPr lang="ja-JP" altLang="en-US" sz="1600" b="1" dirty="0">
+              <a:rPr lang="ja-JP" altLang="en-US" sz="2000" b="1" dirty="0">
                 <a:solidFill>
                   <a:srgbClr val="1B2430"/>
                 </a:solidFill>
@@ -3411,14 +3411,14 @@
               </a:rPr>
               <a:t>半透明</a:t>
             </a:r>
-            <a:endParaRPr lang="ja-JP" sz="1600" dirty="0"/>
+            <a:endParaRPr lang="ja-JP" sz="2000" dirty="0"/>
           </a:p>
           <a:p>
             <a:pPr algn="ctr" indent="0" marL="0">
               <a:buNone/>
             </a:pPr>
             <a:r>
-              <a:rPr lang="ja-JP" altLang="en-US" sz="1600" b="1" dirty="0">
+              <a:rPr lang="ja-JP" altLang="en-US" sz="2000" b="1" dirty="0">
                 <a:solidFill>
                   <a:srgbClr val="1B2430"/>
                 </a:solidFill>
@@ -3428,7 +3428,7 @@
               </a:rPr>
               <a:t>F/D の fp</a:t>
             </a:r>
-            <a:endParaRPr lang="ja-JP" sz="1600" dirty="0"/>
+            <a:endParaRPr lang="ja-JP" sz="2000" dirty="0"/>
           </a:p>
         </p:txBody>
       </p:sp>
@@ -3457,7 +3457,7 @@
               <a:buNone/>
             </a:pPr>
             <a:r>
-              <a:rPr lang="ja-JP" altLang="en-US" sz="1600" dirty="0">
+              <a:rPr lang="ja-JP" altLang="en-US" sz="2000" dirty="0">
                 <a:solidFill>
                   <a:srgbClr val="5C6B7A"/>
                 </a:solidFill>
@@ -3467,7 +3467,7 @@
               </a:rPr>
               <a:t>ABI 名の例: ra, sp, gp, tp, t0–t6, s0–s11, a0–a7。浮動小数点レジスタは F / D 拡張で別途追加します。</a:t>
             </a:r>
-            <a:endParaRPr lang="ja-JP" sz="1600" dirty="0"/>
+            <a:endParaRPr lang="ja-JP" sz="2000" dirty="0"/>
           </a:p>
         </p:txBody>
       </p:sp>
@@ -3504,8 +3504,8 @@
         </p:nvSpPr>
         <p:spPr>
           <a:xfrm>
-            <a:off x="9875520" y="6510528"/>
-            <a:ext cx="1920240" cy="347472"/>
+            <a:off x="9875520" y="6419088"/>
+            <a:ext cx="1920240" cy="438912"/>
           </a:xfrm>
           <a:prstGeom prst="rect">
             <a:avLst/>
@@ -3521,7 +3521,7 @@
               <a:buNone/>
             </a:pPr>
             <a:r>
-              <a:rPr lang="ja-JP" altLang="en-US" sz="1400" dirty="0">
+              <a:rPr lang="ja-JP" altLang="en-US" sz="1800" dirty="0">
                 <a:solidFill>
                   <a:srgbClr val="5C6B7A"/>
                 </a:solidFill>
@@ -3531,7 +3531,7 @@
               </a:rPr>
               <a:t>5 / 8</a:t>
             </a:r>
-            <a:endParaRPr lang="ja-JP" sz="1400" dirty="0"/>
+            <a:endParaRPr lang="ja-JP" sz="1800" dirty="0"/>
           </a:p>
         </p:txBody>
       </p:sp>
@@ -3543,8 +3543,8 @@
         </p:nvSpPr>
         <p:spPr>
           <a:xfrm>
-            <a:off x="411480" y="45720"/>
-            <a:ext cx="11338560" cy="493776"/>
+            <a:off x="411480" y="36576"/>
+            <a:ext cx="11338560" cy="585216"/>
           </a:xfrm>
           <a:prstGeom prst="rect">
             <a:avLst/>
@@ -3560,7 +3560,7 @@
               <a:buNone/>
             </a:pPr>
             <a:r>
-              <a:rPr lang="ja-JP" altLang="en-US" sz="2600" b="1" dirty="0">
+              <a:rPr lang="ja-JP" altLang="en-US" sz="3200" b="1" dirty="0">
                 <a:solidFill>
                   <a:srgbClr val="1B2430"/>
                 </a:solidFill>
@@ -3570,7 +3570,7 @@
               </a:rPr>
               <a:t>命令フォーマット</a:t>
             </a:r>
-            <a:endParaRPr lang="ja-JP" sz="2600" dirty="0"/>
+            <a:endParaRPr lang="ja-JP" sz="3200" dirty="0"/>
           </a:p>
         </p:txBody>
       </p:sp>
@@ -3582,8 +3582,8 @@
         </p:nvSpPr>
         <p:spPr>
           <a:xfrm>
-            <a:off x="457200" y="749808"/>
-            <a:ext cx="11247120" cy="411480"/>
+            <a:off x="457200" y="768096"/>
+            <a:ext cx="11247120" cy="530352"/>
           </a:xfrm>
           <a:prstGeom prst="rect">
             <a:avLst/>
@@ -3599,7 +3599,7 @@
               <a:buNone/>
             </a:pPr>
             <a:r>
-              <a:rPr lang="ja-JP" altLang="en-US" sz="1600" dirty="0">
+              <a:rPr lang="ja-JP" altLang="en-US" sz="2000" dirty="0">
                 <a:solidFill>
                   <a:srgbClr val="1B2430"/>
                 </a:solidFill>
@@ -3609,7 +3609,7 @@
               </a:rPr>
               <a:t>ベース ISA の命令は 32 ビットで、R / I / S / B / U / J の 6 形式です。即値は符号拡張します。</a:t>
             </a:r>
-            <a:endParaRPr lang="ja-JP" sz="1600" dirty="0"/>
+            <a:endParaRPr lang="ja-JP" sz="2000" dirty="0"/>
           </a:p>
         </p:txBody>
       </p:sp>
@@ -3621,8 +3621,8 @@
         </p:nvSpPr>
         <p:spPr>
           <a:xfrm>
-            <a:off x="457200" y="1280160"/>
-            <a:ext cx="1828800" cy="640080"/>
+            <a:off x="457200" y="1389888"/>
+            <a:ext cx="1828800" cy="713232"/>
           </a:xfrm>
           <a:prstGeom prst="rect">
             <a:avLst/>
@@ -3640,7 +3640,7 @@
               <a:buNone/>
             </a:pPr>
             <a:r>
-              <a:rPr lang="ja-JP" altLang="en-US" sz="1600" b="1" dirty="0">
+              <a:rPr lang="ja-JP" altLang="en-US" sz="2000" b="1" dirty="0">
                 <a:solidFill>
                   <a:srgbClr val="FFFFFF"/>
                 </a:solidFill>
@@ -3650,7 +3650,7 @@
               </a:rPr>
               <a:t>opcode</a:t>
             </a:r>
-            <a:endParaRPr lang="ja-JP" sz="1600" dirty="0"/>
+            <a:endParaRPr lang="ja-JP" sz="2000" dirty="0"/>
           </a:p>
         </p:txBody>
       </p:sp>
@@ -3662,8 +3662,8 @@
         </p:nvSpPr>
         <p:spPr>
           <a:xfrm>
-            <a:off x="2377440" y="1280160"/>
-            <a:ext cx="1554480" cy="640080"/>
+            <a:off x="2377440" y="1389888"/>
+            <a:ext cx="1554480" cy="713232"/>
           </a:xfrm>
           <a:prstGeom prst="rect">
             <a:avLst/>
@@ -3681,7 +3681,7 @@
               <a:buNone/>
             </a:pPr>
             <a:r>
-              <a:rPr lang="ja-JP" altLang="en-US" sz="1600" b="1" dirty="0">
+              <a:rPr lang="ja-JP" altLang="en-US" sz="2000" b="1" dirty="0">
                 <a:solidFill>
                   <a:srgbClr val="FFFFFF"/>
                 </a:solidFill>
@@ -3691,7 +3691,7 @@
               </a:rPr>
               <a:t>rd</a:t>
             </a:r>
-            <a:endParaRPr lang="ja-JP" sz="1600" dirty="0"/>
+            <a:endParaRPr lang="ja-JP" sz="2000" dirty="0"/>
           </a:p>
         </p:txBody>
       </p:sp>
@@ -3703,8 +3703,8 @@
         </p:nvSpPr>
         <p:spPr>
           <a:xfrm>
-            <a:off x="4023360" y="1280160"/>
-            <a:ext cx="1554480" cy="640080"/>
+            <a:off x="4023360" y="1389888"/>
+            <a:ext cx="1554480" cy="713232"/>
           </a:xfrm>
           <a:prstGeom prst="rect">
             <a:avLst/>
@@ -3722,7 +3722,7 @@
               <a:buNone/>
             </a:pPr>
             <a:r>
-              <a:rPr lang="ja-JP" altLang="en-US" sz="1600" b="1" dirty="0">
+              <a:rPr lang="ja-JP" altLang="en-US" sz="2000" b="1" dirty="0">
                 <a:solidFill>
                   <a:srgbClr val="FFFFFF"/>
                 </a:solidFill>
@@ -3732,7 +3732,7 @@
               </a:rPr>
               <a:t>funct3</a:t>
             </a:r>
-            <a:endParaRPr lang="ja-JP" sz="1600" dirty="0"/>
+            <a:endParaRPr lang="ja-JP" sz="2000" dirty="0"/>
           </a:p>
         </p:txBody>
       </p:sp>
@@ -3744,8 +3744,8 @@
         </p:nvSpPr>
         <p:spPr>
           <a:xfrm>
-            <a:off x="5669280" y="1280160"/>
-            <a:ext cx="1554480" cy="640080"/>
+            <a:off x="5669280" y="1389888"/>
+            <a:ext cx="1554480" cy="713232"/>
           </a:xfrm>
           <a:prstGeom prst="rect">
             <a:avLst/>
@@ -3763,7 +3763,7 @@
               <a:buNone/>
             </a:pPr>
             <a:r>
-              <a:rPr lang="ja-JP" altLang="en-US" sz="1600" b="1" dirty="0">
+              <a:rPr lang="ja-JP" altLang="en-US" sz="2000" b="1" dirty="0">
                 <a:solidFill>
                   <a:srgbClr val="FFFFFF"/>
                 </a:solidFill>
@@ -3773,7 +3773,7 @@
               </a:rPr>
               <a:t>rs1</a:t>
             </a:r>
-            <a:endParaRPr lang="ja-JP" sz="1600" dirty="0"/>
+            <a:endParaRPr lang="ja-JP" sz="2000" dirty="0"/>
           </a:p>
         </p:txBody>
       </p:sp>
@@ -3785,8 +3785,8 @@
         </p:nvSpPr>
         <p:spPr>
           <a:xfrm>
-            <a:off x="7315200" y="1280160"/>
-            <a:ext cx="1554480" cy="640080"/>
+            <a:off x="7315200" y="1389888"/>
+            <a:ext cx="1554480" cy="713232"/>
           </a:xfrm>
           <a:prstGeom prst="rect">
             <a:avLst/>
@@ -3804,7 +3804,7 @@
               <a:buNone/>
             </a:pPr>
             <a:r>
-              <a:rPr lang="ja-JP" altLang="en-US" sz="1600" b="1" dirty="0">
+              <a:rPr lang="ja-JP" altLang="en-US" sz="2000" b="1" dirty="0">
                 <a:solidFill>
                   <a:srgbClr val="FFFFFF"/>
                 </a:solidFill>
@@ -3814,7 +3814,7 @@
               </a:rPr>
               <a:t>rs2</a:t>
             </a:r>
-            <a:endParaRPr lang="ja-JP" sz="1600" dirty="0"/>
+            <a:endParaRPr lang="ja-JP" sz="2000" dirty="0"/>
           </a:p>
         </p:txBody>
       </p:sp>
@@ -3826,8 +3826,8 @@
         </p:nvSpPr>
         <p:spPr>
           <a:xfrm>
-            <a:off x="8961120" y="1280160"/>
-            <a:ext cx="2697480" cy="640080"/>
+            <a:off x="8961120" y="1389888"/>
+            <a:ext cx="2697480" cy="713232"/>
           </a:xfrm>
           <a:prstGeom prst="rect">
             <a:avLst/>
@@ -3845,7 +3845,7 @@
               <a:buNone/>
             </a:pPr>
             <a:r>
-              <a:rPr lang="ja-JP" altLang="en-US" sz="1600" b="1" dirty="0">
+              <a:rPr lang="ja-JP" altLang="en-US" sz="2000" b="1" dirty="0">
                 <a:solidFill>
                   <a:srgbClr val="FFFFFF"/>
                 </a:solidFill>
@@ -3855,7 +3855,7 @@
               </a:rPr>
               <a:t>funct7 / imm</a:t>
             </a:r>
-            <a:endParaRPr lang="ja-JP" sz="1600" dirty="0"/>
+            <a:endParaRPr lang="ja-JP" sz="2000" dirty="0"/>
           </a:p>
         </p:txBody>
       </p:sp>
@@ -3867,7 +3867,7 @@
         </p:nvSpPr>
         <p:spPr>
           <a:xfrm>
-            <a:off x="10561320" y="2057400"/>
+            <a:off x="10561320" y="2176272"/>
             <a:ext cx="640080" cy="411480"/>
           </a:xfrm>
           <a:prstGeom prst="triangle">
@@ -3887,8 +3887,8 @@
         </p:nvSpPr>
         <p:spPr>
           <a:xfrm>
-            <a:off x="5669280" y="2029968"/>
-            <a:ext cx="4754880" cy="411480"/>
+            <a:off x="5669280" y="2157984"/>
+            <a:ext cx="4754880" cy="438912"/>
           </a:xfrm>
           <a:prstGeom prst="rect">
             <a:avLst/>
@@ -3904,7 +3904,7 @@
               <a:buNone/>
             </a:pPr>
             <a:r>
-              <a:rPr lang="ja-JP" altLang="en-US" sz="1600" dirty="0">
+              <a:rPr lang="ja-JP" altLang="en-US" sz="2000" dirty="0">
                 <a:solidFill>
                   <a:srgbClr val="C97800"/>
                 </a:solidFill>
@@ -3914,7 +3914,7 @@
               </a:rPr>
               <a:t>即値は形式ごとにビット配置が違う</a:t>
             </a:r>
-            <a:endParaRPr lang="ja-JP" sz="1600" dirty="0"/>
+            <a:endParaRPr lang="ja-JP" sz="2000" dirty="0"/>
           </a:p>
         </p:txBody>
       </p:sp>
@@ -3951,7 +3951,7 @@
               <a:buNone/>
             </a:pPr>
             <a:r>
-              <a:rPr lang="ja-JP" altLang="en-US" sz="1600" dirty="0">
+              <a:rPr lang="ja-JP" altLang="en-US" sz="2000" dirty="0">
                 <a:solidFill>
                   <a:srgbClr val="1B2430"/>
                 </a:solidFill>
@@ -3961,14 +3961,14 @@
               </a:rPr>
               <a:t>R  レジスタ演算</a:t>
             </a:r>
-            <a:endParaRPr lang="ja-JP" sz="1600" dirty="0"/>
+            <a:endParaRPr lang="ja-JP" sz="2000" dirty="0"/>
           </a:p>
           <a:p>
             <a:pPr algn="l" indent="0" marL="0">
               <a:buNone/>
             </a:pPr>
             <a:r>
-              <a:rPr lang="ja-JP" altLang="en-US" sz="1600" dirty="0">
+              <a:rPr lang="ja-JP" altLang="en-US" sz="2000" dirty="0">
                 <a:solidFill>
                   <a:srgbClr val="1B2430"/>
                 </a:solidFill>
@@ -3978,7 +3978,7 @@
               </a:rPr>
               <a:t>add, sub, and, or, xor</a:t>
             </a:r>
-            <a:endParaRPr lang="ja-JP" sz="1600" dirty="0"/>
+            <a:endParaRPr lang="ja-JP" sz="2000" dirty="0"/>
           </a:p>
         </p:txBody>
       </p:sp>
@@ -4015,7 +4015,7 @@
               <a:buNone/>
             </a:pPr>
             <a:r>
-              <a:rPr lang="ja-JP" altLang="en-US" sz="1600" dirty="0">
+              <a:rPr lang="ja-JP" altLang="en-US" sz="2000" dirty="0">
                 <a:solidFill>
                   <a:srgbClr val="1B2430"/>
                 </a:solidFill>
@@ -4025,14 +4025,14 @@
               </a:rPr>
               <a:t>I  即値・ロード</a:t>
             </a:r>
-            <a:endParaRPr lang="ja-JP" sz="1600" dirty="0"/>
+            <a:endParaRPr lang="ja-JP" sz="2000" dirty="0"/>
           </a:p>
           <a:p>
             <a:pPr algn="l" indent="0" marL="0">
               <a:buNone/>
             </a:pPr>
             <a:r>
-              <a:rPr lang="ja-JP" altLang="en-US" sz="1600" dirty="0">
+              <a:rPr lang="ja-JP" altLang="en-US" sz="2000" dirty="0">
                 <a:solidFill>
                   <a:srgbClr val="1B2430"/>
                 </a:solidFill>
@@ -4042,7 +4042,7 @@
               </a:rPr>
               <a:t>addi, lw, jalr, シフト</a:t>
             </a:r>
-            <a:endParaRPr lang="ja-JP" sz="1600" dirty="0"/>
+            <a:endParaRPr lang="ja-JP" sz="2000" dirty="0"/>
           </a:p>
         </p:txBody>
       </p:sp>
@@ -4079,7 +4079,7 @@
               <a:buNone/>
             </a:pPr>
             <a:r>
-              <a:rPr lang="ja-JP" altLang="en-US" sz="1600" dirty="0">
+              <a:rPr lang="ja-JP" altLang="en-US" sz="2000" dirty="0">
                 <a:solidFill>
                   <a:srgbClr val="1B2430"/>
                 </a:solidFill>
@@ -4089,14 +4089,14 @@
               </a:rPr>
               <a:t>S  ストア</a:t>
             </a:r>
-            <a:endParaRPr lang="ja-JP" sz="1600" dirty="0"/>
+            <a:endParaRPr lang="ja-JP" sz="2000" dirty="0"/>
           </a:p>
           <a:p>
             <a:pPr algn="l" indent="0" marL="0">
               <a:buNone/>
             </a:pPr>
             <a:r>
-              <a:rPr lang="ja-JP" altLang="en-US" sz="1600" dirty="0">
+              <a:rPr lang="ja-JP" altLang="en-US" sz="2000" dirty="0">
                 <a:solidFill>
                   <a:srgbClr val="1B2430"/>
                 </a:solidFill>
@@ -4106,7 +4106,7 @@
               </a:rPr>
               <a:t>sw, sh, sb</a:t>
             </a:r>
-            <a:endParaRPr lang="ja-JP" sz="1600" dirty="0"/>
+            <a:endParaRPr lang="ja-JP" sz="2000" dirty="0"/>
           </a:p>
         </p:txBody>
       </p:sp>
@@ -4143,7 +4143,7 @@
               <a:buNone/>
             </a:pPr>
             <a:r>
-              <a:rPr lang="ja-JP" altLang="en-US" sz="1600" dirty="0">
+              <a:rPr lang="ja-JP" altLang="en-US" sz="2000" dirty="0">
                 <a:solidFill>
                   <a:srgbClr val="1B2430"/>
                 </a:solidFill>
@@ -4153,14 +4153,14 @@
               </a:rPr>
               <a:t>B  条件分岐</a:t>
             </a:r>
-            <a:endParaRPr lang="ja-JP" sz="1600" dirty="0"/>
+            <a:endParaRPr lang="ja-JP" sz="2000" dirty="0"/>
           </a:p>
           <a:p>
             <a:pPr algn="l" indent="0" marL="0">
               <a:buNone/>
             </a:pPr>
             <a:r>
-              <a:rPr lang="ja-JP" altLang="en-US" sz="1600" dirty="0">
+              <a:rPr lang="ja-JP" altLang="en-US" sz="2000" dirty="0">
                 <a:solidFill>
                   <a:srgbClr val="1B2430"/>
                 </a:solidFill>
@@ -4170,7 +4170,7 @@
               </a:rPr>
               <a:t>beq, bne, blt, bge</a:t>
             </a:r>
-            <a:endParaRPr lang="ja-JP" sz="1600" dirty="0"/>
+            <a:endParaRPr lang="ja-JP" sz="2000" dirty="0"/>
           </a:p>
         </p:txBody>
       </p:sp>
@@ -4207,7 +4207,7 @@
               <a:buNone/>
             </a:pPr>
             <a:r>
-              <a:rPr lang="ja-JP" altLang="en-US" sz="1600" dirty="0">
+              <a:rPr lang="ja-JP" altLang="en-US" sz="2000" dirty="0">
                 <a:solidFill>
                   <a:srgbClr val="1B2430"/>
                 </a:solidFill>
@@ -4217,14 +4217,14 @@
               </a:rPr>
               <a:t>U  上位即値</a:t>
             </a:r>
-            <a:endParaRPr lang="ja-JP" sz="1600" dirty="0"/>
+            <a:endParaRPr lang="ja-JP" sz="2000" dirty="0"/>
           </a:p>
           <a:p>
             <a:pPr algn="l" indent="0" marL="0">
               <a:buNone/>
             </a:pPr>
             <a:r>
-              <a:rPr lang="ja-JP" altLang="en-US" sz="1600" dirty="0">
+              <a:rPr lang="ja-JP" altLang="en-US" sz="2000" dirty="0">
                 <a:solidFill>
                   <a:srgbClr val="1B2430"/>
                 </a:solidFill>
@@ -4234,7 +4234,7 @@
               </a:rPr>
               <a:t>lui, auipc</a:t>
             </a:r>
-            <a:endParaRPr lang="ja-JP" sz="1600" dirty="0"/>
+            <a:endParaRPr lang="ja-JP" sz="2000" dirty="0"/>
           </a:p>
         </p:txBody>
       </p:sp>
@@ -4271,7 +4271,7 @@
               <a:buNone/>
             </a:pPr>
             <a:r>
-              <a:rPr lang="ja-JP" altLang="en-US" sz="1600" dirty="0">
+              <a:rPr lang="ja-JP" altLang="en-US" sz="2000" dirty="0">
                 <a:solidFill>
                   <a:srgbClr val="1B2430"/>
                 </a:solidFill>
@@ -4281,14 +4281,14 @@
               </a:rPr>
               <a:t>J  ジャンプ</a:t>
             </a:r>
-            <a:endParaRPr lang="ja-JP" sz="1600" dirty="0"/>
+            <a:endParaRPr lang="ja-JP" sz="2000" dirty="0"/>
           </a:p>
           <a:p>
             <a:pPr algn="l" indent="0" marL="0">
               <a:buNone/>
             </a:pPr>
             <a:r>
-              <a:rPr lang="ja-JP" altLang="en-US" sz="1600" dirty="0">
+              <a:rPr lang="ja-JP" altLang="en-US" sz="2000" dirty="0">
                 <a:solidFill>
                   <a:srgbClr val="1B2430"/>
                 </a:solidFill>
@@ -4298,7 +4298,7 @@
               </a:rPr>
               <a:t>jal</a:t>
             </a:r>
-            <a:endParaRPr lang="ja-JP" sz="1600" dirty="0"/>
+            <a:endParaRPr lang="ja-JP" sz="2000" dirty="0"/>
           </a:p>
         </p:txBody>
       </p:sp>
@@ -4335,8 +4335,8 @@
         </p:nvSpPr>
         <p:spPr>
           <a:xfrm>
-            <a:off x="9875520" y="6510528"/>
-            <a:ext cx="1920240" cy="347472"/>
+            <a:off x="9875520" y="6419088"/>
+            <a:ext cx="1920240" cy="438912"/>
           </a:xfrm>
           <a:prstGeom prst="rect">
             <a:avLst/>
@@ -4352,7 +4352,7 @@
               <a:buNone/>
             </a:pPr>
             <a:r>
-              <a:rPr lang="ja-JP" altLang="en-US" sz="1400" dirty="0">
+              <a:rPr lang="ja-JP" altLang="en-US" sz="1800" dirty="0">
                 <a:solidFill>
                   <a:srgbClr val="5C6B7A"/>
                 </a:solidFill>
@@ -4362,7 +4362,7 @@
               </a:rPr>
               <a:t>6 / 8</a:t>
             </a:r>
-            <a:endParaRPr lang="ja-JP" sz="1400" dirty="0"/>
+            <a:endParaRPr lang="ja-JP" sz="1800" dirty="0"/>
           </a:p>
         </p:txBody>
       </p:sp>
@@ -4374,8 +4374,8 @@
         </p:nvSpPr>
         <p:spPr>
           <a:xfrm>
-            <a:off x="411480" y="45720"/>
-            <a:ext cx="11338560" cy="493776"/>
+            <a:off x="411480" y="36576"/>
+            <a:ext cx="11338560" cy="585216"/>
           </a:xfrm>
           <a:prstGeom prst="rect">
             <a:avLst/>
@@ -4391,7 +4391,7 @@
               <a:buNone/>
             </a:pPr>
             <a:r>
-              <a:rPr lang="ja-JP" altLang="en-US" sz="2600" b="1" dirty="0">
+              <a:rPr lang="ja-JP" altLang="en-US" sz="3200" b="1" dirty="0">
                 <a:solidFill>
                   <a:srgbClr val="1B2430"/>
                 </a:solidFill>
@@ -4401,7 +4401,7 @@
               </a:rPr>
               <a:t>標準拡張</a:t>
             </a:r>
-            <a:endParaRPr lang="ja-JP" sz="2600" dirty="0"/>
+            <a:endParaRPr lang="ja-JP" sz="3200" dirty="0"/>
           </a:p>
         </p:txBody>
       </p:sp>
@@ -4434,7 +4434,7 @@
               <a:buNone/>
             </a:pPr>
             <a:r>
-              <a:rPr lang="ja-JP" altLang="en-US" sz="1800" b="1" dirty="0">
+              <a:rPr lang="ja-JP" altLang="en-US" sz="2200" b="1" dirty="0">
                 <a:solidFill>
                   <a:srgbClr val="FFFFFF"/>
                 </a:solidFill>
@@ -4444,7 +4444,7 @@
               </a:rPr>
               <a:t>ベース I</a:t>
             </a:r>
-            <a:endParaRPr lang="ja-JP" sz="1800" dirty="0"/>
+            <a:endParaRPr lang="ja-JP" sz="2200" dirty="0"/>
           </a:p>
         </p:txBody>
       </p:sp>
@@ -4476,8 +4476,8 @@
         </p:nvSpPr>
         <p:spPr>
           <a:xfrm>
-            <a:off x="3246120" y="1783080"/>
-            <a:ext cx="1554480" cy="502920"/>
+            <a:off x="3063240" y="1783080"/>
+            <a:ext cx="1965960" cy="640080"/>
           </a:xfrm>
           <a:prstGeom prst="rect">
             <a:avLst/>
@@ -4493,7 +4493,7 @@
               <a:buNone/>
             </a:pPr>
             <a:r>
-              <a:rPr lang="ja-JP" altLang="en-US" sz="1400" dirty="0">
+              <a:rPr lang="ja-JP" altLang="en-US" sz="1800" dirty="0">
                 <a:solidFill>
                   <a:srgbClr val="5C6B7A"/>
                 </a:solidFill>
@@ -4503,7 +4503,7 @@
               </a:rPr>
               <a:t>必要なものだけを足す</a:t>
             </a:r>
-            <a:endParaRPr lang="ja-JP" sz="1400" dirty="0"/>
+            <a:endParaRPr lang="ja-JP" sz="1800" dirty="0"/>
           </a:p>
         </p:txBody>
       </p:sp>
@@ -4538,7 +4538,7 @@
               <a:buNone/>
             </a:pPr>
             <a:r>
-              <a:rPr lang="ja-JP" altLang="en-US" sz="1800" b="1" dirty="0">
+              <a:rPr lang="ja-JP" altLang="en-US" sz="2200" b="1" dirty="0">
                 <a:solidFill>
                   <a:srgbClr val="0F9D58"/>
                 </a:solidFill>
@@ -4548,7 +4548,7 @@
               </a:rPr>
               <a:t>M</a:t>
             </a:r>
-            <a:endParaRPr lang="ja-JP" sz="1800" dirty="0"/>
+            <a:endParaRPr lang="ja-JP" sz="2200" dirty="0"/>
           </a:p>
         </p:txBody>
       </p:sp>
@@ -4583,7 +4583,7 @@
               <a:buNone/>
             </a:pPr>
             <a:r>
-              <a:rPr lang="ja-JP" altLang="en-US" sz="1800" b="1" dirty="0">
+              <a:rPr lang="ja-JP" altLang="en-US" sz="2200" b="1" dirty="0">
                 <a:solidFill>
                   <a:srgbClr val="0B6BCB"/>
                 </a:solidFill>
@@ -4593,7 +4593,7 @@
               </a:rPr>
               <a:t>A</a:t>
             </a:r>
-            <a:endParaRPr lang="ja-JP" sz="1800" dirty="0"/>
+            <a:endParaRPr lang="ja-JP" sz="2200" dirty="0"/>
           </a:p>
         </p:txBody>
       </p:sp>
@@ -4628,7 +4628,7 @@
               <a:buNone/>
             </a:pPr>
             <a:r>
-              <a:rPr lang="ja-JP" altLang="en-US" sz="1600" b="1" dirty="0">
+              <a:rPr lang="ja-JP" altLang="en-US" sz="2000" b="1" dirty="0">
                 <a:solidFill>
                   <a:srgbClr val="C97800"/>
                 </a:solidFill>
@@ -4638,7 +4638,7 @@
               </a:rPr>
               <a:t>F/D</a:t>
             </a:r>
-            <a:endParaRPr lang="ja-JP" sz="1600" dirty="0"/>
+            <a:endParaRPr lang="ja-JP" sz="2000" dirty="0"/>
           </a:p>
         </p:txBody>
       </p:sp>
@@ -4673,7 +4673,7 @@
               <a:buNone/>
             </a:pPr>
             <a:r>
-              <a:rPr lang="ja-JP" altLang="en-US" sz="1800" b="1" dirty="0">
+              <a:rPr lang="ja-JP" altLang="en-US" sz="2200" b="1" dirty="0">
                 <a:solidFill>
                   <a:srgbClr val="7C3AED"/>
                 </a:solidFill>
@@ -4683,7 +4683,7 @@
               </a:rPr>
               <a:t>C</a:t>
             </a:r>
-            <a:endParaRPr lang="ja-JP" sz="1800" dirty="0"/>
+            <a:endParaRPr lang="ja-JP" sz="2200" dirty="0"/>
           </a:p>
         </p:txBody>
       </p:sp>
@@ -4718,7 +4718,7 @@
               <a:buNone/>
             </a:pPr>
             <a:r>
-              <a:rPr lang="ja-JP" altLang="en-US" sz="1800" b="1" dirty="0">
+              <a:rPr lang="ja-JP" altLang="en-US" sz="2200" b="1" dirty="0">
                 <a:solidFill>
                   <a:srgbClr val="0B6BCB"/>
                 </a:solidFill>
@@ -4728,7 +4728,7 @@
               </a:rPr>
               <a:t>V</a:t>
             </a:r>
-            <a:endParaRPr lang="ja-JP" sz="1800" dirty="0"/>
+            <a:endParaRPr lang="ja-JP" sz="2200" dirty="0"/>
           </a:p>
         </p:txBody>
       </p:sp>
@@ -4763,7 +4763,7 @@
               <a:buNone/>
             </a:pPr>
             <a:r>
-              <a:rPr lang="ja-JP" altLang="en-US" sz="1600" dirty="0">
+              <a:rPr lang="ja-JP" altLang="en-US" sz="2000" dirty="0">
                 <a:solidFill>
                   <a:srgbClr val="1B2430"/>
                 </a:solidFill>
@@ -4773,14 +4773,14 @@
               </a:rPr>
               <a:t>M  整数の乗算・除算</a:t>
             </a:r>
-            <a:endParaRPr lang="ja-JP" sz="1600" dirty="0"/>
+            <a:endParaRPr lang="ja-JP" sz="2000" dirty="0"/>
           </a:p>
           <a:p>
             <a:pPr algn="l" indent="0" marL="0">
               <a:buNone/>
             </a:pPr>
             <a:r>
-              <a:rPr lang="ja-JP" altLang="en-US" sz="1600" dirty="0">
+              <a:rPr lang="ja-JP" altLang="en-US" sz="2000" dirty="0">
                 <a:solidFill>
                   <a:srgbClr val="1B2430"/>
                 </a:solidFill>
@@ -4790,14 +4790,14 @@
               </a:rPr>
               <a:t>A  アトミック（A 拡張）</a:t>
             </a:r>
-            <a:endParaRPr lang="ja-JP" sz="1600" dirty="0"/>
+            <a:endParaRPr lang="ja-JP" sz="2000" dirty="0"/>
           </a:p>
           <a:p>
             <a:pPr algn="l" indent="0" marL="0">
               <a:buNone/>
             </a:pPr>
             <a:r>
-              <a:rPr lang="ja-JP" altLang="en-US" sz="1600" dirty="0">
+              <a:rPr lang="ja-JP" altLang="en-US" sz="2000" dirty="0">
                 <a:solidFill>
                   <a:srgbClr val="1B2430"/>
                 </a:solidFill>
@@ -4807,14 +4807,14 @@
               </a:rPr>
               <a:t>F  単精度浮動小数点</a:t>
             </a:r>
-            <a:endParaRPr lang="ja-JP" sz="1600" dirty="0"/>
+            <a:endParaRPr lang="ja-JP" sz="2000" dirty="0"/>
           </a:p>
           <a:p>
             <a:pPr algn="l" indent="0" marL="0">
               <a:buNone/>
             </a:pPr>
             <a:r>
-              <a:rPr lang="ja-JP" altLang="en-US" sz="1600" dirty="0">
+              <a:rPr lang="ja-JP" altLang="en-US" sz="2000" dirty="0">
                 <a:solidFill>
                   <a:srgbClr val="1B2430"/>
                 </a:solidFill>
@@ -4824,7 +4824,7 @@
               </a:rPr>
               <a:t>D  倍精度浮動小数点</a:t>
             </a:r>
-            <a:endParaRPr lang="ja-JP" sz="1600" dirty="0"/>
+            <a:endParaRPr lang="ja-JP" sz="2000" dirty="0"/>
           </a:p>
         </p:txBody>
       </p:sp>
@@ -4859,7 +4859,7 @@
               <a:buNone/>
             </a:pPr>
             <a:r>
-              <a:rPr lang="ja-JP" altLang="en-US" sz="1600" dirty="0">
+              <a:rPr lang="ja-JP" altLang="en-US" sz="2000" dirty="0">
                 <a:solidFill>
                   <a:srgbClr val="1B2430"/>
                 </a:solidFill>
@@ -4869,14 +4869,14 @@
               </a:rPr>
               <a:t>C  16 ビット圧縮符号化</a:t>
             </a:r>
-            <a:endParaRPr lang="ja-JP" sz="1600" dirty="0"/>
+            <a:endParaRPr lang="ja-JP" sz="2000" dirty="0"/>
           </a:p>
           <a:p>
             <a:pPr algn="l" indent="0" marL="0">
               <a:buNone/>
             </a:pPr>
             <a:r>
-              <a:rPr lang="ja-JP" altLang="en-US" sz="1600" dirty="0">
+              <a:rPr lang="ja-JP" altLang="en-US" sz="2000" dirty="0">
                 <a:solidFill>
                   <a:srgbClr val="1B2430"/>
                 </a:solidFill>
@@ -4886,14 +4886,14 @@
               </a:rPr>
               <a:t>V  ベクトル（批准済み）</a:t>
             </a:r>
-            <a:endParaRPr lang="ja-JP" sz="1600" dirty="0"/>
+            <a:endParaRPr lang="ja-JP" sz="2000" dirty="0"/>
           </a:p>
           <a:p>
             <a:pPr algn="l" indent="0" marL="0">
               <a:buNone/>
             </a:pPr>
             <a:r>
-              <a:rPr lang="ja-JP" altLang="en-US" sz="1600" dirty="0">
+              <a:rPr lang="ja-JP" altLang="en-US" sz="2000" dirty="0">
                 <a:solidFill>
                   <a:srgbClr val="1B2430"/>
                 </a:solidFill>
@@ -4903,14 +4903,14 @@
               </a:rPr>
               <a:t>Zicsr / Zifencei  など</a:t>
             </a:r>
-            <a:endParaRPr lang="ja-JP" sz="1600" dirty="0"/>
+            <a:endParaRPr lang="ja-JP" sz="2000" dirty="0"/>
           </a:p>
           <a:p>
             <a:pPr algn="l" indent="0" marL="0">
               <a:buNone/>
             </a:pPr>
             <a:r>
-              <a:rPr lang="ja-JP" altLang="en-US" sz="1600" dirty="0">
+              <a:rPr lang="ja-JP" altLang="en-US" sz="2000" dirty="0">
                 <a:solidFill>
                   <a:srgbClr val="1B2430"/>
                 </a:solidFill>
@@ -4920,7 +4920,7 @@
               </a:rPr>
               <a:t>B  ビット操作 ほか</a:t>
             </a:r>
-            <a:endParaRPr lang="ja-JP" sz="1600" dirty="0"/>
+            <a:endParaRPr lang="ja-JP" sz="2000" dirty="0"/>
           </a:p>
         </p:txBody>
       </p:sp>
@@ -4957,7 +4957,7 @@
               <a:buNone/>
             </a:pPr>
             <a:r>
-              <a:rPr lang="ja-JP" altLang="en-US" sz="1600" b="1" dirty="0">
+              <a:rPr lang="ja-JP" altLang="en-US" sz="2000" b="1" dirty="0">
                 <a:solidFill>
                   <a:srgbClr val="1B2430"/>
                 </a:solidFill>
@@ -4967,20 +4967,20 @@
               </a:rPr>
               <a:t>G = IMAFD</a:t>
             </a:r>
-            <a:endParaRPr lang="ja-JP" sz="1600" dirty="0"/>
+            <a:endParaRPr lang="ja-JP" sz="2000" dirty="0"/>
           </a:p>
           <a:p>
             <a:pPr algn="l" indent="0" marL="0">
               <a:buNone/>
             </a:pPr>
-            <a:endParaRPr lang="ja-JP" sz="1600" dirty="0"/>
+            <a:endParaRPr lang="ja-JP" sz="2000" dirty="0"/>
           </a:p>
           <a:p>
             <a:pPr algn="l" indent="0" marL="0">
               <a:buNone/>
             </a:pPr>
             <a:r>
-              <a:rPr lang="ja-JP" altLang="en-US" sz="1600" b="1" dirty="0">
+              <a:rPr lang="ja-JP" altLang="en-US" sz="2000" b="1" dirty="0">
                 <a:solidFill>
                   <a:srgbClr val="1B2430"/>
                 </a:solidFill>
@@ -4990,14 +4990,14 @@
               </a:rPr>
               <a:t>汎用の出発点は</a:t>
             </a:r>
-            <a:endParaRPr lang="ja-JP" sz="1600" dirty="0"/>
+            <a:endParaRPr lang="ja-JP" sz="2000" dirty="0"/>
           </a:p>
           <a:p>
             <a:pPr algn="l" indent="0" marL="0">
               <a:buNone/>
             </a:pPr>
             <a:r>
-              <a:rPr lang="ja-JP" altLang="en-US" sz="1600" b="1" dirty="0">
+              <a:rPr lang="ja-JP" altLang="en-US" sz="2000" b="1" dirty="0">
                 <a:solidFill>
                   <a:srgbClr val="1B2430"/>
                 </a:solidFill>
@@ -5007,14 +5007,14 @@
               </a:rPr>
               <a:t>RV64GC が多い</a:t>
             </a:r>
-            <a:endParaRPr lang="ja-JP" sz="1600" dirty="0"/>
+            <a:endParaRPr lang="ja-JP" sz="2000" dirty="0"/>
           </a:p>
           <a:p>
             <a:pPr algn="l" indent="0" marL="0">
               <a:buNone/>
             </a:pPr>
             <a:r>
-              <a:rPr lang="ja-JP" altLang="en-US" sz="1600" b="1" dirty="0">
+              <a:rPr lang="ja-JP" altLang="en-US" sz="2000" b="1" dirty="0">
                 <a:solidFill>
                   <a:srgbClr val="1B2430"/>
                 </a:solidFill>
@@ -5024,7 +5024,7 @@
               </a:rPr>
               <a:t>（I+MAFD+C）</a:t>
             </a:r>
-            <a:endParaRPr lang="ja-JP" sz="1600" dirty="0"/>
+            <a:endParaRPr lang="ja-JP" sz="2000" dirty="0"/>
           </a:p>
         </p:txBody>
       </p:sp>
@@ -5061,8 +5061,8 @@
         </p:nvSpPr>
         <p:spPr>
           <a:xfrm>
-            <a:off x="9875520" y="6510528"/>
-            <a:ext cx="1920240" cy="347472"/>
+            <a:off x="9875520" y="6419088"/>
+            <a:ext cx="1920240" cy="438912"/>
           </a:xfrm>
           <a:prstGeom prst="rect">
             <a:avLst/>
@@ -5078,7 +5078,7 @@
               <a:buNone/>
             </a:pPr>
             <a:r>
-              <a:rPr lang="ja-JP" altLang="en-US" sz="1400" dirty="0">
+              <a:rPr lang="ja-JP" altLang="en-US" sz="1800" dirty="0">
                 <a:solidFill>
                   <a:srgbClr val="5C6B7A"/>
                 </a:solidFill>
@@ -5088,7 +5088,7 @@
               </a:rPr>
               <a:t>7 / 8</a:t>
             </a:r>
-            <a:endParaRPr lang="ja-JP" sz="1400" dirty="0"/>
+            <a:endParaRPr lang="ja-JP" sz="1800" dirty="0"/>
           </a:p>
         </p:txBody>
       </p:sp>
@@ -5100,8 +5100,8 @@
         </p:nvSpPr>
         <p:spPr>
           <a:xfrm>
-            <a:off x="411480" y="45720"/>
-            <a:ext cx="11338560" cy="493776"/>
+            <a:off x="411480" y="36576"/>
+            <a:ext cx="11338560" cy="585216"/>
           </a:xfrm>
           <a:prstGeom prst="rect">
             <a:avLst/>
@@ -5117,7 +5117,7 @@
               <a:buNone/>
             </a:pPr>
             <a:r>
-              <a:rPr lang="ja-JP" altLang="en-US" sz="2600" b="1" dirty="0">
+              <a:rPr lang="ja-JP" altLang="en-US" sz="3200" b="1" dirty="0">
                 <a:solidFill>
                   <a:srgbClr val="1B2430"/>
                 </a:solidFill>
@@ -5127,7 +5127,7 @@
               </a:rPr>
               <a:t>特権レベル</a:t>
             </a:r>
-            <a:endParaRPr lang="ja-JP" sz="2600" dirty="0"/>
+            <a:endParaRPr lang="ja-JP" sz="3200" dirty="0"/>
           </a:p>
         </p:txBody>
       </p:sp>
@@ -5162,7 +5162,7 @@
               <a:buNone/>
             </a:pPr>
             <a:r>
-              <a:rPr lang="ja-JP" altLang="en-US" sz="1600" b="1" dirty="0">
+              <a:rPr lang="ja-JP" altLang="en-US" sz="2000" b="1" dirty="0">
                 <a:solidFill>
                   <a:srgbClr val="1B2430"/>
                 </a:solidFill>
@@ -5172,7 +5172,7 @@
               </a:rPr>
               <a:t>U-mode    ユーザー（アプリケーション）</a:t>
             </a:r>
-            <a:endParaRPr lang="ja-JP" sz="1600" dirty="0"/>
+            <a:endParaRPr lang="ja-JP" sz="2000" dirty="0"/>
           </a:p>
         </p:txBody>
       </p:sp>
@@ -5227,7 +5227,7 @@
               <a:buNone/>
             </a:pPr>
             <a:r>
-              <a:rPr lang="ja-JP" altLang="en-US" sz="1600" b="1" dirty="0">
+              <a:rPr lang="ja-JP" altLang="en-US" sz="2000" b="1" dirty="0">
                 <a:solidFill>
                   <a:srgbClr val="1B2430"/>
                 </a:solidFill>
@@ -5237,7 +5237,7 @@
               </a:rPr>
               <a:t>S-mode    スーパーバイザ（Linux など）</a:t>
             </a:r>
-            <a:endParaRPr lang="ja-JP" sz="1600" dirty="0"/>
+            <a:endParaRPr lang="ja-JP" sz="2000" dirty="0"/>
           </a:p>
         </p:txBody>
       </p:sp>
@@ -5292,7 +5292,7 @@
               <a:buNone/>
             </a:pPr>
             <a:r>
-              <a:rPr lang="ja-JP" altLang="en-US" sz="1600" b="1" dirty="0">
+              <a:rPr lang="ja-JP" altLang="en-US" sz="2000" b="1" dirty="0">
                 <a:solidFill>
                   <a:srgbClr val="1B2430"/>
                 </a:solidFill>
@@ -5302,7 +5302,7 @@
               </a:rPr>
               <a:t>M-mode    マシン（ファームウェア、必須）</a:t>
             </a:r>
-            <a:endParaRPr lang="ja-JP" sz="1600" dirty="0"/>
+            <a:endParaRPr lang="ja-JP" sz="2000" dirty="0"/>
           </a:p>
         </p:txBody>
       </p:sp>
@@ -5342,7 +5342,7 @@
         <p:spPr>
           <a:xfrm>
             <a:off x="7726680" y="1051560"/>
-            <a:ext cx="3794760" cy="365760"/>
+            <a:ext cx="3794760" cy="457200"/>
           </a:xfrm>
           <a:prstGeom prst="rect">
             <a:avLst/>
@@ -5358,7 +5358,7 @@
               <a:buNone/>
             </a:pPr>
             <a:r>
-              <a:rPr lang="ja-JP" altLang="en-US" sz="1600" b="1" dirty="0">
+              <a:rPr lang="ja-JP" altLang="en-US" sz="2000" b="1" dirty="0">
                 <a:solidFill>
                   <a:srgbClr val="0B6BCB"/>
                 </a:solidFill>
@@ -5368,7 +5368,7 @@
               </a:rPr>
               <a:t>要点</a:t>
             </a:r>
-            <a:endParaRPr lang="ja-JP" sz="1600" dirty="0"/>
+            <a:endParaRPr lang="ja-JP" sz="2000" dirty="0"/>
           </a:p>
         </p:txBody>
       </p:sp>
@@ -5397,7 +5397,7 @@
               <a:buNone/>
             </a:pPr>
             <a:r>
-              <a:rPr lang="ja-JP" altLang="en-US" sz="1600" dirty="0">
+              <a:rPr lang="ja-JP" altLang="en-US" sz="2000" dirty="0">
                 <a:solidFill>
                   <a:srgbClr val="1B2430"/>
                 </a:solidFill>
@@ -5407,20 +5407,20 @@
               </a:rPr>
               <a:t>M-mode はすべての実装に必要です。</a:t>
             </a:r>
-            <a:endParaRPr lang="ja-JP" sz="1600" dirty="0"/>
+            <a:endParaRPr lang="ja-JP" sz="2000" dirty="0"/>
           </a:p>
           <a:p>
             <a:pPr indent="0" marL="0">
               <a:buNone/>
             </a:pPr>
-            <a:endParaRPr lang="ja-JP" sz="1600" dirty="0"/>
+            <a:endParaRPr lang="ja-JP" sz="2000" dirty="0"/>
           </a:p>
           <a:p>
             <a:pPr indent="0" marL="0">
               <a:buNone/>
             </a:pPr>
             <a:r>
-              <a:rPr lang="ja-JP" altLang="en-US" sz="1600" dirty="0">
+              <a:rPr lang="ja-JP" altLang="en-US" sz="2000" dirty="0">
                 <a:solidFill>
                   <a:srgbClr val="1B2430"/>
                 </a:solidFill>
@@ -5430,20 +5430,20 @@
               </a:rPr>
               <a:t>Unix 系 OS は S-mode と U-mode を載せます。</a:t>
             </a:r>
-            <a:endParaRPr lang="ja-JP" sz="1600" dirty="0"/>
+            <a:endParaRPr lang="ja-JP" sz="2000" dirty="0"/>
           </a:p>
           <a:p>
             <a:pPr indent="0" marL="0">
               <a:buNone/>
             </a:pPr>
-            <a:endParaRPr lang="ja-JP" sz="1600" dirty="0"/>
+            <a:endParaRPr lang="ja-JP" sz="2000" dirty="0"/>
           </a:p>
           <a:p>
             <a:pPr indent="0" marL="0">
               <a:buNone/>
             </a:pPr>
             <a:r>
-              <a:rPr lang="ja-JP" altLang="en-US" sz="1600" dirty="0">
+              <a:rPr lang="ja-JP" altLang="en-US" sz="2000" dirty="0">
                 <a:solidFill>
                   <a:srgbClr val="1B2430"/>
                 </a:solidFill>
@@ -5453,20 +5453,20 @@
               </a:rPr>
               <a:t>仮想化は Hypervisor（H）拡張です。</a:t>
             </a:r>
-            <a:endParaRPr lang="ja-JP" sz="1600" dirty="0"/>
+            <a:endParaRPr lang="ja-JP" sz="2000" dirty="0"/>
           </a:p>
           <a:p>
             <a:pPr indent="0" marL="0">
               <a:buNone/>
             </a:pPr>
-            <a:endParaRPr lang="ja-JP" sz="1600" dirty="0"/>
+            <a:endParaRPr lang="ja-JP" sz="2000" dirty="0"/>
           </a:p>
           <a:p>
             <a:pPr indent="0" marL="0">
               <a:buNone/>
             </a:pPr>
             <a:r>
-              <a:rPr lang="ja-JP" altLang="en-US" sz="1600" dirty="0">
+              <a:rPr lang="ja-JP" altLang="en-US" sz="2000" dirty="0">
                 <a:solidFill>
                   <a:srgbClr val="1B2430"/>
                 </a:solidFill>
@@ -5476,7 +5476,7 @@
               </a:rPr>
               <a:t>トラップはより高い特権へ渡り、mret / sret で戻ります。</a:t>
             </a:r>
-            <a:endParaRPr lang="ja-JP" sz="1600" dirty="0"/>
+            <a:endParaRPr lang="ja-JP" sz="2000" dirty="0"/>
           </a:p>
         </p:txBody>
       </p:sp>
@@ -5513,8 +5513,8 @@
         </p:nvSpPr>
         <p:spPr>
           <a:xfrm>
-            <a:off x="9875520" y="6510528"/>
-            <a:ext cx="1920240" cy="347472"/>
+            <a:off x="9875520" y="6419088"/>
+            <a:ext cx="1920240" cy="438912"/>
           </a:xfrm>
           <a:prstGeom prst="rect">
             <a:avLst/>
@@ -5530,7 +5530,7 @@
               <a:buNone/>
             </a:pPr>
             <a:r>
-              <a:rPr lang="ja-JP" altLang="en-US" sz="1400" dirty="0">
+              <a:rPr lang="ja-JP" altLang="en-US" sz="1800" dirty="0">
                 <a:solidFill>
                   <a:srgbClr val="5C6B7A"/>
                 </a:solidFill>
@@ -5540,7 +5540,7 @@
               </a:rPr>
               <a:t>8 / 8</a:t>
             </a:r>
-            <a:endParaRPr lang="ja-JP" sz="1400" dirty="0"/>
+            <a:endParaRPr lang="ja-JP" sz="1800" dirty="0"/>
           </a:p>
         </p:txBody>
       </p:sp>
@@ -5552,8 +5552,8 @@
         </p:nvSpPr>
         <p:spPr>
           <a:xfrm>
-            <a:off x="640080" y="777240"/>
-            <a:ext cx="10789920" cy="640080"/>
+            <a:off x="640080" y="658368"/>
+            <a:ext cx="10789920" cy="777240"/>
           </a:xfrm>
           <a:prstGeom prst="rect">
             <a:avLst/>
@@ -5569,7 +5569,7 @@
               <a:buNone/>
             </a:pPr>
             <a:r>
-              <a:rPr lang="ja-JP" altLang="en-US" sz="3600" b="1" dirty="0">
+              <a:rPr lang="ja-JP" altLang="en-US" sz="4400" b="1" dirty="0">
                 <a:solidFill>
                   <a:srgbClr val="1B2430"/>
                 </a:solidFill>
@@ -5579,7 +5579,7 @@
               </a:rPr>
               <a:t>まとめ</a:t>
             </a:r>
-            <a:endParaRPr lang="ja-JP" sz="3600" dirty="0"/>
+            <a:endParaRPr lang="ja-JP" sz="4400" dirty="0"/>
           </a:p>
         </p:txBody>
       </p:sp>
@@ -5591,7 +5591,7 @@
         </p:nvSpPr>
         <p:spPr>
           <a:xfrm>
-            <a:off x="640080" y="1554480"/>
+            <a:off x="640080" y="1481328"/>
             <a:ext cx="502920" cy="91440"/>
           </a:xfrm>
           <a:prstGeom prst="roundRect">
@@ -5613,12 +5613,12 @@
         </p:nvSpPr>
         <p:spPr>
           <a:xfrm>
-            <a:off x="640080" y="1920240"/>
-            <a:ext cx="10881360" cy="777240"/>
+            <a:off x="640080" y="1783080"/>
+            <a:ext cx="10881360" cy="914400"/>
           </a:xfrm>
           <a:prstGeom prst="roundRect">
             <a:avLst>
-              <a:gd name="adj" fmla="val 9412"/>
+              <a:gd name="adj" fmla="val 8000"/>
             </a:avLst>
           </a:prstGeom>
           <a:solidFill>
@@ -5638,7 +5638,7 @@
               <a:buNone/>
             </a:pPr>
             <a:r>
-              <a:rPr lang="ja-JP" altLang="en-US" sz="1800" dirty="0">
+              <a:rPr lang="ja-JP" altLang="en-US" sz="2200" dirty="0">
                 <a:solidFill>
                   <a:srgbClr val="1B2430"/>
                 </a:solidFill>
@@ -5648,7 +5648,7 @@
               </a:rPr>
               <a:t>オープン標準。仕様にロイヤリティは不要です。</a:t>
             </a:r>
-            <a:endParaRPr lang="ja-JP" sz="1800" dirty="0"/>
+            <a:endParaRPr lang="ja-JP" sz="2200" dirty="0"/>
           </a:p>
         </p:txBody>
       </p:sp>
@@ -5661,11 +5661,11 @@
         <p:spPr>
           <a:xfrm>
             <a:off x="640080" y="2834640"/>
-            <a:ext cx="10881360" cy="777240"/>
+            <a:ext cx="10881360" cy="914400"/>
           </a:xfrm>
           <a:prstGeom prst="roundRect">
             <a:avLst>
-              <a:gd name="adj" fmla="val 9412"/>
+              <a:gd name="adj" fmla="val 8000"/>
             </a:avLst>
           </a:prstGeom>
           <a:solidFill>
@@ -5685,7 +5685,7 @@
               <a:buNone/>
             </a:pPr>
             <a:r>
-              <a:rPr lang="ja-JP" altLang="en-US" sz="1800" dirty="0">
+              <a:rPr lang="ja-JP" altLang="en-US" sz="2200" dirty="0">
                 <a:solidFill>
                   <a:srgbClr val="1B2430"/>
                 </a:solidFill>
@@ -5695,7 +5695,7 @@
               </a:rPr>
               <a:t>ベース ISA を小さく凍結し、機能は M / A / F / D / C / V などの拡張で足します。</a:t>
             </a:r>
-            <a:endParaRPr lang="ja-JP" sz="1800" dirty="0"/>
+            <a:endParaRPr lang="ja-JP" sz="2200" dirty="0"/>
           </a:p>
         </p:txBody>
       </p:sp>
@@ -5707,12 +5707,12 @@
         </p:nvSpPr>
         <p:spPr>
           <a:xfrm>
-            <a:off x="640080" y="3749040"/>
-            <a:ext cx="10881360" cy="777240"/>
+            <a:off x="640080" y="3886200"/>
+            <a:ext cx="10881360" cy="914400"/>
           </a:xfrm>
           <a:prstGeom prst="roundRect">
             <a:avLst>
-              <a:gd name="adj" fmla="val 9412"/>
+              <a:gd name="adj" fmla="val 8000"/>
             </a:avLst>
           </a:prstGeom>
           <a:solidFill>
@@ -5732,7 +5732,7 @@
               <a:buNone/>
             </a:pPr>
             <a:r>
-              <a:rPr lang="ja-JP" altLang="en-US" sz="1800" dirty="0">
+              <a:rPr lang="ja-JP" altLang="en-US" sz="2200" dirty="0">
                 <a:solidFill>
                   <a:srgbClr val="1B2430"/>
                 </a:solidFill>
@@ -5742,7 +5742,7 @@
               </a:rPr>
               <a:t>汎用の出発点は RV64GC。特権は M（必須）に加え、OS 向けに S と U を載せます。</a:t>
             </a:r>
-            <a:endParaRPr lang="ja-JP" sz="1800" dirty="0"/>
+            <a:endParaRPr lang="ja-JP" sz="2200" dirty="0"/>
           </a:p>
         </p:txBody>
       </p:sp>
@@ -5754,8 +5754,8 @@
         </p:nvSpPr>
         <p:spPr>
           <a:xfrm>
-            <a:off x="640080" y="4800600"/>
-            <a:ext cx="10881360" cy="640080"/>
+            <a:off x="640080" y="4937760"/>
+            <a:ext cx="10881360" cy="731520"/>
           </a:xfrm>
           <a:prstGeom prst="rect">
             <a:avLst/>
@@ -5771,7 +5771,7 @@
               <a:buNone/>
             </a:pPr>
             <a:r>
-              <a:rPr lang="ja-JP" altLang="en-US" sz="2600" b="1" dirty="0">
+              <a:rPr lang="ja-JP" altLang="en-US" sz="3200" b="1" dirty="0">
                 <a:solidFill>
                   <a:srgbClr val="0B6BCB"/>
                 </a:solidFill>
@@ -5781,7 +5781,7 @@
               </a:rPr>
               <a:t>ご清聴ありがとうございました</a:t>
             </a:r>
-            <a:endParaRPr lang="ja-JP" sz="2600" dirty="0"/>
+            <a:endParaRPr lang="ja-JP" sz="3200" dirty="0"/>
           </a:p>
         </p:txBody>
       </p:sp>

</xml_diff>

<commit_message>
Add template slots and rebuild the 8-slide RISC-V deck
Template elements with an id deep-merge onto each slide so title and
heading geometry live in the template; chrome without an id stays on
the slide master. Rebuild the sample as the 市場調査くん S1–S8 Japanese
intro plus SHD forecast, with wrap:false on the conclusion one-liner.

Co-authored-by: shotaminato <shotaminato@users.noreply.github.com>
</commit_message>
<xml_diff>
--- a/examples/sample-deck.pptx
+++ b/examples/sample-deck.pptx
@@ -6,9 +6,16 @@
   </p:sldMasterIdLst>
   <p:sldIdLst>
     <p:sldId id="256" r:id="rId2"/>
+    <p:sldId id="257" r:id="rId3"/>
+    <p:sldId id="258" r:id="rId4"/>
+    <p:sldId id="259" r:id="rId5"/>
+    <p:sldId id="260" r:id="rId6"/>
+    <p:sldId id="261" r:id="rId7"/>
+    <p:sldId id="262" r:id="rId8"/>
+    <p:sldId id="263" r:id="rId9"/>
   </p:sldIdLst>
   <p:notesMasterIdLst>
-    <p:notesMasterId r:id="rId3"/>
+    <p:notesMasterId r:id="rId10"/>
   </p:notesMasterIdLst>
   <p:sldSz cx="12191695" cy="6858000"/>
   <p:notesSz cx="6858000" cy="12191695"/>
@@ -502,7 +509,7 @@
           <a:p>
             <a:r>
               <a:rPr lang="en-US" dirty="0"/>
-              <a:t>SHD Group 2026。RISC-V 搭載 SoC の出荷数と売上。2024年まで実績、2025年以降は予測。</a:t>
+              <a:t>表紙。調査日 2026-10-06。基礎レポートと SHD 予測を出典付きでまとめた入門。</a:t>
             </a:r>
             <a:endParaRPr lang="en-US" dirty="0"/>
           </a:p>
@@ -526,6 +533,622 @@
             <a:fld id="{F7021451-1387-4CA6-816F-3879F97B5CBC}" type="slidenum">
               <a:rPr lang="en-US"/>
               <a:t>1</a:t>
+            </a:fld>
+            <a:endParaRPr lang="en-US"/>
+          </a:p>
+        </p:txBody>
+      </p:sp>
+    </p:spTree>
+    <p:extLst>
+      <p:ext uri="{BB962C8B-B14F-4D97-AF65-F5344CB8AC3E}">
+        <p14:creationId xmlns:p14="http://schemas.microsoft.com/office/powerpoint/2010/main" val="1024086991"/>
+      </p:ext>
+    </p:extLst>
+  </p:cSld>
+  <p:clrMapOvr>
+    <a:masterClrMapping/>
+  </p:clrMapOvr>
+</p:notes>
+</file>
+
+<file path=ppt/notesSlides/notesSlide2.xml><?xml version="1.0" encoding="utf-8"?>
+<p:notes xmlns:a="http://schemas.openxmlformats.org/drawingml/2006/main" xmlns:r="http://schemas.openxmlformats.org/officeDocument/2006/relationships" xmlns:p="http://schemas.openxmlformats.org/presentationml/2006/main">
+  <p:cSld>
+    <p:spTree>
+      <p:nvGrpSpPr>
+        <p:cNvPr id="1" name=""/>
+        <p:cNvGrpSpPr/>
+        <p:nvPr/>
+      </p:nvGrpSpPr>
+      <p:grpSpPr>
+        <a:xfrm>
+          <a:off x="0" y="0"/>
+          <a:ext cx="0" cy="0"/>
+          <a:chOff x="0" y="0"/>
+          <a:chExt cx="0" cy="0"/>
+        </a:xfrm>
+      </p:grpSpPr>
+      <p:sp>
+        <p:nvSpPr>
+          <p:cNvPr id="2" name="Slide Image Placeholder 1"/>
+          <p:cNvSpPr>
+            <a:spLocks noGrp="1" noRot="1" noChangeAspect="1"/>
+          </p:cNvSpPr>
+          <p:nvPr>
+            <p:ph type="sldImg"/>
+          </p:nvPr>
+        </p:nvSpPr>
+        <p:spPr/>
+      </p:sp>
+      <p:sp>
+        <p:nvSpPr>
+          <p:cNvPr id="3" name="Notes Placeholder 2"/>
+          <p:cNvSpPr>
+            <a:spLocks noGrp="1"/>
+          </p:cNvSpPr>
+          <p:nvPr>
+            <p:ph type="body" idx="1"/>
+          </p:nvPr>
+        </p:nvSpPr>
+        <p:spPr/>
+        <p:txBody>
+          <a:bodyPr/>
+          <a:lstStyle/>
+          <a:p>
+            <a:r>
+              <a:rPr lang="en-US" dirty="0"/>
+              <a:t>RISC-V はオープンな ISA（仕様）。チップでも会社でもない。実装 IP は別コスト。</a:t>
+            </a:r>
+            <a:endParaRPr lang="en-US" dirty="0"/>
+          </a:p>
+        </p:txBody>
+      </p:sp>
+      <p:sp>
+        <p:nvSpPr>
+          <p:cNvPr id="4" name="Slide Number Placeholder 3"/>
+          <p:cNvSpPr>
+            <a:spLocks noGrp="1"/>
+          </p:cNvSpPr>
+          <p:nvPr>
+            <p:ph type="sldNum" sz="quarter" idx="10"/>
+          </p:nvPr>
+        </p:nvSpPr>
+        <p:spPr/>
+        <p:txBody>
+          <a:bodyPr/>
+          <a:lstStyle/>
+          <a:p>
+            <a:fld id="{F7021451-1387-4CA6-816F-3879F97B5CBC}" type="slidenum">
+              <a:rPr lang="en-US"/>
+              <a:t>2</a:t>
+            </a:fld>
+            <a:endParaRPr lang="en-US"/>
+          </a:p>
+        </p:txBody>
+      </p:sp>
+    </p:spTree>
+    <p:extLst>
+      <p:ext uri="{BB962C8B-B14F-4D97-AF65-F5344CB8AC3E}">
+        <p14:creationId xmlns:p14="http://schemas.microsoft.com/office/powerpoint/2010/main" val="1024086991"/>
+      </p:ext>
+    </p:extLst>
+  </p:cSld>
+  <p:clrMapOvr>
+    <a:masterClrMapping/>
+  </p:clrMapOvr>
+</p:notes>
+</file>
+
+<file path=ppt/notesSlides/notesSlide3.xml><?xml version="1.0" encoding="utf-8"?>
+<p:notes xmlns:a="http://schemas.openxmlformats.org/drawingml/2006/main" xmlns:r="http://schemas.openxmlformats.org/officeDocument/2006/relationships" xmlns:p="http://schemas.openxmlformats.org/presentationml/2006/main">
+  <p:cSld>
+    <p:spTree>
+      <p:nvGrpSpPr>
+        <p:cNvPr id="1" name=""/>
+        <p:cNvGrpSpPr/>
+        <p:nvPr/>
+      </p:nvGrpSpPr>
+      <p:grpSpPr>
+        <a:xfrm>
+          <a:off x="0" y="0"/>
+          <a:ext cx="0" cy="0"/>
+          <a:chOff x="0" y="0"/>
+          <a:chExt cx="0" cy="0"/>
+        </a:xfrm>
+      </p:grpSpPr>
+      <p:sp>
+        <p:nvSpPr>
+          <p:cNvPr id="2" name="Slide Image Placeholder 1"/>
+          <p:cNvSpPr>
+            <a:spLocks noGrp="1" noRot="1" noChangeAspect="1"/>
+          </p:cNvSpPr>
+          <p:nvPr>
+            <p:ph type="sldImg"/>
+          </p:nvPr>
+        </p:nvSpPr>
+        <p:spPr/>
+      </p:sp>
+      <p:sp>
+        <p:nvSpPr>
+          <p:cNvPr id="3" name="Notes Placeholder 2"/>
+          <p:cNvSpPr>
+            <a:spLocks noGrp="1"/>
+          </p:cNvSpPr>
+          <p:nvPr>
+            <p:ph type="body" idx="1"/>
+          </p:nvPr>
+        </p:nvSpPr>
+        <p:spPr/>
+        <p:txBody>
+          <a:bodyPr/>
+          <a:lstStyle/>
+          <a:p>
+            <a:r>
+              <a:rPr lang="en-US" dirty="0"/>
+              <a:t>モジュール方式。RV32/64 の I に拡張を足す。RVA23 は V と H が必須。オープン ISA は無料シリコンではない。</a:t>
+            </a:r>
+            <a:endParaRPr lang="en-US" dirty="0"/>
+          </a:p>
+        </p:txBody>
+      </p:sp>
+      <p:sp>
+        <p:nvSpPr>
+          <p:cNvPr id="4" name="Slide Number Placeholder 3"/>
+          <p:cNvSpPr>
+            <a:spLocks noGrp="1"/>
+          </p:cNvSpPr>
+          <p:nvPr>
+            <p:ph type="sldNum" sz="quarter" idx="10"/>
+          </p:nvPr>
+        </p:nvSpPr>
+        <p:spPr/>
+        <p:txBody>
+          <a:bodyPr/>
+          <a:lstStyle/>
+          <a:p>
+            <a:fld id="{F7021451-1387-4CA6-816F-3879F97B5CBC}" type="slidenum">
+              <a:rPr lang="en-US"/>
+              <a:t>3</a:t>
+            </a:fld>
+            <a:endParaRPr lang="en-US"/>
+          </a:p>
+        </p:txBody>
+      </p:sp>
+    </p:spTree>
+    <p:extLst>
+      <p:ext uri="{BB962C8B-B14F-4D97-AF65-F5344CB8AC3E}">
+        <p14:creationId xmlns:p14="http://schemas.microsoft.com/office/powerpoint/2010/main" val="1024086991"/>
+      </p:ext>
+    </p:extLst>
+  </p:cSld>
+  <p:clrMapOvr>
+    <a:masterClrMapping/>
+  </p:clrMapOvr>
+</p:notes>
+</file>
+
+<file path=ppt/notesSlides/notesSlide4.xml><?xml version="1.0" encoding="utf-8"?>
+<p:notes xmlns:a="http://schemas.openxmlformats.org/drawingml/2006/main" xmlns:r="http://schemas.openxmlformats.org/officeDocument/2006/relationships" xmlns:p="http://schemas.openxmlformats.org/presentationml/2006/main">
+  <p:cSld>
+    <p:spTree>
+      <p:nvGrpSpPr>
+        <p:cNvPr id="1" name=""/>
+        <p:cNvGrpSpPr/>
+        <p:nvPr/>
+      </p:nvGrpSpPr>
+      <p:grpSpPr>
+        <a:xfrm>
+          <a:off x="0" y="0"/>
+          <a:ext cx="0" cy="0"/>
+          <a:chOff x="0" y="0"/>
+          <a:chExt cx="0" cy="0"/>
+        </a:xfrm>
+      </p:grpSpPr>
+      <p:sp>
+        <p:nvSpPr>
+          <p:cNvPr id="2" name="Slide Image Placeholder 1"/>
+          <p:cNvSpPr>
+            <a:spLocks noGrp="1" noRot="1" noChangeAspect="1"/>
+          </p:cNvSpPr>
+          <p:nvPr>
+            <p:ph type="sldImg"/>
+          </p:nvPr>
+        </p:nvSpPr>
+        <p:spPr/>
+      </p:sp>
+      <p:sp>
+        <p:nvSpPr>
+          <p:cNvPr id="3" name="Notes Placeholder 2"/>
+          <p:cNvSpPr>
+            <a:spLocks noGrp="1"/>
+          </p:cNvSpPr>
+          <p:nvPr>
+            <p:ph type="body" idx="1"/>
+          </p:nvPr>
+        </p:nvSpPr>
+        <p:spPr/>
+        <p:txBody>
+          <a:bodyPr/>
+          <a:lstStyle/>
+          <a:p>
+            <a:r>
+              <a:rPr lang="en-US" dirty="0"/>
+              <a:t>2010 年 Berkeley 開始から 2026 年 RVA23 ハードウェア元年までの主要マイルストーン。</a:t>
+            </a:r>
+            <a:endParaRPr lang="en-US" dirty="0"/>
+          </a:p>
+        </p:txBody>
+      </p:sp>
+      <p:sp>
+        <p:nvSpPr>
+          <p:cNvPr id="4" name="Slide Number Placeholder 3"/>
+          <p:cNvSpPr>
+            <a:spLocks noGrp="1"/>
+          </p:cNvSpPr>
+          <p:nvPr>
+            <p:ph type="sldNum" sz="quarter" idx="10"/>
+          </p:nvPr>
+        </p:nvSpPr>
+        <p:spPr/>
+        <p:txBody>
+          <a:bodyPr/>
+          <a:lstStyle/>
+          <a:p>
+            <a:fld id="{F7021451-1387-4CA6-816F-3879F97B5CBC}" type="slidenum">
+              <a:rPr lang="en-US"/>
+              <a:t>4</a:t>
+            </a:fld>
+            <a:endParaRPr lang="en-US"/>
+          </a:p>
+        </p:txBody>
+      </p:sp>
+    </p:spTree>
+    <p:extLst>
+      <p:ext uri="{BB962C8B-B14F-4D97-AF65-F5344CB8AC3E}">
+        <p14:creationId xmlns:p14="http://schemas.microsoft.com/office/powerpoint/2010/main" val="1024086991"/>
+      </p:ext>
+    </p:extLst>
+  </p:cSld>
+  <p:clrMapOvr>
+    <a:masterClrMapping/>
+  </p:clrMapOvr>
+</p:notes>
+</file>
+
+<file path=ppt/notesSlides/notesSlide5.xml><?xml version="1.0" encoding="utf-8"?>
+<p:notes xmlns:a="http://schemas.openxmlformats.org/drawingml/2006/main" xmlns:r="http://schemas.openxmlformats.org/officeDocument/2006/relationships" xmlns:p="http://schemas.openxmlformats.org/presentationml/2006/main">
+  <p:cSld>
+    <p:spTree>
+      <p:nvGrpSpPr>
+        <p:cNvPr id="1" name=""/>
+        <p:cNvGrpSpPr/>
+        <p:nvPr/>
+      </p:nvGrpSpPr>
+      <p:grpSpPr>
+        <a:xfrm>
+          <a:off x="0" y="0"/>
+          <a:ext cx="0" cy="0"/>
+          <a:chOff x="0" y="0"/>
+          <a:chExt cx="0" cy="0"/>
+        </a:xfrm>
+      </p:grpSpPr>
+      <p:sp>
+        <p:nvSpPr>
+          <p:cNvPr id="2" name="Slide Image Placeholder 1"/>
+          <p:cNvSpPr>
+            <a:spLocks noGrp="1" noRot="1" noChangeAspect="1"/>
+          </p:cNvSpPr>
+          <p:nvPr>
+            <p:ph type="sldImg"/>
+          </p:nvPr>
+        </p:nvSpPr>
+        <p:spPr/>
+      </p:sp>
+      <p:sp>
+        <p:nvSpPr>
+          <p:cNvPr id="3" name="Notes Placeholder 2"/>
+          <p:cNvSpPr>
+            <a:spLocks noGrp="1"/>
+          </p:cNvSpPr>
+          <p:nvPr>
+            <p:ph type="body" idx="1"/>
+          </p:nvPr>
+        </p:nvSpPr>
+        <p:spPr/>
+        <p:txBody>
+          <a:bodyPr/>
+          <a:lstStyle/>
+          <a:p>
+            <a:r>
+              <a:rPr lang="en-US" dirty="0"/>
+              <a:t>2026年は RVA23 ハードウェア元年。量産 SoC と OS ベースラインが揃い始めた。サーバーとスマホはまだ弱い。</a:t>
+            </a:r>
+            <a:endParaRPr lang="en-US" dirty="0"/>
+          </a:p>
+        </p:txBody>
+      </p:sp>
+      <p:sp>
+        <p:nvSpPr>
+          <p:cNvPr id="4" name="Slide Number Placeholder 3"/>
+          <p:cNvSpPr>
+            <a:spLocks noGrp="1"/>
+          </p:cNvSpPr>
+          <p:nvPr>
+            <p:ph type="sldNum" sz="quarter" idx="10"/>
+          </p:nvPr>
+        </p:nvSpPr>
+        <p:spPr/>
+        <p:txBody>
+          <a:bodyPr/>
+          <a:lstStyle/>
+          <a:p>
+            <a:fld id="{F7021451-1387-4CA6-816F-3879F97B5CBC}" type="slidenum">
+              <a:rPr lang="en-US"/>
+              <a:t>5</a:t>
+            </a:fld>
+            <a:endParaRPr lang="en-US"/>
+          </a:p>
+        </p:txBody>
+      </p:sp>
+    </p:spTree>
+    <p:extLst>
+      <p:ext uri="{BB962C8B-B14F-4D97-AF65-F5344CB8AC3E}">
+        <p14:creationId xmlns:p14="http://schemas.microsoft.com/office/powerpoint/2010/main" val="1024086991"/>
+      </p:ext>
+    </p:extLst>
+  </p:cSld>
+  <p:clrMapOvr>
+    <a:masterClrMapping/>
+  </p:clrMapOvr>
+</p:notes>
+</file>
+
+<file path=ppt/notesSlides/notesSlide6.xml><?xml version="1.0" encoding="utf-8"?>
+<p:notes xmlns:a="http://schemas.openxmlformats.org/drawingml/2006/main" xmlns:r="http://schemas.openxmlformats.org/officeDocument/2006/relationships" xmlns:p="http://schemas.openxmlformats.org/presentationml/2006/main">
+  <p:cSld>
+    <p:spTree>
+      <p:nvGrpSpPr>
+        <p:cNvPr id="1" name=""/>
+        <p:cNvGrpSpPr/>
+        <p:nvPr/>
+      </p:nvGrpSpPr>
+      <p:grpSpPr>
+        <a:xfrm>
+          <a:off x="0" y="0"/>
+          <a:ext cx="0" cy="0"/>
+          <a:chOff x="0" y="0"/>
+          <a:chExt cx="0" cy="0"/>
+        </a:xfrm>
+      </p:grpSpPr>
+      <p:sp>
+        <p:nvSpPr>
+          <p:cNvPr id="2" name="Slide Image Placeholder 1"/>
+          <p:cNvSpPr>
+            <a:spLocks noGrp="1" noRot="1" noChangeAspect="1"/>
+          </p:cNvSpPr>
+          <p:nvPr>
+            <p:ph type="sldImg"/>
+          </p:nvPr>
+        </p:nvSpPr>
+        <p:spPr/>
+      </p:sp>
+      <p:sp>
+        <p:nvSpPr>
+          <p:cNvPr id="3" name="Notes Placeholder 2"/>
+          <p:cNvSpPr>
+            <a:spLocks noGrp="1"/>
+          </p:cNvSpPr>
+          <p:nvPr>
+            <p:ph type="body" idx="1"/>
+          </p:nvPr>
+        </p:nvSpPr>
+        <p:spPr/>
+        <p:txBody>
+          <a:bodyPr/>
+          <a:lstStyle/>
+          <a:p>
+            <a:r>
+              <a:rPr lang="en-US" dirty="0"/>
+              <a:t>SHD Group 2026年版。出荷数と売上は 2024 年まで実績、2025 年以降は予測。売上は RISC-V を含む SoC 全体の金額。</a:t>
+            </a:r>
+            <a:endParaRPr lang="en-US" dirty="0"/>
+          </a:p>
+        </p:txBody>
+      </p:sp>
+      <p:sp>
+        <p:nvSpPr>
+          <p:cNvPr id="4" name="Slide Number Placeholder 3"/>
+          <p:cNvSpPr>
+            <a:spLocks noGrp="1"/>
+          </p:cNvSpPr>
+          <p:nvPr>
+            <p:ph type="sldNum" sz="quarter" idx="10"/>
+          </p:nvPr>
+        </p:nvSpPr>
+        <p:spPr/>
+        <p:txBody>
+          <a:bodyPr/>
+          <a:lstStyle/>
+          <a:p>
+            <a:fld id="{F7021451-1387-4CA6-816F-3879F97B5CBC}" type="slidenum">
+              <a:rPr lang="en-US"/>
+              <a:t>6</a:t>
+            </a:fld>
+            <a:endParaRPr lang="en-US"/>
+          </a:p>
+        </p:txBody>
+      </p:sp>
+    </p:spTree>
+    <p:extLst>
+      <p:ext uri="{BB962C8B-B14F-4D97-AF65-F5344CB8AC3E}">
+        <p14:creationId xmlns:p14="http://schemas.microsoft.com/office/powerpoint/2010/main" val="1024086991"/>
+      </p:ext>
+    </p:extLst>
+  </p:cSld>
+  <p:clrMapOvr>
+    <a:masterClrMapping/>
+  </p:clrMapOvr>
+</p:notes>
+</file>
+
+<file path=ppt/notesSlides/notesSlide7.xml><?xml version="1.0" encoding="utf-8"?>
+<p:notes xmlns:a="http://schemas.openxmlformats.org/drawingml/2006/main" xmlns:r="http://schemas.openxmlformats.org/officeDocument/2006/relationships" xmlns:p="http://schemas.openxmlformats.org/presentationml/2006/main">
+  <p:cSld>
+    <p:spTree>
+      <p:nvGrpSpPr>
+        <p:cNvPr id="1" name=""/>
+        <p:cNvGrpSpPr/>
+        <p:nvPr/>
+      </p:nvGrpSpPr>
+      <p:grpSpPr>
+        <a:xfrm>
+          <a:off x="0" y="0"/>
+          <a:ext cx="0" cy="0"/>
+          <a:chOff x="0" y="0"/>
+          <a:chExt cx="0" cy="0"/>
+        </a:xfrm>
+      </p:grpSpPr>
+      <p:sp>
+        <p:nvSpPr>
+          <p:cNvPr id="2" name="Slide Image Placeholder 1"/>
+          <p:cNvSpPr>
+            <a:spLocks noGrp="1" noRot="1" noChangeAspect="1"/>
+          </p:cNvSpPr>
+          <p:nvPr>
+            <p:ph type="sldImg"/>
+          </p:nvPr>
+        </p:nvSpPr>
+        <p:spPr/>
+      </p:sp>
+      <p:sp>
+        <p:nvSpPr>
+          <p:cNvPr id="3" name="Notes Placeholder 2"/>
+          <p:cNvSpPr>
+            <a:spLocks noGrp="1"/>
+          </p:cNvSpPr>
+          <p:nvPr>
+            <p:ph type="body" idx="1"/>
+          </p:nvPr>
+        </p:nvSpPr>
+        <p:spPr/>
+        <p:txBody>
+          <a:bodyPr/>
+          <a:lstStyle/>
+          <a:p>
+            <a:r>
+              <a:rPr lang="en-US" dirty="0"/>
+              <a:t>SHD Group Table 32。RISC-V CPU IP 売上。2024年 2.05億ドル、2031年 19.1億ドル、CAGR 39.7%。</a:t>
+            </a:r>
+            <a:endParaRPr lang="en-US" dirty="0"/>
+          </a:p>
+        </p:txBody>
+      </p:sp>
+      <p:sp>
+        <p:nvSpPr>
+          <p:cNvPr id="4" name="Slide Number Placeholder 3"/>
+          <p:cNvSpPr>
+            <a:spLocks noGrp="1"/>
+          </p:cNvSpPr>
+          <p:nvPr>
+            <p:ph type="sldNum" sz="quarter" idx="10"/>
+          </p:nvPr>
+        </p:nvSpPr>
+        <p:spPr/>
+        <p:txBody>
+          <a:bodyPr/>
+          <a:lstStyle/>
+          <a:p>
+            <a:fld id="{F7021451-1387-4CA6-816F-3879F97B5CBC}" type="slidenum">
+              <a:rPr lang="en-US"/>
+              <a:t>7</a:t>
+            </a:fld>
+            <a:endParaRPr lang="en-US"/>
+          </a:p>
+        </p:txBody>
+      </p:sp>
+    </p:spTree>
+    <p:extLst>
+      <p:ext uri="{BB962C8B-B14F-4D97-AF65-F5344CB8AC3E}">
+        <p14:creationId xmlns:p14="http://schemas.microsoft.com/office/powerpoint/2010/main" val="1024086991"/>
+      </p:ext>
+    </p:extLst>
+  </p:cSld>
+  <p:clrMapOvr>
+    <a:masterClrMapping/>
+  </p:clrMapOvr>
+</p:notes>
+</file>
+
+<file path=ppt/notesSlides/notesSlide8.xml><?xml version="1.0" encoding="utf-8"?>
+<p:notes xmlns:a="http://schemas.openxmlformats.org/drawingml/2006/main" xmlns:r="http://schemas.openxmlformats.org/officeDocument/2006/relationships" xmlns:p="http://schemas.openxmlformats.org/presentationml/2006/main">
+  <p:cSld>
+    <p:spTree>
+      <p:nvGrpSpPr>
+        <p:cNvPr id="1" name=""/>
+        <p:cNvGrpSpPr/>
+        <p:nvPr/>
+      </p:nvGrpSpPr>
+      <p:grpSpPr>
+        <a:xfrm>
+          <a:off x="0" y="0"/>
+          <a:ext cx="0" cy="0"/>
+          <a:chOff x="0" y="0"/>
+          <a:chExt cx="0" cy="0"/>
+        </a:xfrm>
+      </p:grpSpPr>
+      <p:sp>
+        <p:nvSpPr>
+          <p:cNvPr id="2" name="Slide Image Placeholder 1"/>
+          <p:cNvSpPr>
+            <a:spLocks noGrp="1" noRot="1" noChangeAspect="1"/>
+          </p:cNvSpPr>
+          <p:nvPr>
+            <p:ph type="sldImg"/>
+          </p:nvPr>
+        </p:nvSpPr>
+        <p:spPr/>
+      </p:sp>
+      <p:sp>
+        <p:nvSpPr>
+          <p:cNvPr id="3" name="Notes Placeholder 2"/>
+          <p:cNvSpPr>
+            <a:spLocks noGrp="1"/>
+          </p:cNvSpPr>
+          <p:nvPr>
+            <p:ph type="body" idx="1"/>
+          </p:nvPr>
+        </p:nvSpPr>
+        <p:spPr/>
+        <p:txBody>
+          <a:bodyPr/>
+          <a:lstStyle/>
+          <a:p>
+            <a:r>
+              <a:rPr lang="en-US" dirty="0"/>
+              <a:t>まとめ。ラベルは付けない。1行のみ wrap:false。</a:t>
+            </a:r>
+            <a:endParaRPr lang="en-US" dirty="0"/>
+          </a:p>
+        </p:txBody>
+      </p:sp>
+      <p:sp>
+        <p:nvSpPr>
+          <p:cNvPr id="4" name="Slide Number Placeholder 3"/>
+          <p:cNvSpPr>
+            <a:spLocks noGrp="1"/>
+          </p:cNvSpPr>
+          <p:nvPr>
+            <p:ph type="sldNum" sz="quarter" idx="10"/>
+          </p:nvPr>
+        </p:nvSpPr>
+        <p:spPr/>
+        <p:txBody>
+          <a:bodyPr/>
+          <a:lstStyle/>
+          <a:p>
+            <a:fld id="{F7021451-1387-4CA6-816F-3879F97B5CBC}" type="slidenum">
+              <a:rPr lang="en-US"/>
+              <a:t>8</a:t>
             </a:fld>
             <a:endParaRPr lang="en-US"/>
           </a:p>
@@ -576,7 +1199,7 @@
 
 <file path=ppt/slideLayouts/slideLayout2.xml><?xml version="1.0" encoding="utf-8"?>
 <p:sldLayout xmlns:a="http://schemas.openxmlformats.org/drawingml/2006/main" xmlns:r="http://schemas.openxmlformats.org/officeDocument/2006/relationships" xmlns:p="http://schemas.openxmlformats.org/presentationml/2006/main" preserve="1">
-  <p:cSld name="default">
+  <p:cSld name="title">
     <p:bg>
       <p:bgPr>
         <a:solidFill>
@@ -606,6 +1229,26 @@
         </p:nvSpPr>
         <p:spPr>
           <a:xfrm>
+            <a:off x="0" y="0"/>
+            <a:ext cx="146304" cy="6858000"/>
+          </a:xfrm>
+          <a:prstGeom prst="rect">
+            <a:avLst/>
+          </a:prstGeom>
+          <a:solidFill>
+            <a:srgbClr val="0B6BCB"/>
+          </a:solidFill>
+          <a:ln/>
+        </p:spPr>
+      </p:sp>
+      <p:sp>
+        <p:nvSpPr>
+          <p:cNvPr id="3" name="Shape 1"/>
+          <p:cNvSpPr/>
+          <p:nvPr/>
+        </p:nvSpPr>
+        <p:spPr>
+          <a:xfrm>
             <a:off x="0" y="6419088"/>
             <a:ext cx="12191695" cy="438912"/>
           </a:xfrm>
@@ -620,14 +1263,14 @@
       </p:sp>
       <p:sp>
         <p:nvSpPr>
-          <p:cNvPr id="3" name="Text 1"/>
-          <p:cNvSpPr/>
-          <p:nvPr/>
-        </p:nvSpPr>
-        <p:spPr>
-          <a:xfrm>
-            <a:off x="292608" y="6419088"/>
-            <a:ext cx="9464040" cy="438912"/>
+          <p:cNvPr id="4" name="Text 2"/>
+          <p:cNvSpPr/>
+          <p:nvPr/>
+        </p:nvSpPr>
+        <p:spPr>
+          <a:xfrm>
+            <a:off x="502920" y="6419088"/>
+            <a:ext cx="9235440" cy="438912"/>
           </a:xfrm>
           <a:prstGeom prst="rect">
             <a:avLst/>
@@ -651,7 +1294,311 @@
                 <a:ea typeface="Yu Gothic UI" pitchFamily="34" charset="-122"/>
                 <a:cs typeface="Yu Gothic UI" pitchFamily="34" charset="-120"/>
               </a:rPr>
-              <a:t>SHD102-26 Abridged, April 2026, Tables 13–14（公開数値から再作図）</a:t>
+              <a:t>調査日 2026-10-06</a:t>
+            </a:r>
+            <a:endParaRPr lang="ja-JP" sz="1600" dirty="0"/>
+          </a:p>
+        </p:txBody>
+      </p:sp>
+      <p:sp>
+        <p:nvSpPr>
+          <p:cNvPr id="5" name="Text 3"/>
+          <p:cNvSpPr/>
+          <p:nvPr/>
+        </p:nvSpPr>
+        <p:spPr>
+          <a:xfrm>
+            <a:off x="640080" y="3429000"/>
+            <a:ext cx="502920" cy="91440"/>
+          </a:xfrm>
+          <a:prstGeom prst="roundRect">
+            <a:avLst>
+              <a:gd name="adj" fmla="val 500000"/>
+            </a:avLst>
+          </a:prstGeom>
+          <a:solidFill>
+            <a:srgbClr val="0B6BCB"/>
+          </a:solidFill>
+          <a:ln/>
+        </p:spPr>
+        <p:txBody>
+          <a:bodyPr wrap="square" lIns="50800" tIns="50800" rIns="50800" bIns="50800" rtlCol="0" anchor="ctr"/>
+          <a:lstStyle/>
+          <a:p>
+            <a:pPr algn="ctr" indent="0" marL="0">
+              <a:buNone/>
+            </a:pPr>
+            <a:endParaRPr lang="ja-JP" dirty="0"/>
+          </a:p>
+        </p:txBody>
+      </p:sp>
+    </p:spTree>
+  </p:cSld>
+  <p:clrMapOvr>
+    <a:masterClrMapping/>
+  </p:clrMapOvr>
+</p:sldLayout>
+</file>
+
+<file path=ppt/slideLayouts/slideLayout3.xml><?xml version="1.0" encoding="utf-8"?>
+<p:sldLayout xmlns:a="http://schemas.openxmlformats.org/drawingml/2006/main" xmlns:r="http://schemas.openxmlformats.org/officeDocument/2006/relationships" xmlns:p="http://schemas.openxmlformats.org/presentationml/2006/main" preserve="1">
+  <p:cSld name="content">
+    <p:bg>
+      <p:bgPr>
+        <a:solidFill>
+          <a:srgbClr val="FFFEFA"/>
+        </a:solidFill>
+      </p:bgPr>
+    </p:bg>
+    <p:spTree>
+      <p:nvGrpSpPr>
+        <p:cNvPr id="1" name=""/>
+        <p:cNvGrpSpPr/>
+        <p:nvPr/>
+      </p:nvGrpSpPr>
+      <p:grpSpPr>
+        <a:xfrm>
+          <a:off x="0" y="0"/>
+          <a:ext cx="0" cy="0"/>
+          <a:chOff x="0" y="0"/>
+          <a:chExt cx="0" cy="0"/>
+        </a:xfrm>
+      </p:grpSpPr>
+      <p:sp>
+        <p:nvSpPr>
+          <p:cNvPr id="2" name="Shape 0"/>
+          <p:cNvSpPr/>
+          <p:nvPr/>
+        </p:nvSpPr>
+        <p:spPr>
+          <a:xfrm>
+            <a:off x="0" y="0"/>
+            <a:ext cx="12191695" cy="658368"/>
+          </a:xfrm>
+          <a:prstGeom prst="rect">
+            <a:avLst/>
+          </a:prstGeom>
+          <a:solidFill>
+            <a:srgbClr val="E8F3FF"/>
+          </a:solidFill>
+          <a:ln/>
+        </p:spPr>
+      </p:sp>
+      <p:sp>
+        <p:nvSpPr>
+          <p:cNvPr id="3" name="Shape 1"/>
+          <p:cNvSpPr/>
+          <p:nvPr/>
+        </p:nvSpPr>
+        <p:spPr>
+          <a:xfrm>
+            <a:off x="0" y="658368"/>
+            <a:ext cx="12191695" cy="50292"/>
+          </a:xfrm>
+          <a:prstGeom prst="rect">
+            <a:avLst/>
+          </a:prstGeom>
+          <a:solidFill>
+            <a:srgbClr val="0B6BCB"/>
+          </a:solidFill>
+          <a:ln/>
+        </p:spPr>
+      </p:sp>
+      <p:sp>
+        <p:nvSpPr>
+          <p:cNvPr id="4" name="Shape 2"/>
+          <p:cNvSpPr/>
+          <p:nvPr/>
+        </p:nvSpPr>
+        <p:spPr>
+          <a:xfrm>
+            <a:off x="0" y="6419088"/>
+            <a:ext cx="12191695" cy="438912"/>
+          </a:xfrm>
+          <a:prstGeom prst="rect">
+            <a:avLst/>
+          </a:prstGeom>
+          <a:solidFill>
+            <a:srgbClr val="F3F1EA"/>
+          </a:solidFill>
+          <a:ln/>
+        </p:spPr>
+      </p:sp>
+      <p:sp>
+        <p:nvSpPr>
+          <p:cNvPr id="5" name="Text 3"/>
+          <p:cNvSpPr/>
+          <p:nvPr/>
+        </p:nvSpPr>
+        <p:spPr>
+          <a:xfrm>
+            <a:off x="411480" y="6419088"/>
+            <a:ext cx="9326880" cy="438912"/>
+          </a:xfrm>
+          <a:prstGeom prst="rect">
+            <a:avLst/>
+          </a:prstGeom>
+          <a:noFill/>
+          <a:ln/>
+        </p:spPr>
+        <p:txBody>
+          <a:bodyPr wrap="none" lIns="0" tIns="0" rIns="0" bIns="0" rtlCol="0" anchor="ctr"/>
+          <a:lstStyle/>
+          <a:p>
+            <a:pPr indent="0" marL="0">
+              <a:buNone/>
+            </a:pPr>
+            <a:r>
+              <a:rPr lang="ja-JP" altLang="en-US" sz="1600" dirty="0">
+                <a:solidFill>
+                  <a:srgbClr val="5C6B7A"/>
+                </a:solidFill>
+                <a:latin typeface="Yu Gothic UI" pitchFamily="34" charset="0"/>
+                <a:ea typeface="Yu Gothic UI" pitchFamily="34" charset="-122"/>
+                <a:cs typeface="Yu Gothic UI" pitchFamily="34" charset="-120"/>
+              </a:rPr>
+              <a:t>RISC-V 入門＆市場動向  ·  2026年10月</a:t>
+            </a:r>
+            <a:endParaRPr lang="ja-JP" sz="1600" dirty="0"/>
+          </a:p>
+        </p:txBody>
+      </p:sp>
+    </p:spTree>
+  </p:cSld>
+  <p:clrMapOvr>
+    <a:masterClrMapping/>
+  </p:clrMapOvr>
+</p:sldLayout>
+</file>
+
+<file path=ppt/slideLayouts/slideLayout4.xml><?xml version="1.0" encoding="utf-8"?>
+<p:sldLayout xmlns:a="http://schemas.openxmlformats.org/drawingml/2006/main" xmlns:r="http://schemas.openxmlformats.org/officeDocument/2006/relationships" xmlns:p="http://schemas.openxmlformats.org/presentationml/2006/main" preserve="1">
+  <p:cSld name="conclusion">
+    <p:bg>
+      <p:bgPr>
+        <a:solidFill>
+          <a:srgbClr val="FFFEFA"/>
+        </a:solidFill>
+      </p:bgPr>
+    </p:bg>
+    <p:spTree>
+      <p:nvGrpSpPr>
+        <p:cNvPr id="1" name=""/>
+        <p:cNvGrpSpPr/>
+        <p:nvPr/>
+      </p:nvGrpSpPr>
+      <p:grpSpPr>
+        <a:xfrm>
+          <a:off x="0" y="0"/>
+          <a:ext cx="0" cy="0"/>
+          <a:chOff x="0" y="0"/>
+          <a:chExt cx="0" cy="0"/>
+        </a:xfrm>
+      </p:grpSpPr>
+      <p:sp>
+        <p:nvSpPr>
+          <p:cNvPr id="2" name="Text 0"/>
+          <p:cNvSpPr/>
+          <p:nvPr/>
+        </p:nvSpPr>
+        <p:spPr>
+          <a:xfrm>
+            <a:off x="10698480" y="-777240"/>
+            <a:ext cx="2377440" cy="2377440"/>
+          </a:xfrm>
+          <a:prstGeom prst="ellipse">
+            <a:avLst/>
+          </a:prstGeom>
+          <a:solidFill>
+            <a:srgbClr val="E8F3FF"/>
+          </a:solidFill>
+          <a:ln/>
+        </p:spPr>
+        <p:txBody>
+          <a:bodyPr wrap="square" lIns="50800" tIns="50800" rIns="50800" bIns="50800" rtlCol="0" anchor="ctr"/>
+          <a:lstStyle/>
+          <a:p>
+            <a:pPr algn="ctr" indent="0" marL="0">
+              <a:buNone/>
+            </a:pPr>
+            <a:endParaRPr lang="ja-JP" dirty="0"/>
+          </a:p>
+        </p:txBody>
+      </p:sp>
+      <p:sp>
+        <p:nvSpPr>
+          <p:cNvPr id="3" name="Shape 1"/>
+          <p:cNvSpPr/>
+          <p:nvPr/>
+        </p:nvSpPr>
+        <p:spPr>
+          <a:xfrm>
+            <a:off x="0" y="6419088"/>
+            <a:ext cx="12191695" cy="438912"/>
+          </a:xfrm>
+          <a:prstGeom prst="rect">
+            <a:avLst/>
+          </a:prstGeom>
+          <a:solidFill>
+            <a:srgbClr val="F3F1EA"/>
+          </a:solidFill>
+          <a:ln/>
+        </p:spPr>
+      </p:sp>
+      <p:sp>
+        <p:nvSpPr>
+          <p:cNvPr id="4" name="Shape 2"/>
+          <p:cNvSpPr/>
+          <p:nvPr/>
+        </p:nvSpPr>
+        <p:spPr>
+          <a:xfrm>
+            <a:off x="0" y="6364224"/>
+            <a:ext cx="12191695" cy="54864"/>
+          </a:xfrm>
+          <a:prstGeom prst="rect">
+            <a:avLst/>
+          </a:prstGeom>
+          <a:solidFill>
+            <a:srgbClr val="0B6BCB"/>
+          </a:solidFill>
+          <a:ln/>
+        </p:spPr>
+      </p:sp>
+      <p:sp>
+        <p:nvSpPr>
+          <p:cNvPr id="5" name="Text 3"/>
+          <p:cNvSpPr/>
+          <p:nvPr/>
+        </p:nvSpPr>
+        <p:spPr>
+          <a:xfrm>
+            <a:off x="411480" y="6419088"/>
+            <a:ext cx="9326880" cy="438912"/>
+          </a:xfrm>
+          <a:prstGeom prst="rect">
+            <a:avLst/>
+          </a:prstGeom>
+          <a:noFill/>
+          <a:ln/>
+        </p:spPr>
+        <p:txBody>
+          <a:bodyPr wrap="none" lIns="0" tIns="0" rIns="0" bIns="0" rtlCol="0" anchor="ctr"/>
+          <a:lstStyle/>
+          <a:p>
+            <a:pPr indent="0" marL="0">
+              <a:buNone/>
+            </a:pPr>
+            <a:r>
+              <a:rPr lang="ja-JP" altLang="en-US" sz="1600" dirty="0">
+                <a:solidFill>
+                  <a:srgbClr val="5C6B7A"/>
+                </a:solidFill>
+                <a:latin typeface="Yu Gothic UI" pitchFamily="34" charset="0"/>
+                <a:ea typeface="Yu Gothic UI" pitchFamily="34" charset="-122"/>
+                <a:cs typeface="Yu Gothic UI" pitchFamily="34" charset="-120"/>
+              </a:rPr>
+              <a:t>RISC-V 入門＆市場動向  ·  2026年10月</a:t>
             </a:r>
             <a:endParaRPr lang="ja-JP" sz="1600" dirty="0"/>
           </a:p>
@@ -688,6 +1635,8 @@
   <p:sldLayoutIdLst>
     <p:sldLayoutId id="2147483649" r:id="rId1"/>
     <p:sldLayoutId id="2147483650" r:id="rId2"/>
+    <p:sldLayoutId id="2147483651" r:id="rId3"/>
+    <p:sldLayoutId id="2147483652" r:id="rId4"/>
   </p:sldLayoutIdLst>
   <p:hf sldNum="0" hdr="0" ftr="0" dt="0"/>
   <p:txStyles>
@@ -978,7 +1927,7 @@
           <a:ln/>
         </p:spPr>
         <p:txBody>
-          <a:bodyPr wrap="square" lIns="0" tIns="0" rIns="0" bIns="0" rtlCol="0" anchor="ctr"/>
+          <a:bodyPr wrap="none" lIns="0" tIns="0" rIns="0" bIns="0" rtlCol="0" anchor="ctr"/>
           <a:lstStyle/>
           <a:p>
             <a:pPr algn="r" indent="0" marL="0">
@@ -993,7 +1942,7 @@
                 <a:ea typeface="Yu Gothic UI" pitchFamily="34" charset="-122"/>
                 <a:cs typeface="Yu Gothic UI" pitchFamily="34" charset="-120"/>
               </a:rPr>
-              <a:t>1 / 1</a:t>
+              <a:t>1 / 8</a:t>
             </a:r>
             <a:endParaRPr lang="ja-JP" sz="1800" dirty="0"/>
           </a:p>
@@ -1001,23 +1950,42 @@
       </p:sp>
       <p:sp>
         <p:nvSpPr>
-          <p:cNvPr id="4" name="Shape 1"/>
-          <p:cNvSpPr/>
-          <p:nvPr/>
-        </p:nvSpPr>
-        <p:spPr>
-          <a:xfrm>
-            <a:off x="292608" y="237744"/>
-            <a:ext cx="82296" cy="384048"/>
+          <p:cNvPr id="4" name="Text 1"/>
+          <p:cNvSpPr/>
+          <p:nvPr/>
+        </p:nvSpPr>
+        <p:spPr>
+          <a:xfrm>
+            <a:off x="640080" y="1965960"/>
+            <a:ext cx="10515600" cy="1097280"/>
           </a:xfrm>
           <a:prstGeom prst="rect">
             <a:avLst/>
           </a:prstGeom>
-          <a:solidFill>
-            <a:srgbClr val="1B365D"/>
-          </a:solidFill>
+          <a:noFill/>
           <a:ln/>
         </p:spPr>
+        <p:txBody>
+          <a:bodyPr wrap="none" lIns="0" tIns="0" rIns="0" bIns="0" rtlCol="0" anchor="ctr"/>
+          <a:lstStyle/>
+          <a:p>
+            <a:pPr indent="0" marL="0">
+              <a:buNone/>
+            </a:pPr>
+            <a:r>
+              <a:rPr lang="ja-JP" altLang="en-US" sz="4000" b="1" dirty="0">
+                <a:solidFill>
+                  <a:srgbClr val="1B2430"/>
+                </a:solidFill>
+                <a:latin typeface="Yu Gothic UI" pitchFamily="34" charset="0"/>
+                <a:ea typeface="Yu Gothic UI" pitchFamily="34" charset="-122"/>
+                <a:cs typeface="Yu Gothic UI" pitchFamily="34" charset="-120"/>
+              </a:rPr>
+              <a:t>RISC-V 入門＆市場動向（2026年10月）</a:t>
+            </a:r>
+            <a:endParaRPr lang="ja-JP" sz="4000" dirty="0"/>
+          </a:p>
+        </p:txBody>
       </p:sp>
       <p:sp>
         <p:nvSpPr>
@@ -1027,8 +1995,8 @@
         </p:nvSpPr>
         <p:spPr>
           <a:xfrm>
-            <a:off x="475488" y="182880"/>
-            <a:ext cx="7498080" cy="475488"/>
+            <a:off x="640080" y="3703320"/>
+            <a:ext cx="10972800" cy="457200"/>
           </a:xfrm>
           <a:prstGeom prst="rect">
             <a:avLst/>
@@ -1044,30 +2012,55 @@
               <a:buNone/>
             </a:pPr>
             <a:r>
-              <a:rPr lang="ja-JP" altLang="en-US" sz="2800" b="1" dirty="0">
-                <a:solidFill>
-                  <a:srgbClr val="1B2430"/>
-                </a:solidFill>
-                <a:latin typeface="Yu Gothic UI" pitchFamily="34" charset="0"/>
-                <a:ea typeface="Yu Gothic UI" pitchFamily="34" charset="-122"/>
-                <a:cs typeface="Yu Gothic UI" pitchFamily="34" charset="-120"/>
-              </a:rPr>
-              <a:t>RISC-V市場予測（SHD Group 2026）</a:t>
-            </a:r>
-            <a:endParaRPr lang="ja-JP" sz="2800" dirty="0"/>
-          </a:p>
-        </p:txBody>
-      </p:sp>
-      <p:sp>
-        <p:nvSpPr>
-          <p:cNvPr id="6" name="Text 3"/>
-          <p:cNvSpPr/>
-          <p:nvPr/>
-        </p:nvSpPr>
-        <p:spPr>
-          <a:xfrm>
-            <a:off x="7818120" y="219456"/>
-            <a:ext cx="4069080" cy="420624"/>
+              <a:rPr lang="ja-JP" altLang="en-US" sz="2200" dirty="0">
+                <a:solidFill>
+                  <a:srgbClr val="0B6BCB"/>
+                </a:solidFill>
+                <a:latin typeface="Yu Gothic UI" pitchFamily="34" charset="0"/>
+                <a:ea typeface="Yu Gothic UI" pitchFamily="34" charset="-122"/>
+                <a:cs typeface="Yu Gothic UI" pitchFamily="34" charset="-120"/>
+              </a:rPr>
+              <a:t>基礎からSHD予測まで／出典付き</a:t>
+            </a:r>
+            <a:endParaRPr lang="ja-JP" sz="2200" dirty="0"/>
+          </a:p>
+        </p:txBody>
+      </p:sp>
+    </p:spTree>
+  </p:cSld>
+  <p:clrMapOvr>
+    <a:masterClrMapping/>
+  </p:clrMapOvr>
+</p:sld>
+</file>
+
+<file path=ppt/slides/slide2.xml><?xml version="1.0" encoding="utf-8"?>
+<p:sld xmlns:a="http://schemas.openxmlformats.org/drawingml/2006/main" xmlns:r="http://schemas.openxmlformats.org/officeDocument/2006/relationships" xmlns:p="http://schemas.openxmlformats.org/presentationml/2006/main">
+  <p:cSld name="Slide 2">
+    <p:spTree>
+      <p:nvGrpSpPr>
+        <p:cNvPr id="1" name=""/>
+        <p:cNvGrpSpPr/>
+        <p:nvPr/>
+      </p:nvGrpSpPr>
+      <p:grpSpPr>
+        <a:xfrm>
+          <a:off x="0" y="0"/>
+          <a:ext cx="0" cy="0"/>
+          <a:chOff x="0" y="0"/>
+          <a:chExt cx="0" cy="0"/>
+        </a:xfrm>
+      </p:grpSpPr>
+      <p:sp>
+        <p:nvSpPr>
+          <p:cNvPr id="3" name="Text 0"/>
+          <p:cNvSpPr/>
+          <p:nvPr/>
+        </p:nvSpPr>
+        <p:spPr>
+          <a:xfrm>
+            <a:off x="9875520" y="6419088"/>
+            <a:ext cx="2011680" cy="438912"/>
           </a:xfrm>
           <a:prstGeom prst="rect">
             <a:avLst/>
@@ -1083,7 +2076,7 @@
               <a:buNone/>
             </a:pPr>
             <a:r>
-              <a:rPr lang="ja-JP" altLang="en-US" sz="1600" dirty="0">
+              <a:rPr lang="ja-JP" altLang="en-US" sz="1800" dirty="0">
                 <a:solidFill>
                   <a:srgbClr val="5C6B7A"/>
                 </a:solidFill>
@@ -1091,15 +2084,310 @@
                 <a:ea typeface="Yu Gothic UI" pitchFamily="34" charset="-122"/>
                 <a:cs typeface="Yu Gothic UI" pitchFamily="34" charset="-120"/>
               </a:rPr>
-              <a:t>2024年まで実績／2025年以降は予測</a:t>
-            </a:r>
-            <a:endParaRPr lang="ja-JP" sz="1600" dirty="0"/>
+              <a:t>2 / 8</a:t>
+            </a:r>
+            <a:endParaRPr lang="ja-JP" sz="1800" dirty="0"/>
+          </a:p>
+        </p:txBody>
+      </p:sp>
+      <p:sp>
+        <p:nvSpPr>
+          <p:cNvPr id="4" name="Text 1"/>
+          <p:cNvSpPr/>
+          <p:nvPr/>
+        </p:nvSpPr>
+        <p:spPr>
+          <a:xfrm>
+            <a:off x="411480" y="36576"/>
+            <a:ext cx="11338560" cy="585216"/>
+          </a:xfrm>
+          <a:prstGeom prst="rect">
+            <a:avLst/>
+          </a:prstGeom>
+          <a:noFill/>
+          <a:ln/>
+        </p:spPr>
+        <p:txBody>
+          <a:bodyPr wrap="none" lIns="0" tIns="0" rIns="0" bIns="0" rtlCol="0" anchor="ctr"/>
+          <a:lstStyle/>
+          <a:p>
+            <a:pPr indent="0" marL="0">
+              <a:buNone/>
+            </a:pPr>
+            <a:r>
+              <a:rPr lang="ja-JP" altLang="en-US" sz="2800" b="1" dirty="0">
+                <a:solidFill>
+                  <a:srgbClr val="1B2430"/>
+                </a:solidFill>
+                <a:latin typeface="Yu Gothic UI" pitchFamily="34" charset="0"/>
+                <a:ea typeface="Yu Gothic UI" pitchFamily="34" charset="-122"/>
+                <a:cs typeface="Yu Gothic UI" pitchFamily="34" charset="-120"/>
+              </a:rPr>
+              <a:t>RISC-Vは「オープンなISA（仕様）」</a:t>
+            </a:r>
+            <a:endParaRPr lang="ja-JP" sz="2800" dirty="0"/>
+          </a:p>
+        </p:txBody>
+      </p:sp>
+      <p:sp>
+        <p:nvSpPr>
+          <p:cNvPr id="5" name="Text 2"/>
+          <p:cNvSpPr/>
+          <p:nvPr/>
+        </p:nvSpPr>
+        <p:spPr>
+          <a:xfrm>
+            <a:off x="365760" y="822960"/>
+            <a:ext cx="5212080" cy="1234440"/>
+          </a:xfrm>
+          <a:prstGeom prst="roundRect">
+            <a:avLst>
+              <a:gd name="adj" fmla="val 7407"/>
+            </a:avLst>
+          </a:prstGeom>
+          <a:solidFill>
+            <a:srgbClr val="FFFFFF"/>
+          </a:solidFill>
+          <a:ln w="13970">
+            <a:solidFill>
+              <a:srgbClr val="C5CDD6"/>
+            </a:solidFill>
+          </a:ln>
+        </p:spPr>
+        <p:txBody>
+          <a:bodyPr wrap="square" lIns="50800" tIns="50800" rIns="50800" bIns="50800" rtlCol="0" anchor="ctr"/>
+          <a:lstStyle/>
+          <a:p>
+            <a:pPr algn="l" indent="0" marL="0">
+              <a:buNone/>
+            </a:pPr>
+            <a:r>
+              <a:rPr lang="ja-JP" altLang="en-US" sz="1800" dirty="0">
+                <a:solidFill>
+                  <a:srgbClr val="1B2430"/>
+                </a:solidFill>
+                <a:latin typeface="Yu Gothic UI" pitchFamily="34" charset="0"/>
+                <a:ea typeface="Yu Gothic UI" pitchFamily="34" charset="-122"/>
+                <a:cs typeface="Yu Gothic UI" pitchFamily="34" charset="-120"/>
+              </a:rPr>
+              <a:t>チップでも会社でもない</a:t>
+            </a:r>
+            <a:endParaRPr lang="ja-JP" sz="1800" dirty="0"/>
+          </a:p>
+          <a:p>
+            <a:pPr algn="l" indent="0" marL="0">
+              <a:buNone/>
+            </a:pPr>
+            <a:r>
+              <a:rPr lang="ja-JP" altLang="en-US" sz="1800" dirty="0">
+                <a:solidFill>
+                  <a:srgbClr val="1B2430"/>
+                </a:solidFill>
+                <a:latin typeface="Yu Gothic UI" pitchFamily="34" charset="0"/>
+                <a:ea typeface="Yu Gothic UI" pitchFamily="34" charset="-122"/>
+                <a:cs typeface="Yu Gothic UI" pitchFamily="34" charset="-120"/>
+              </a:rPr>
+              <a:t>ソフトウェアと CPU の「約束事」。</a:t>
+            </a:r>
+            <a:endParaRPr lang="ja-JP" sz="1800" dirty="0"/>
+          </a:p>
+        </p:txBody>
+      </p:sp>
+      <p:sp>
+        <p:nvSpPr>
+          <p:cNvPr id="6" name="Text 3"/>
+          <p:cNvSpPr/>
+          <p:nvPr/>
+        </p:nvSpPr>
+        <p:spPr>
+          <a:xfrm>
+            <a:off x="365760" y="2176272"/>
+            <a:ext cx="5212080" cy="1234440"/>
+          </a:xfrm>
+          <a:prstGeom prst="roundRect">
+            <a:avLst>
+              <a:gd name="adj" fmla="val 7407"/>
+            </a:avLst>
+          </a:prstGeom>
+          <a:solidFill>
+            <a:srgbClr val="FFFFFF"/>
+          </a:solidFill>
+          <a:ln w="13970">
+            <a:solidFill>
+              <a:srgbClr val="C5CDD6"/>
+            </a:solidFill>
+          </a:ln>
+        </p:spPr>
+        <p:txBody>
+          <a:bodyPr wrap="square" lIns="50800" tIns="50800" rIns="50800" bIns="50800" rtlCol="0" anchor="ctr"/>
+          <a:lstStyle/>
+          <a:p>
+            <a:pPr algn="l" indent="0" marL="0">
+              <a:buNone/>
+            </a:pPr>
+            <a:r>
+              <a:rPr lang="ja-JP" altLang="en-US" sz="1800" dirty="0">
+                <a:solidFill>
+                  <a:srgbClr val="1B2430"/>
+                </a:solidFill>
+                <a:latin typeface="Yu Gothic UI" pitchFamily="34" charset="0"/>
+                <a:ea typeface="Yu Gothic UI" pitchFamily="34" charset="-122"/>
+                <a:cs typeface="Yu Gothic UI" pitchFamily="34" charset="-120"/>
+              </a:rPr>
+              <a:t>仕様はロイヤリティフリー</a:t>
+            </a:r>
+            <a:endParaRPr lang="ja-JP" sz="1800" dirty="0"/>
+          </a:p>
+          <a:p>
+            <a:pPr algn="l" indent="0" marL="0">
+              <a:buNone/>
+            </a:pPr>
+            <a:r>
+              <a:rPr lang="ja-JP" altLang="en-US" sz="1800" dirty="0">
+                <a:solidFill>
+                  <a:srgbClr val="1B2430"/>
+                </a:solidFill>
+                <a:latin typeface="Yu Gothic UI" pitchFamily="34" charset="0"/>
+                <a:ea typeface="Yu Gothic UI" pitchFamily="34" charset="-122"/>
+                <a:cs typeface="Yu Gothic UI" pitchFamily="34" charset="-120"/>
+              </a:rPr>
+              <a:t>実装 IP・検証・製造は別コスト。</a:t>
+            </a:r>
+            <a:endParaRPr lang="ja-JP" sz="1800" dirty="0"/>
+          </a:p>
+        </p:txBody>
+      </p:sp>
+      <p:sp>
+        <p:nvSpPr>
+          <p:cNvPr id="7" name="Text 4"/>
+          <p:cNvSpPr/>
+          <p:nvPr/>
+        </p:nvSpPr>
+        <p:spPr>
+          <a:xfrm>
+            <a:off x="365760" y="3529584"/>
+            <a:ext cx="5212080" cy="1234440"/>
+          </a:xfrm>
+          <a:prstGeom prst="roundRect">
+            <a:avLst>
+              <a:gd name="adj" fmla="val 7407"/>
+            </a:avLst>
+          </a:prstGeom>
+          <a:solidFill>
+            <a:srgbClr val="FFFFFF"/>
+          </a:solidFill>
+          <a:ln w="13970">
+            <a:solidFill>
+              <a:srgbClr val="C5CDD6"/>
+            </a:solidFill>
+          </a:ln>
+        </p:spPr>
+        <p:txBody>
+          <a:bodyPr wrap="square" lIns="50800" tIns="50800" rIns="50800" bIns="50800" rtlCol="0" anchor="ctr"/>
+          <a:lstStyle/>
+          <a:p>
+            <a:pPr algn="l" indent="0" marL="0">
+              <a:buNone/>
+            </a:pPr>
+            <a:r>
+              <a:rPr lang="ja-JP" altLang="en-US" sz="1800" dirty="0">
+                <a:solidFill>
+                  <a:srgbClr val="1B2430"/>
+                </a:solidFill>
+                <a:latin typeface="Yu Gothic UI" pitchFamily="34" charset="0"/>
+                <a:ea typeface="Yu Gothic UI" pitchFamily="34" charset="-122"/>
+                <a:cs typeface="Yu Gothic UI" pitchFamily="34" charset="-120"/>
+              </a:rPr>
+              <a:t>2010 Berkeley → 2020 RVI</a:t>
+            </a:r>
+            <a:endParaRPr lang="ja-JP" sz="1800" dirty="0"/>
+          </a:p>
+          <a:p>
+            <a:pPr algn="l" indent="0" marL="0">
+              <a:buNone/>
+            </a:pPr>
+            <a:r>
+              <a:rPr lang="ja-JP" altLang="en-US" sz="1800" dirty="0">
+                <a:solidFill>
+                  <a:srgbClr val="1B2430"/>
+                </a:solidFill>
+                <a:latin typeface="Yu Gothic UI" pitchFamily="34" charset="0"/>
+                <a:ea typeface="Yu Gothic UI" pitchFamily="34" charset="-122"/>
+                <a:cs typeface="Yu Gothic UI" pitchFamily="34" charset="-120"/>
+              </a:rPr>
+              <a:t>標準団体はチップを作らない。</a:t>
+            </a:r>
+            <a:endParaRPr lang="ja-JP" sz="1800" dirty="0"/>
+          </a:p>
+        </p:txBody>
+      </p:sp>
+      <p:sp>
+        <p:nvSpPr>
+          <p:cNvPr id="8" name="Text 5"/>
+          <p:cNvSpPr/>
+          <p:nvPr/>
+        </p:nvSpPr>
+        <p:spPr>
+          <a:xfrm>
+            <a:off x="365760" y="4882896"/>
+            <a:ext cx="5212080" cy="1234440"/>
+          </a:xfrm>
+          <a:prstGeom prst="roundRect">
+            <a:avLst>
+              <a:gd name="adj" fmla="val 7407"/>
+            </a:avLst>
+          </a:prstGeom>
+          <a:solidFill>
+            <a:srgbClr val="FFFFFF"/>
+          </a:solidFill>
+          <a:ln w="13970">
+            <a:solidFill>
+              <a:srgbClr val="C5CDD6"/>
+            </a:solidFill>
+          </a:ln>
+        </p:spPr>
+        <p:txBody>
+          <a:bodyPr wrap="square" lIns="50800" tIns="50800" rIns="50800" bIns="50800" rtlCol="0" anchor="ctr"/>
+          <a:lstStyle/>
+          <a:p>
+            <a:pPr algn="l" indent="0" marL="0">
+              <a:buNone/>
+            </a:pPr>
+            <a:r>
+              <a:rPr lang="ja-JP" altLang="en-US" sz="1800" dirty="0">
+                <a:solidFill>
+                  <a:srgbClr val="1B2430"/>
+                </a:solidFill>
+                <a:latin typeface="Yu Gothic UI" pitchFamily="34" charset="0"/>
+                <a:ea typeface="Yu Gothic UI" pitchFamily="34" charset="-122"/>
+                <a:cs typeface="Yu Gothic UI" pitchFamily="34" charset="-120"/>
+              </a:rPr>
+              <a:t>強みは自由度。弱みは高性能の実績</a:t>
+            </a:r>
+            <a:endParaRPr lang="ja-JP" sz="1800" dirty="0"/>
+          </a:p>
+          <a:p>
+            <a:pPr algn="l" indent="0" marL="0">
+              <a:buNone/>
+            </a:pPr>
+            <a:r>
+              <a:rPr lang="ja-JP" altLang="en-US" sz="1800" dirty="0">
+                <a:solidFill>
+                  <a:srgbClr val="1B2430"/>
+                </a:solidFill>
+                <a:latin typeface="Yu Gothic UI" pitchFamily="34" charset="0"/>
+                <a:ea typeface="Yu Gothic UI" pitchFamily="34" charset="-122"/>
+                <a:cs typeface="Yu Gothic UI" pitchFamily="34" charset="-120"/>
+              </a:rPr>
+              <a:t>と断片化リスク。</a:t>
+            </a:r>
+            <a:endParaRPr lang="ja-JP" sz="1800" dirty="0"/>
           </a:p>
         </p:txBody>
       </p:sp>
       <p:pic>
         <p:nvPicPr>
-          <p:cNvPr id="7" name="Image 0" descr="RISC-V搭載SoCの出荷数と普及率（2022〜2031）">    </p:cNvPr>
+          <p:cNvPr id="9" name="Image 0" descr="RISC-V と Arm のライセンスモデル比較">    </p:cNvPr>
           <p:cNvPicPr>
             <a:picLocks noChangeAspect="1"/>
           </p:cNvPicPr>
@@ -1112,8 +2400,1377 @@
         </p:blipFill>
         <p:spPr>
           <a:xfrm>
-            <a:off x="256032" y="713232"/>
-            <a:ext cx="5833872" cy="3291840"/>
+            <a:off x="5715000" y="822960"/>
+            <a:ext cx="6126480" cy="5303520"/>
+          </a:xfrm>
+          <a:prstGeom prst="rect">
+            <a:avLst/>
+          </a:prstGeom>
+        </p:spPr>
+      </p:pic>
+    </p:spTree>
+  </p:cSld>
+  <p:clrMapOvr>
+    <a:masterClrMapping/>
+  </p:clrMapOvr>
+</p:sld>
+</file>
+
+<file path=ppt/slides/slide3.xml><?xml version="1.0" encoding="utf-8"?>
+<p:sld xmlns:a="http://schemas.openxmlformats.org/drawingml/2006/main" xmlns:r="http://schemas.openxmlformats.org/officeDocument/2006/relationships" xmlns:p="http://schemas.openxmlformats.org/presentationml/2006/main">
+  <p:cSld name="Slide 3">
+    <p:spTree>
+      <p:nvGrpSpPr>
+        <p:cNvPr id="1" name=""/>
+        <p:cNvGrpSpPr/>
+        <p:nvPr/>
+      </p:nvGrpSpPr>
+      <p:grpSpPr>
+        <a:xfrm>
+          <a:off x="0" y="0"/>
+          <a:ext cx="0" cy="0"/>
+          <a:chOff x="0" y="0"/>
+          <a:chExt cx="0" cy="0"/>
+        </a:xfrm>
+      </p:grpSpPr>
+      <p:sp>
+        <p:nvSpPr>
+          <p:cNvPr id="3" name="Text 0"/>
+          <p:cNvSpPr/>
+          <p:nvPr/>
+        </p:nvSpPr>
+        <p:spPr>
+          <a:xfrm>
+            <a:off x="9875520" y="6419088"/>
+            <a:ext cx="2011680" cy="438912"/>
+          </a:xfrm>
+          <a:prstGeom prst="rect">
+            <a:avLst/>
+          </a:prstGeom>
+          <a:noFill/>
+          <a:ln/>
+        </p:spPr>
+        <p:txBody>
+          <a:bodyPr wrap="none" lIns="0" tIns="0" rIns="0" bIns="0" rtlCol="0" anchor="ctr"/>
+          <a:lstStyle/>
+          <a:p>
+            <a:pPr algn="r" indent="0" marL="0">
+              <a:buNone/>
+            </a:pPr>
+            <a:r>
+              <a:rPr lang="ja-JP" altLang="en-US" sz="1800" dirty="0">
+                <a:solidFill>
+                  <a:srgbClr val="5C6B7A"/>
+                </a:solidFill>
+                <a:latin typeface="Yu Gothic UI" pitchFamily="34" charset="0"/>
+                <a:ea typeface="Yu Gothic UI" pitchFamily="34" charset="-122"/>
+                <a:cs typeface="Yu Gothic UI" pitchFamily="34" charset="-120"/>
+              </a:rPr>
+              <a:t>3 / 8</a:t>
+            </a:r>
+            <a:endParaRPr lang="ja-JP" sz="1800" dirty="0"/>
+          </a:p>
+        </p:txBody>
+      </p:sp>
+      <p:sp>
+        <p:nvSpPr>
+          <p:cNvPr id="4" name="Text 1"/>
+          <p:cNvSpPr/>
+          <p:nvPr/>
+        </p:nvSpPr>
+        <p:spPr>
+          <a:xfrm>
+            <a:off x="411480" y="36576"/>
+            <a:ext cx="11338560" cy="585216"/>
+          </a:xfrm>
+          <a:prstGeom prst="rect">
+            <a:avLst/>
+          </a:prstGeom>
+          <a:noFill/>
+          <a:ln/>
+        </p:spPr>
+        <p:txBody>
+          <a:bodyPr wrap="none" lIns="0" tIns="0" rIns="0" bIns="0" rtlCol="0" anchor="ctr"/>
+          <a:lstStyle/>
+          <a:p>
+            <a:pPr indent="0" marL="0">
+              <a:buNone/>
+            </a:pPr>
+            <a:r>
+              <a:rPr lang="ja-JP" altLang="en-US" sz="2800" b="1" dirty="0">
+                <a:solidFill>
+                  <a:srgbClr val="1B2430"/>
+                </a:solidFill>
+                <a:latin typeface="Yu Gothic UI" pitchFamily="34" charset="0"/>
+                <a:ea typeface="Yu Gothic UI" pitchFamily="34" charset="-122"/>
+                <a:cs typeface="Yu Gothic UI" pitchFamily="34" charset="-120"/>
+              </a:rPr>
+              <a:t>基本ISA＋拡張＋プロファイル</a:t>
+            </a:r>
+            <a:endParaRPr lang="ja-JP" sz="2800" dirty="0"/>
+          </a:p>
+        </p:txBody>
+      </p:sp>
+      <p:sp>
+        <p:nvSpPr>
+          <p:cNvPr id="5" name="Text 2"/>
+          <p:cNvSpPr/>
+          <p:nvPr/>
+        </p:nvSpPr>
+        <p:spPr>
+          <a:xfrm>
+            <a:off x="365760" y="804672"/>
+            <a:ext cx="3703320" cy="1325880"/>
+          </a:xfrm>
+          <a:prstGeom prst="roundRect">
+            <a:avLst>
+              <a:gd name="adj" fmla="val 6897"/>
+            </a:avLst>
+          </a:prstGeom>
+          <a:solidFill>
+            <a:srgbClr val="FFFFFF"/>
+          </a:solidFill>
+          <a:ln w="13970">
+            <a:solidFill>
+              <a:srgbClr val="C5CDD6"/>
+            </a:solidFill>
+          </a:ln>
+        </p:spPr>
+        <p:txBody>
+          <a:bodyPr wrap="square" lIns="50800" tIns="50800" rIns="50800" bIns="50800" rtlCol="0" anchor="ctr"/>
+          <a:lstStyle/>
+          <a:p>
+            <a:pPr algn="ctr" indent="0" marL="0">
+              <a:buNone/>
+            </a:pPr>
+            <a:r>
+              <a:rPr lang="ja-JP" altLang="en-US" sz="1800" dirty="0">
+                <a:solidFill>
+                  <a:srgbClr val="1B2430"/>
+                </a:solidFill>
+                <a:latin typeface="Yu Gothic UI" pitchFamily="34" charset="0"/>
+                <a:ea typeface="Yu Gothic UI" pitchFamily="34" charset="-122"/>
+                <a:cs typeface="Yu Gothic UI" pitchFamily="34" charset="-120"/>
+              </a:rPr>
+              <a:t>RV32/64 の I に</a:t>
+            </a:r>
+            <a:endParaRPr lang="ja-JP" sz="1800" dirty="0"/>
+          </a:p>
+          <a:p>
+            <a:pPr algn="ctr" indent="0" marL="0">
+              <a:buNone/>
+            </a:pPr>
+            <a:r>
+              <a:rPr lang="ja-JP" altLang="en-US" sz="1800" dirty="0">
+                <a:solidFill>
+                  <a:srgbClr val="1B2430"/>
+                </a:solidFill>
+                <a:latin typeface="Yu Gothic UI" pitchFamily="34" charset="0"/>
+                <a:ea typeface="Yu Gothic UI" pitchFamily="34" charset="-122"/>
+                <a:cs typeface="Yu Gothic UI" pitchFamily="34" charset="-120"/>
+              </a:rPr>
+              <a:t>M / A / F / D / C / V を足す</a:t>
+            </a:r>
+            <a:endParaRPr lang="ja-JP" sz="1800" dirty="0"/>
+          </a:p>
+        </p:txBody>
+      </p:sp>
+      <p:sp>
+        <p:nvSpPr>
+          <p:cNvPr id="6" name="Text 3"/>
+          <p:cNvSpPr/>
+          <p:nvPr/>
+        </p:nvSpPr>
+        <p:spPr>
+          <a:xfrm>
+            <a:off x="4206240" y="804672"/>
+            <a:ext cx="3703320" cy="1325880"/>
+          </a:xfrm>
+          <a:prstGeom prst="roundRect">
+            <a:avLst>
+              <a:gd name="adj" fmla="val 6897"/>
+            </a:avLst>
+          </a:prstGeom>
+          <a:solidFill>
+            <a:srgbClr val="FFFFFF"/>
+          </a:solidFill>
+          <a:ln w="13970">
+            <a:solidFill>
+              <a:srgbClr val="C5CDD6"/>
+            </a:solidFill>
+          </a:ln>
+        </p:spPr>
+        <p:txBody>
+          <a:bodyPr wrap="square" lIns="50800" tIns="50800" rIns="50800" bIns="50800" rtlCol="0" anchor="ctr"/>
+          <a:lstStyle/>
+          <a:p>
+            <a:pPr algn="ctr" indent="0" marL="0">
+              <a:buNone/>
+            </a:pPr>
+            <a:r>
+              <a:rPr lang="ja-JP" altLang="en-US" sz="1800" dirty="0">
+                <a:solidFill>
+                  <a:srgbClr val="1B2430"/>
+                </a:solidFill>
+                <a:latin typeface="Yu Gothic UI" pitchFamily="34" charset="0"/>
+                <a:ea typeface="Yu Gothic UI" pitchFamily="34" charset="-122"/>
+                <a:cs typeface="Yu Gothic UI" pitchFamily="34" charset="-120"/>
+              </a:rPr>
+              <a:t>RVA23（2024-10 批准）</a:t>
+            </a:r>
+            <a:endParaRPr lang="ja-JP" sz="1800" dirty="0"/>
+          </a:p>
+          <a:p>
+            <a:pPr algn="ctr" indent="0" marL="0">
+              <a:buNone/>
+            </a:pPr>
+            <a:r>
+              <a:rPr lang="ja-JP" altLang="en-US" sz="1800" dirty="0">
+                <a:solidFill>
+                  <a:srgbClr val="1B2430"/>
+                </a:solidFill>
+                <a:latin typeface="Yu Gothic UI" pitchFamily="34" charset="0"/>
+                <a:ea typeface="Yu Gothic UI" pitchFamily="34" charset="-122"/>
+                <a:cs typeface="Yu Gothic UI" pitchFamily="34" charset="-120"/>
+              </a:rPr>
+              <a:t>V と H が必須</a:t>
+            </a:r>
+            <a:endParaRPr lang="ja-JP" sz="1800" dirty="0"/>
+          </a:p>
+        </p:txBody>
+      </p:sp>
+      <p:sp>
+        <p:nvSpPr>
+          <p:cNvPr id="7" name="Text 4"/>
+          <p:cNvSpPr/>
+          <p:nvPr/>
+        </p:nvSpPr>
+        <p:spPr>
+          <a:xfrm>
+            <a:off x="8046720" y="804672"/>
+            <a:ext cx="3749040" cy="1325880"/>
+          </a:xfrm>
+          <a:prstGeom prst="roundRect">
+            <a:avLst>
+              <a:gd name="adj" fmla="val 6897"/>
+            </a:avLst>
+          </a:prstGeom>
+          <a:solidFill>
+            <a:srgbClr val="FFFFFF"/>
+          </a:solidFill>
+          <a:ln w="13970">
+            <a:solidFill>
+              <a:srgbClr val="C5CDD6"/>
+            </a:solidFill>
+          </a:ln>
+        </p:spPr>
+        <p:txBody>
+          <a:bodyPr wrap="square" lIns="50800" tIns="50800" rIns="50800" bIns="50800" rtlCol="0" anchor="ctr"/>
+          <a:lstStyle/>
+          <a:p>
+            <a:pPr algn="ctr" indent="0" marL="0">
+              <a:buNone/>
+            </a:pPr>
+            <a:r>
+              <a:rPr lang="ja-JP" altLang="en-US" sz="1800" dirty="0">
+                <a:solidFill>
+                  <a:srgbClr val="1B2430"/>
+                </a:solidFill>
+                <a:latin typeface="Yu Gothic UI" pitchFamily="34" charset="0"/>
+                <a:ea typeface="Yu Gothic UI" pitchFamily="34" charset="-122"/>
+                <a:cs typeface="Yu Gothic UI" pitchFamily="34" charset="-120"/>
+              </a:rPr>
+              <a:t>オープンISA ≠ 無償シリコン</a:t>
+            </a:r>
+            <a:endParaRPr lang="ja-JP" sz="1800" dirty="0"/>
+          </a:p>
+          <a:p>
+            <a:pPr algn="ctr" indent="0" marL="0">
+              <a:buNone/>
+            </a:pPr>
+            <a:r>
+              <a:rPr lang="ja-JP" altLang="en-US" sz="1800" dirty="0">
+                <a:solidFill>
+                  <a:srgbClr val="1B2430"/>
+                </a:solidFill>
+                <a:latin typeface="Yu Gothic UI" pitchFamily="34" charset="0"/>
+                <a:ea typeface="Yu Gothic UI" pitchFamily="34" charset="-122"/>
+                <a:cs typeface="Yu Gothic UI" pitchFamily="34" charset="-120"/>
+              </a:rPr>
+              <a:t>コアは IP／OSS／自社設計</a:t>
+            </a:r>
+            <a:endParaRPr lang="ja-JP" sz="1800" dirty="0"/>
+          </a:p>
+        </p:txBody>
+      </p:sp>
+      <p:pic>
+        <p:nvPicPr>
+          <p:cNvPr id="8" name="Image 0" descr="RISC-V ISA の構成。基本命令セット、標準拡張、プロファイル">    </p:cNvPr>
+          <p:cNvPicPr>
+            <a:picLocks noChangeAspect="1"/>
+          </p:cNvPicPr>
+          <p:nvPr/>
+        </p:nvPicPr>
+        <p:blipFill>
+          <a:blip r:embed="rId1"/>
+          <a:srcRect l="0" r="0" t="0" b="0"/>
+          <a:stretch/>
+        </p:blipFill>
+        <p:spPr>
+          <a:xfrm>
+            <a:off x="1280160" y="2240280"/>
+            <a:ext cx="9601200" cy="4023360"/>
+          </a:xfrm>
+          <a:prstGeom prst="rect">
+            <a:avLst/>
+          </a:prstGeom>
+        </p:spPr>
+      </p:pic>
+    </p:spTree>
+  </p:cSld>
+  <p:clrMapOvr>
+    <a:masterClrMapping/>
+  </p:clrMapOvr>
+</p:sld>
+</file>
+
+<file path=ppt/slides/slide4.xml><?xml version="1.0" encoding="utf-8"?>
+<p:sld xmlns:a="http://schemas.openxmlformats.org/drawingml/2006/main" xmlns:r="http://schemas.openxmlformats.org/officeDocument/2006/relationships" xmlns:p="http://schemas.openxmlformats.org/presentationml/2006/main">
+  <p:cSld name="Slide 4">
+    <p:spTree>
+      <p:nvGrpSpPr>
+        <p:cNvPr id="1" name=""/>
+        <p:cNvGrpSpPr/>
+        <p:nvPr/>
+      </p:nvGrpSpPr>
+      <p:grpSpPr>
+        <a:xfrm>
+          <a:off x="0" y="0"/>
+          <a:ext cx="0" cy="0"/>
+          <a:chOff x="0" y="0"/>
+          <a:chExt cx="0" cy="0"/>
+        </a:xfrm>
+      </p:grpSpPr>
+      <p:sp>
+        <p:nvSpPr>
+          <p:cNvPr id="3" name="Text 0"/>
+          <p:cNvSpPr/>
+          <p:nvPr/>
+        </p:nvSpPr>
+        <p:spPr>
+          <a:xfrm>
+            <a:off x="9875520" y="6419088"/>
+            <a:ext cx="2011680" cy="438912"/>
+          </a:xfrm>
+          <a:prstGeom prst="rect">
+            <a:avLst/>
+          </a:prstGeom>
+          <a:noFill/>
+          <a:ln/>
+        </p:spPr>
+        <p:txBody>
+          <a:bodyPr wrap="none" lIns="0" tIns="0" rIns="0" bIns="0" rtlCol="0" anchor="ctr"/>
+          <a:lstStyle/>
+          <a:p>
+            <a:pPr algn="r" indent="0" marL="0">
+              <a:buNone/>
+            </a:pPr>
+            <a:r>
+              <a:rPr lang="ja-JP" altLang="en-US" sz="1800" dirty="0">
+                <a:solidFill>
+                  <a:srgbClr val="5C6B7A"/>
+                </a:solidFill>
+                <a:latin typeface="Yu Gothic UI" pitchFamily="34" charset="0"/>
+                <a:ea typeface="Yu Gothic UI" pitchFamily="34" charset="-122"/>
+                <a:cs typeface="Yu Gothic UI" pitchFamily="34" charset="-120"/>
+              </a:rPr>
+              <a:t>4 / 8</a:t>
+            </a:r>
+            <a:endParaRPr lang="ja-JP" sz="1800" dirty="0"/>
+          </a:p>
+        </p:txBody>
+      </p:sp>
+      <p:sp>
+        <p:nvSpPr>
+          <p:cNvPr id="4" name="Text 1"/>
+          <p:cNvSpPr/>
+          <p:nvPr/>
+        </p:nvSpPr>
+        <p:spPr>
+          <a:xfrm>
+            <a:off x="411480" y="36576"/>
+            <a:ext cx="11338560" cy="585216"/>
+          </a:xfrm>
+          <a:prstGeom prst="rect">
+            <a:avLst/>
+          </a:prstGeom>
+          <a:noFill/>
+          <a:ln/>
+        </p:spPr>
+        <p:txBody>
+          <a:bodyPr wrap="none" lIns="0" tIns="0" rIns="0" bIns="0" rtlCol="0" anchor="ctr"/>
+          <a:lstStyle/>
+          <a:p>
+            <a:pPr indent="0" marL="0">
+              <a:buNone/>
+            </a:pPr>
+            <a:r>
+              <a:rPr lang="ja-JP" altLang="en-US" sz="2800" b="1" dirty="0">
+                <a:solidFill>
+                  <a:srgbClr val="1B2430"/>
+                </a:solidFill>
+                <a:latin typeface="Yu Gothic UI" pitchFamily="34" charset="0"/>
+                <a:ea typeface="Yu Gothic UI" pitchFamily="34" charset="-122"/>
+                <a:cs typeface="Yu Gothic UI" pitchFamily="34" charset="-120"/>
+              </a:rPr>
+              <a:t>2010→2026 マイルストーン</a:t>
+            </a:r>
+            <a:endParaRPr lang="ja-JP" sz="2800" dirty="0"/>
+          </a:p>
+        </p:txBody>
+      </p:sp>
+      <p:sp>
+        <p:nvSpPr>
+          <p:cNvPr id="5" name="Text 2"/>
+          <p:cNvSpPr/>
+          <p:nvPr/>
+        </p:nvSpPr>
+        <p:spPr>
+          <a:xfrm>
+            <a:off x="365760" y="786384"/>
+            <a:ext cx="3703320" cy="777240"/>
+          </a:xfrm>
+          <a:prstGeom prst="roundRect">
+            <a:avLst>
+              <a:gd name="adj" fmla="val 11765"/>
+            </a:avLst>
+          </a:prstGeom>
+          <a:solidFill>
+            <a:srgbClr val="FFFFFF"/>
+          </a:solidFill>
+          <a:ln w="13970">
+            <a:solidFill>
+              <a:srgbClr val="C5CDD6"/>
+            </a:solidFill>
+          </a:ln>
+        </p:spPr>
+        <p:txBody>
+          <a:bodyPr wrap="none" lIns="50800" tIns="50800" rIns="50800" bIns="50800" rtlCol="0" anchor="ctr"/>
+          <a:lstStyle/>
+          <a:p>
+            <a:pPr algn="ctr" indent="0" marL="0">
+              <a:buNone/>
+            </a:pPr>
+            <a:r>
+              <a:rPr lang="ja-JP" altLang="en-US" sz="1600" dirty="0">
+                <a:solidFill>
+                  <a:srgbClr val="1B2430"/>
+                </a:solidFill>
+                <a:latin typeface="Yu Gothic UI" pitchFamily="34" charset="0"/>
+                <a:ea typeface="Yu Gothic UI" pitchFamily="34" charset="-122"/>
+                <a:cs typeface="Yu Gothic UI" pitchFamily="34" charset="-120"/>
+              </a:rPr>
+              <a:t>2010 Berkeley ／ 2015 Foundation</a:t>
+            </a:r>
+            <a:endParaRPr lang="ja-JP" sz="1600" dirty="0"/>
+          </a:p>
+        </p:txBody>
+      </p:sp>
+      <p:sp>
+        <p:nvSpPr>
+          <p:cNvPr id="6" name="Text 3"/>
+          <p:cNvSpPr/>
+          <p:nvPr/>
+        </p:nvSpPr>
+        <p:spPr>
+          <a:xfrm>
+            <a:off x="4206240" y="786384"/>
+            <a:ext cx="3703320" cy="777240"/>
+          </a:xfrm>
+          <a:prstGeom prst="roundRect">
+            <a:avLst>
+              <a:gd name="adj" fmla="val 11765"/>
+            </a:avLst>
+          </a:prstGeom>
+          <a:solidFill>
+            <a:srgbClr val="FFFFFF"/>
+          </a:solidFill>
+          <a:ln w="13970">
+            <a:solidFill>
+              <a:srgbClr val="C5CDD6"/>
+            </a:solidFill>
+          </a:ln>
+        </p:spPr>
+        <p:txBody>
+          <a:bodyPr wrap="none" lIns="50800" tIns="50800" rIns="50800" bIns="50800" rtlCol="0" anchor="ctr"/>
+          <a:lstStyle/>
+          <a:p>
+            <a:pPr algn="ctr" indent="0" marL="0">
+              <a:buNone/>
+            </a:pPr>
+            <a:r>
+              <a:rPr lang="ja-JP" altLang="en-US" sz="1600" dirty="0">
+                <a:solidFill>
+                  <a:srgbClr val="1B2430"/>
+                </a:solidFill>
+                <a:latin typeface="Yu Gothic UI" pitchFamily="34" charset="0"/>
+                <a:ea typeface="Yu Gothic UI" pitchFamily="34" charset="-122"/>
+                <a:cs typeface="Yu Gothic UI" pitchFamily="34" charset="-120"/>
+              </a:rPr>
+              <a:t>2020 RVI ／ 2024 RVA23 批准</a:t>
+            </a:r>
+            <a:endParaRPr lang="ja-JP" sz="1600" dirty="0"/>
+          </a:p>
+        </p:txBody>
+      </p:sp>
+      <p:sp>
+        <p:nvSpPr>
+          <p:cNvPr id="7" name="Text 4"/>
+          <p:cNvSpPr/>
+          <p:nvPr/>
+        </p:nvSpPr>
+        <p:spPr>
+          <a:xfrm>
+            <a:off x="8046720" y="786384"/>
+            <a:ext cx="3749040" cy="777240"/>
+          </a:xfrm>
+          <a:prstGeom prst="roundRect">
+            <a:avLst>
+              <a:gd name="adj" fmla="val 11765"/>
+            </a:avLst>
+          </a:prstGeom>
+          <a:solidFill>
+            <a:srgbClr val="FFFFFF"/>
+          </a:solidFill>
+          <a:ln w="13970">
+            <a:solidFill>
+              <a:srgbClr val="C5CDD6"/>
+            </a:solidFill>
+          </a:ln>
+        </p:spPr>
+        <p:txBody>
+          <a:bodyPr wrap="none" lIns="50800" tIns="50800" rIns="50800" bIns="50800" rtlCol="0" anchor="ctr"/>
+          <a:lstStyle/>
+          <a:p>
+            <a:pPr algn="ctr" indent="0" marL="0">
+              <a:buNone/>
+            </a:pPr>
+            <a:r>
+              <a:rPr lang="ja-JP" altLang="en-US" sz="1600" dirty="0">
+                <a:solidFill>
+                  <a:srgbClr val="1B2430"/>
+                </a:solidFill>
+                <a:latin typeface="Yu Gothic UI" pitchFamily="34" charset="0"/>
+                <a:ea typeface="Yu Gothic UI" pitchFamily="34" charset="-122"/>
+                <a:cs typeface="Yu Gothic UI" pitchFamily="34" charset="-120"/>
+              </a:rPr>
+              <a:t>2026 K3 出荷・Ubuntu 26.04 LTS</a:t>
+            </a:r>
+            <a:endParaRPr lang="ja-JP" sz="1600" dirty="0"/>
+          </a:p>
+        </p:txBody>
+      </p:sp>
+      <p:pic>
+        <p:nvPicPr>
+          <p:cNvPr id="8" name="Image 0" descr="RISC-V 年表（2010→2026）">    </p:cNvPr>
+          <p:cNvPicPr>
+            <a:picLocks noChangeAspect="1"/>
+          </p:cNvPicPr>
+          <p:nvPr/>
+        </p:nvPicPr>
+        <p:blipFill>
+          <a:blip r:embed="rId1"/>
+          <a:srcRect l="0" r="0" t="0" b="0"/>
+          <a:stretch/>
+        </p:blipFill>
+        <p:spPr>
+          <a:xfrm>
+            <a:off x="365760" y="1691640"/>
+            <a:ext cx="11430000" cy="4572000"/>
+          </a:xfrm>
+          <a:prstGeom prst="rect">
+            <a:avLst/>
+          </a:prstGeom>
+        </p:spPr>
+      </p:pic>
+    </p:spTree>
+  </p:cSld>
+  <p:clrMapOvr>
+    <a:masterClrMapping/>
+  </p:clrMapOvr>
+</p:sld>
+</file>
+
+<file path=ppt/slides/slide5.xml><?xml version="1.0" encoding="utf-8"?>
+<p:sld xmlns:a="http://schemas.openxmlformats.org/drawingml/2006/main" xmlns:r="http://schemas.openxmlformats.org/officeDocument/2006/relationships" xmlns:p="http://schemas.openxmlformats.org/presentationml/2006/main">
+  <p:cSld name="Slide 5">
+    <p:spTree>
+      <p:nvGrpSpPr>
+        <p:cNvPr id="1" name=""/>
+        <p:cNvGrpSpPr/>
+        <p:nvPr/>
+      </p:nvGrpSpPr>
+      <p:grpSpPr>
+        <a:xfrm>
+          <a:off x="0" y="0"/>
+          <a:ext cx="0" cy="0"/>
+          <a:chOff x="0" y="0"/>
+          <a:chExt cx="0" cy="0"/>
+        </a:xfrm>
+      </p:grpSpPr>
+      <p:sp>
+        <p:nvSpPr>
+          <p:cNvPr id="3" name="Text 0"/>
+          <p:cNvSpPr/>
+          <p:nvPr/>
+        </p:nvSpPr>
+        <p:spPr>
+          <a:xfrm>
+            <a:off x="9875520" y="6419088"/>
+            <a:ext cx="2011680" cy="438912"/>
+          </a:xfrm>
+          <a:prstGeom prst="rect">
+            <a:avLst/>
+          </a:prstGeom>
+          <a:noFill/>
+          <a:ln/>
+        </p:spPr>
+        <p:txBody>
+          <a:bodyPr wrap="none" lIns="0" tIns="0" rIns="0" bIns="0" rtlCol="0" anchor="ctr"/>
+          <a:lstStyle/>
+          <a:p>
+            <a:pPr algn="r" indent="0" marL="0">
+              <a:buNone/>
+            </a:pPr>
+            <a:r>
+              <a:rPr lang="ja-JP" altLang="en-US" sz="1800" dirty="0">
+                <a:solidFill>
+                  <a:srgbClr val="5C6B7A"/>
+                </a:solidFill>
+                <a:latin typeface="Yu Gothic UI" pitchFamily="34" charset="0"/>
+                <a:ea typeface="Yu Gothic UI" pitchFamily="34" charset="-122"/>
+                <a:cs typeface="Yu Gothic UI" pitchFamily="34" charset="-120"/>
+              </a:rPr>
+              <a:t>5 / 8</a:t>
+            </a:r>
+            <a:endParaRPr lang="ja-JP" sz="1800" dirty="0"/>
+          </a:p>
+        </p:txBody>
+      </p:sp>
+      <p:sp>
+        <p:nvSpPr>
+          <p:cNvPr id="4" name="Text 1"/>
+          <p:cNvSpPr/>
+          <p:nvPr/>
+        </p:nvSpPr>
+        <p:spPr>
+          <a:xfrm>
+            <a:off x="411480" y="36576"/>
+            <a:ext cx="11338560" cy="585216"/>
+          </a:xfrm>
+          <a:prstGeom prst="rect">
+            <a:avLst/>
+          </a:prstGeom>
+          <a:noFill/>
+          <a:ln/>
+        </p:spPr>
+        <p:txBody>
+          <a:bodyPr wrap="none" lIns="0" tIns="0" rIns="0" bIns="0" rtlCol="0" anchor="ctr"/>
+          <a:lstStyle/>
+          <a:p>
+            <a:pPr indent="0" marL="0">
+              <a:buNone/>
+            </a:pPr>
+            <a:r>
+              <a:rPr lang="ja-JP" altLang="en-US" sz="2800" b="1" dirty="0">
+                <a:solidFill>
+                  <a:srgbClr val="1B2430"/>
+                </a:solidFill>
+                <a:latin typeface="Yu Gothic UI" pitchFamily="34" charset="0"/>
+                <a:ea typeface="Yu Gothic UI" pitchFamily="34" charset="-122"/>
+                <a:cs typeface="Yu Gothic UI" pitchFamily="34" charset="-120"/>
+              </a:rPr>
+              <a:t>2026年＝RVA23ハードウェア元年</a:t>
+            </a:r>
+            <a:endParaRPr lang="ja-JP" sz="2800" dirty="0"/>
+          </a:p>
+        </p:txBody>
+      </p:sp>
+      <p:sp>
+        <p:nvSpPr>
+          <p:cNvPr id="5" name="Text 2"/>
+          <p:cNvSpPr/>
+          <p:nvPr/>
+        </p:nvSpPr>
+        <p:spPr>
+          <a:xfrm>
+            <a:off x="365760" y="868680"/>
+            <a:ext cx="5623560" cy="2468880"/>
+          </a:xfrm>
+          <a:prstGeom prst="roundRect">
+            <a:avLst>
+              <a:gd name="adj" fmla="val 4444"/>
+            </a:avLst>
+          </a:prstGeom>
+          <a:solidFill>
+            <a:srgbClr val="FFFFFF"/>
+          </a:solidFill>
+          <a:ln w="13970">
+            <a:solidFill>
+              <a:srgbClr val="C5CDD6"/>
+            </a:solidFill>
+          </a:ln>
+        </p:spPr>
+        <p:txBody>
+          <a:bodyPr wrap="square" lIns="50800" tIns="50800" rIns="50800" bIns="50800" rtlCol="0" anchor="ctr"/>
+          <a:lstStyle/>
+          <a:p>
+            <a:pPr algn="l" indent="0" marL="0">
+              <a:buNone/>
+            </a:pPr>
+            <a:r>
+              <a:rPr lang="ja-JP" altLang="en-US" sz="1800" dirty="0">
+                <a:solidFill>
+                  <a:srgbClr val="1B2430"/>
+                </a:solidFill>
+                <a:latin typeface="Yu Gothic UI" pitchFamily="34" charset="0"/>
+                <a:ea typeface="Yu Gothic UI" pitchFamily="34" charset="-122"/>
+                <a:cs typeface="Yu Gothic UI" pitchFamily="34" charset="-120"/>
+              </a:rPr>
+              <a:t>量産 RVA23 SoC</a:t>
+            </a:r>
+            <a:endParaRPr lang="ja-JP" sz="1800" dirty="0"/>
+          </a:p>
+          <a:p>
+            <a:pPr algn="l" indent="0" marL="0">
+              <a:buNone/>
+            </a:pPr>
+            <a:r>
+              <a:rPr lang="ja-JP" altLang="en-US" sz="1800" dirty="0">
+                <a:solidFill>
+                  <a:srgbClr val="1B2430"/>
+                </a:solidFill>
+                <a:latin typeface="Yu Gothic UI" pitchFamily="34" charset="0"/>
+                <a:ea typeface="Yu Gothic UI" pitchFamily="34" charset="-122"/>
+                <a:cs typeface="Yu Gothic UI" pitchFamily="34" charset="-120"/>
+              </a:rPr>
+              <a:t>SpacemiT K3 が出荷（2026-04）。</a:t>
+            </a:r>
+            <a:endParaRPr lang="ja-JP" sz="1800" dirty="0"/>
+          </a:p>
+          <a:p>
+            <a:pPr algn="l" indent="0" marL="0">
+              <a:buNone/>
+            </a:pPr>
+            <a:r>
+              <a:rPr lang="ja-JP" altLang="en-US" sz="1800" dirty="0">
+                <a:solidFill>
+                  <a:srgbClr val="1B2430"/>
+                </a:solidFill>
+                <a:latin typeface="Yu Gothic UI" pitchFamily="34" charset="0"/>
+                <a:ea typeface="Yu Gothic UI" pitchFamily="34" charset="-122"/>
+                <a:cs typeface="Yu Gothic UI" pitchFamily="34" charset="-120"/>
+              </a:rPr>
+              <a:t>Ubuntu 26.04 LTS が RVA23 を必須ベースラインにした初の主要 LTS。</a:t>
+            </a:r>
+            <a:endParaRPr lang="ja-JP" sz="1800" dirty="0"/>
+          </a:p>
+        </p:txBody>
+      </p:sp>
+      <p:sp>
+        <p:nvSpPr>
+          <p:cNvPr id="6" name="Text 3"/>
+          <p:cNvSpPr/>
+          <p:nvPr/>
+        </p:nvSpPr>
+        <p:spPr>
+          <a:xfrm>
+            <a:off x="6172200" y="868680"/>
+            <a:ext cx="5623560" cy="2468880"/>
+          </a:xfrm>
+          <a:prstGeom prst="roundRect">
+            <a:avLst>
+              <a:gd name="adj" fmla="val 4444"/>
+            </a:avLst>
+          </a:prstGeom>
+          <a:solidFill>
+            <a:srgbClr val="FFFFFF"/>
+          </a:solidFill>
+          <a:ln w="13970">
+            <a:solidFill>
+              <a:srgbClr val="C5CDD6"/>
+            </a:solidFill>
+          </a:ln>
+        </p:spPr>
+        <p:txBody>
+          <a:bodyPr wrap="square" lIns="50800" tIns="50800" rIns="50800" bIns="50800" rtlCol="0" anchor="ctr"/>
+          <a:lstStyle/>
+          <a:p>
+            <a:pPr algn="l" indent="0" marL="0">
+              <a:buNone/>
+            </a:pPr>
+            <a:r>
+              <a:rPr lang="ja-JP" altLang="en-US" sz="1800" dirty="0">
+                <a:solidFill>
+                  <a:srgbClr val="1B2430"/>
+                </a:solidFill>
+                <a:latin typeface="Yu Gothic UI" pitchFamily="34" charset="0"/>
+                <a:ea typeface="Yu Gothic UI" pitchFamily="34" charset="-122"/>
+                <a:cs typeface="Yu Gothic UI" pitchFamily="34" charset="-120"/>
+              </a:rPr>
+              <a:t>CUDA on RISC-V</a:t>
+            </a:r>
+            <a:endParaRPr lang="ja-JP" sz="1800" dirty="0"/>
+          </a:p>
+          <a:p>
+            <a:pPr algn="l" indent="0" marL="0">
+              <a:buNone/>
+            </a:pPr>
+            <a:r>
+              <a:rPr lang="ja-JP" altLang="en-US" sz="1800" dirty="0">
+                <a:solidFill>
+                  <a:srgbClr val="1B2430"/>
+                </a:solidFill>
+                <a:latin typeface="Yu Gothic UI" pitchFamily="34" charset="0"/>
+                <a:ea typeface="Yu Gothic UI" pitchFamily="34" charset="-122"/>
+                <a:cs typeface="Yu Gothic UI" pitchFamily="34" charset="-120"/>
+              </a:rPr>
+              <a:t>NVIDIA がホスト対応を表明。</a:t>
+            </a:r>
+            <a:endParaRPr lang="ja-JP" sz="1800" dirty="0"/>
+          </a:p>
+          <a:p>
+            <a:pPr algn="l" indent="0" marL="0">
+              <a:buNone/>
+            </a:pPr>
+            <a:r>
+              <a:rPr lang="ja-JP" altLang="en-US" sz="1800" dirty="0">
+                <a:solidFill>
+                  <a:srgbClr val="1B2430"/>
+                </a:solidFill>
+                <a:latin typeface="Yu Gothic UI" pitchFamily="34" charset="0"/>
+                <a:ea typeface="Yu Gothic UI" pitchFamily="34" charset="-122"/>
+                <a:cs typeface="Yu Gothic UI" pitchFamily="34" charset="-120"/>
+              </a:rPr>
+              <a:t>2026-08、SiFive BigSky 上で CUDA が動作。</a:t>
+            </a:r>
+            <a:endParaRPr lang="ja-JP" sz="1800" dirty="0"/>
+          </a:p>
+        </p:txBody>
+      </p:sp>
+      <p:sp>
+        <p:nvSpPr>
+          <p:cNvPr id="7" name="Text 4"/>
+          <p:cNvSpPr/>
+          <p:nvPr/>
+        </p:nvSpPr>
+        <p:spPr>
+          <a:xfrm>
+            <a:off x="365760" y="3520440"/>
+            <a:ext cx="5623560" cy="2606040"/>
+          </a:xfrm>
+          <a:prstGeom prst="roundRect">
+            <a:avLst>
+              <a:gd name="adj" fmla="val 4211"/>
+            </a:avLst>
+          </a:prstGeom>
+          <a:solidFill>
+            <a:srgbClr val="FFFFFF"/>
+          </a:solidFill>
+          <a:ln w="13970">
+            <a:solidFill>
+              <a:srgbClr val="C5CDD6"/>
+            </a:solidFill>
+          </a:ln>
+        </p:spPr>
+        <p:txBody>
+          <a:bodyPr wrap="square" lIns="50800" tIns="50800" rIns="50800" bIns="50800" rtlCol="0" anchor="ctr"/>
+          <a:lstStyle/>
+          <a:p>
+            <a:pPr algn="l" indent="0" marL="0">
+              <a:buNone/>
+            </a:pPr>
+            <a:r>
+              <a:rPr lang="ja-JP" altLang="en-US" sz="1800" dirty="0">
+                <a:solidFill>
+                  <a:srgbClr val="1B2430"/>
+                </a:solidFill>
+                <a:latin typeface="Yu Gothic UI" pitchFamily="34" charset="0"/>
+                <a:ea typeface="Yu Gothic UI" pitchFamily="34" charset="-122"/>
+                <a:cs typeface="Yu Gothic UI" pitchFamily="34" charset="-120"/>
+              </a:rPr>
+              <a:t>資金と買収</a:t>
+            </a:r>
+            <a:endParaRPr lang="ja-JP" sz="1800" dirty="0"/>
+          </a:p>
+          <a:p>
+            <a:pPr algn="l" indent="0" marL="0">
+              <a:buNone/>
+            </a:pPr>
+            <a:r>
+              <a:rPr lang="ja-JP" altLang="en-US" sz="1800" dirty="0">
+                <a:solidFill>
+                  <a:srgbClr val="1B2430"/>
+                </a:solidFill>
+                <a:latin typeface="Yu Gothic UI" pitchFamily="34" charset="0"/>
+                <a:ea typeface="Yu Gothic UI" pitchFamily="34" charset="-122"/>
+                <a:cs typeface="Yu Gothic UI" pitchFamily="34" charset="-120"/>
+              </a:rPr>
+              <a:t>Qualcomm が Ventana を買収（2025-12）。</a:t>
+            </a:r>
+            <a:endParaRPr lang="ja-JP" sz="1800" dirty="0"/>
+          </a:p>
+          <a:p>
+            <a:pPr algn="l" indent="0" marL="0">
+              <a:buNone/>
+            </a:pPr>
+            <a:r>
+              <a:rPr lang="ja-JP" altLang="en-US" sz="1800" dirty="0">
+                <a:solidFill>
+                  <a:srgbClr val="1B2430"/>
+                </a:solidFill>
+                <a:latin typeface="Yu Gothic UI" pitchFamily="34" charset="0"/>
+                <a:ea typeface="Yu Gothic UI" pitchFamily="34" charset="-122"/>
+                <a:cs typeface="Yu Gothic UI" pitchFamily="34" charset="-120"/>
+              </a:rPr>
+              <a:t>SiFive は評価額約 36.5 億ドル（2026-04）。</a:t>
+            </a:r>
+            <a:endParaRPr lang="ja-JP" sz="1800" dirty="0"/>
+          </a:p>
+        </p:txBody>
+      </p:sp>
+      <p:sp>
+        <p:nvSpPr>
+          <p:cNvPr id="8" name="Text 5"/>
+          <p:cNvSpPr/>
+          <p:nvPr/>
+        </p:nvSpPr>
+        <p:spPr>
+          <a:xfrm>
+            <a:off x="6172200" y="3520440"/>
+            <a:ext cx="5623560" cy="2606040"/>
+          </a:xfrm>
+          <a:prstGeom prst="roundRect">
+            <a:avLst>
+              <a:gd name="adj" fmla="val 4211"/>
+            </a:avLst>
+          </a:prstGeom>
+          <a:solidFill>
+            <a:srgbClr val="E8F3FF"/>
+          </a:solidFill>
+          <a:ln w="15240">
+            <a:solidFill>
+              <a:srgbClr val="0B6BCB"/>
+            </a:solidFill>
+          </a:ln>
+        </p:spPr>
+        <p:txBody>
+          <a:bodyPr wrap="square" lIns="50800" tIns="50800" rIns="50800" bIns="50800" rtlCol="0" anchor="ctr"/>
+          <a:lstStyle/>
+          <a:p>
+            <a:pPr algn="l" indent="0" marL="0">
+              <a:buNone/>
+            </a:pPr>
+            <a:r>
+              <a:rPr lang="ja-JP" altLang="en-US" sz="1800" dirty="0">
+                <a:solidFill>
+                  <a:srgbClr val="1B2430"/>
+                </a:solidFill>
+                <a:latin typeface="Yu Gothic UI" pitchFamily="34" charset="0"/>
+                <a:ea typeface="Yu Gothic UI" pitchFamily="34" charset="-122"/>
+                <a:cs typeface="Yu Gothic UI" pitchFamily="34" charset="-120"/>
+              </a:rPr>
+              <a:t>まだ弱いところ</a:t>
+            </a:r>
+            <a:endParaRPr lang="ja-JP" sz="1800" dirty="0"/>
+          </a:p>
+          <a:p>
+            <a:pPr algn="l" indent="0" marL="0">
+              <a:buNone/>
+            </a:pPr>
+            <a:r>
+              <a:rPr lang="ja-JP" altLang="en-US" sz="1800" dirty="0">
+                <a:solidFill>
+                  <a:srgbClr val="1B2430"/>
+                </a:solidFill>
+                <a:latin typeface="Yu Gothic UI" pitchFamily="34" charset="0"/>
+                <a:ea typeface="Yu Gothic UI" pitchFamily="34" charset="-122"/>
+                <a:cs typeface="Yu Gothic UI" pitchFamily="34" charset="-120"/>
+              </a:rPr>
+              <a:t>Android の NDK ABI は未確定。</a:t>
+            </a:r>
+            <a:endParaRPr lang="ja-JP" sz="1800" dirty="0"/>
+          </a:p>
+          <a:p>
+            <a:pPr algn="l" indent="0" marL="0">
+              <a:buNone/>
+            </a:pPr>
+            <a:r>
+              <a:rPr lang="ja-JP" altLang="en-US" sz="1800" dirty="0">
+                <a:solidFill>
+                  <a:srgbClr val="1B2430"/>
+                </a:solidFill>
+                <a:latin typeface="Yu Gothic UI" pitchFamily="34" charset="0"/>
+                <a:ea typeface="Yu Gothic UI" pitchFamily="34" charset="-122"/>
+                <a:cs typeface="Yu Gothic UI" pitchFamily="34" charset="-120"/>
+              </a:rPr>
+              <a:t>汎用サーバーの量産展開は黎明期。</a:t>
+            </a:r>
+            <a:endParaRPr lang="ja-JP" sz="1800" dirty="0"/>
+          </a:p>
+        </p:txBody>
+      </p:sp>
+    </p:spTree>
+  </p:cSld>
+  <p:clrMapOvr>
+    <a:masterClrMapping/>
+  </p:clrMapOvr>
+</p:sld>
+</file>
+
+<file path=ppt/slides/slide6.xml><?xml version="1.0" encoding="utf-8"?>
+<p:sld xmlns:a="http://schemas.openxmlformats.org/drawingml/2006/main" xmlns:r="http://schemas.openxmlformats.org/officeDocument/2006/relationships" xmlns:p="http://schemas.openxmlformats.org/presentationml/2006/main">
+  <p:cSld name="Slide 6">
+    <p:spTree>
+      <p:nvGrpSpPr>
+        <p:cNvPr id="1" name=""/>
+        <p:cNvGrpSpPr/>
+        <p:nvPr/>
+      </p:nvGrpSpPr>
+      <p:grpSpPr>
+        <a:xfrm>
+          <a:off x="0" y="0"/>
+          <a:ext cx="0" cy="0"/>
+          <a:chOff x="0" y="0"/>
+          <a:chExt cx="0" cy="0"/>
+        </a:xfrm>
+      </p:grpSpPr>
+      <p:sp>
+        <p:nvSpPr>
+          <p:cNvPr id="3" name="Text 0"/>
+          <p:cNvSpPr/>
+          <p:nvPr/>
+        </p:nvSpPr>
+        <p:spPr>
+          <a:xfrm>
+            <a:off x="9875520" y="6419088"/>
+            <a:ext cx="2011680" cy="438912"/>
+          </a:xfrm>
+          <a:prstGeom prst="rect">
+            <a:avLst/>
+          </a:prstGeom>
+          <a:noFill/>
+          <a:ln/>
+        </p:spPr>
+        <p:txBody>
+          <a:bodyPr wrap="none" lIns="0" tIns="0" rIns="0" bIns="0" rtlCol="0" anchor="ctr"/>
+          <a:lstStyle/>
+          <a:p>
+            <a:pPr algn="r" indent="0" marL="0">
+              <a:buNone/>
+            </a:pPr>
+            <a:r>
+              <a:rPr lang="ja-JP" altLang="en-US" sz="1800" dirty="0">
+                <a:solidFill>
+                  <a:srgbClr val="5C6B7A"/>
+                </a:solidFill>
+                <a:latin typeface="Yu Gothic UI" pitchFamily="34" charset="0"/>
+                <a:ea typeface="Yu Gothic UI" pitchFamily="34" charset="-122"/>
+                <a:cs typeface="Yu Gothic UI" pitchFamily="34" charset="-120"/>
+              </a:rPr>
+              <a:t>6 / 8</a:t>
+            </a:r>
+            <a:endParaRPr lang="ja-JP" sz="1800" dirty="0"/>
+          </a:p>
+        </p:txBody>
+      </p:sp>
+      <p:sp>
+        <p:nvSpPr>
+          <p:cNvPr id="4" name="Text 1"/>
+          <p:cNvSpPr/>
+          <p:nvPr/>
+        </p:nvSpPr>
+        <p:spPr>
+          <a:xfrm>
+            <a:off x="411480" y="36576"/>
+            <a:ext cx="7680960" cy="585216"/>
+          </a:xfrm>
+          <a:prstGeom prst="rect">
+            <a:avLst/>
+          </a:prstGeom>
+          <a:noFill/>
+          <a:ln/>
+        </p:spPr>
+        <p:txBody>
+          <a:bodyPr wrap="none" lIns="0" tIns="0" rIns="0" bIns="0" rtlCol="0" anchor="ctr"/>
+          <a:lstStyle/>
+          <a:p>
+            <a:pPr indent="0" marL="0">
+              <a:buNone/>
+            </a:pPr>
+            <a:r>
+              <a:rPr lang="ja-JP" altLang="en-US" sz="2600" b="1" dirty="0">
+                <a:solidFill>
+                  <a:srgbClr val="1B2430"/>
+                </a:solidFill>
+                <a:latin typeface="Yu Gothic UI" pitchFamily="34" charset="0"/>
+                <a:ea typeface="Yu Gothic UI" pitchFamily="34" charset="-122"/>
+                <a:cs typeface="Yu Gothic UI" pitchFamily="34" charset="-120"/>
+              </a:rPr>
+              <a:t>RISC-V市場予測（SHD Group 2026）</a:t>
+            </a:r>
+            <a:endParaRPr lang="ja-JP" sz="2600" dirty="0"/>
+          </a:p>
+        </p:txBody>
+      </p:sp>
+      <p:sp>
+        <p:nvSpPr>
+          <p:cNvPr id="5" name="Text 2"/>
+          <p:cNvSpPr/>
+          <p:nvPr/>
+        </p:nvSpPr>
+        <p:spPr>
+          <a:xfrm>
+            <a:off x="7955280" y="73152"/>
+            <a:ext cx="3840480" cy="502920"/>
+          </a:xfrm>
+          <a:prstGeom prst="rect">
+            <a:avLst/>
+          </a:prstGeom>
+          <a:noFill/>
+          <a:ln/>
+        </p:spPr>
+        <p:txBody>
+          <a:bodyPr wrap="none" lIns="0" tIns="0" rIns="0" bIns="0" rtlCol="0" anchor="ctr"/>
+          <a:lstStyle/>
+          <a:p>
+            <a:pPr algn="r" indent="0" marL="0">
+              <a:buNone/>
+            </a:pPr>
+            <a:r>
+              <a:rPr lang="ja-JP" altLang="en-US" sz="1600" dirty="0">
+                <a:solidFill>
+                  <a:srgbClr val="5C6B7A"/>
+                </a:solidFill>
+                <a:latin typeface="Yu Gothic UI" pitchFamily="34" charset="0"/>
+                <a:ea typeface="Yu Gothic UI" pitchFamily="34" charset="-122"/>
+                <a:cs typeface="Yu Gothic UI" pitchFamily="34" charset="-120"/>
+              </a:rPr>
+              <a:t>実績〜2024 ／ 予測2025〜</a:t>
+            </a:r>
+            <a:endParaRPr lang="ja-JP" sz="1600" dirty="0"/>
+          </a:p>
+        </p:txBody>
+      </p:sp>
+      <p:sp>
+        <p:nvSpPr>
+          <p:cNvPr id="6" name="Text 3"/>
+          <p:cNvSpPr/>
+          <p:nvPr/>
+        </p:nvSpPr>
+        <p:spPr>
+          <a:xfrm>
+            <a:off x="365760" y="749808"/>
+            <a:ext cx="3703320" cy="868680"/>
+          </a:xfrm>
+          <a:prstGeom prst="roundRect">
+            <a:avLst>
+              <a:gd name="adj" fmla="val 8421"/>
+            </a:avLst>
+          </a:prstGeom>
+          <a:solidFill>
+            <a:srgbClr val="FFFFFF"/>
+          </a:solidFill>
+          <a:ln w="12700">
+            <a:solidFill>
+              <a:srgbClr val="C5CDD6"/>
+            </a:solidFill>
+          </a:ln>
+        </p:spPr>
+        <p:txBody>
+          <a:bodyPr wrap="square" lIns="50800" tIns="50800" rIns="50800" bIns="50800" rtlCol="0" anchor="ctr"/>
+          <a:lstStyle/>
+          <a:p>
+            <a:pPr algn="ctr" indent="0" marL="0">
+              <a:buNone/>
+            </a:pPr>
+            <a:r>
+              <a:rPr lang="ja-JP" altLang="en-US" sz="1600" dirty="0">
+                <a:solidFill>
+                  <a:srgbClr val="1B2430"/>
+                </a:solidFill>
+                <a:latin typeface="Yu Gothic UI" pitchFamily="34" charset="0"/>
+                <a:ea typeface="Yu Gothic UI" pitchFamily="34" charset="-122"/>
+                <a:cs typeface="Yu Gothic UI" pitchFamily="34" charset="-120"/>
+              </a:rPr>
+              <a:t>2031年 出荷 360億個</a:t>
+            </a:r>
+            <a:endParaRPr lang="ja-JP" sz="1600" dirty="0"/>
+          </a:p>
+          <a:p>
+            <a:pPr algn="ctr" indent="0" marL="0">
+              <a:buNone/>
+            </a:pPr>
+            <a:r>
+              <a:rPr lang="ja-JP" altLang="en-US" sz="1600" dirty="0">
+                <a:solidFill>
+                  <a:srgbClr val="1B2430"/>
+                </a:solidFill>
+                <a:latin typeface="Yu Gothic UI" pitchFamily="34" charset="0"/>
+                <a:ea typeface="Yu Gothic UI" pitchFamily="34" charset="-122"/>
+                <a:cs typeface="Yu Gothic UI" pitchFamily="34" charset="-120"/>
+              </a:rPr>
+              <a:t>CAGR 31.7%</a:t>
+            </a:r>
+            <a:endParaRPr lang="ja-JP" sz="1600" dirty="0"/>
+          </a:p>
+        </p:txBody>
+      </p:sp>
+      <p:sp>
+        <p:nvSpPr>
+          <p:cNvPr id="7" name="Text 4"/>
+          <p:cNvSpPr/>
+          <p:nvPr/>
+        </p:nvSpPr>
+        <p:spPr>
+          <a:xfrm>
+            <a:off x="4206240" y="749808"/>
+            <a:ext cx="3703320" cy="868680"/>
+          </a:xfrm>
+          <a:prstGeom prst="roundRect">
+            <a:avLst>
+              <a:gd name="adj" fmla="val 8421"/>
+            </a:avLst>
+          </a:prstGeom>
+          <a:solidFill>
+            <a:srgbClr val="FFFFFF"/>
+          </a:solidFill>
+          <a:ln w="12700">
+            <a:solidFill>
+              <a:srgbClr val="C5CDD6"/>
+            </a:solidFill>
+          </a:ln>
+        </p:spPr>
+        <p:txBody>
+          <a:bodyPr wrap="square" lIns="50800" tIns="50800" rIns="50800" bIns="50800" rtlCol="0" anchor="ctr"/>
+          <a:lstStyle/>
+          <a:p>
+            <a:pPr algn="ctr" indent="0" marL="0">
+              <a:buNone/>
+            </a:pPr>
+            <a:r>
+              <a:rPr lang="ja-JP" altLang="en-US" sz="1600" dirty="0">
+                <a:solidFill>
+                  <a:srgbClr val="1B2430"/>
+                </a:solidFill>
+                <a:latin typeface="Yu Gothic UI" pitchFamily="34" charset="0"/>
+                <a:ea typeface="Yu Gothic UI" pitchFamily="34" charset="-122"/>
+                <a:cs typeface="Yu Gothic UI" pitchFamily="34" charset="-120"/>
+              </a:rPr>
+              <a:t>2031年 売上 3,180億ドル</a:t>
+            </a:r>
+            <a:endParaRPr lang="ja-JP" sz="1600" dirty="0"/>
+          </a:p>
+          <a:p>
+            <a:pPr algn="ctr" indent="0" marL="0">
+              <a:buNone/>
+            </a:pPr>
+            <a:r>
+              <a:rPr lang="ja-JP" altLang="en-US" sz="1600" dirty="0">
+                <a:solidFill>
+                  <a:srgbClr val="1B2430"/>
+                </a:solidFill>
+                <a:latin typeface="Yu Gothic UI" pitchFamily="34" charset="0"/>
+                <a:ea typeface="Yu Gothic UI" pitchFamily="34" charset="-122"/>
+                <a:cs typeface="Yu Gothic UI" pitchFamily="34" charset="-120"/>
+              </a:rPr>
+              <a:t>CAGR 22.5%</a:t>
+            </a:r>
+            <a:endParaRPr lang="ja-JP" sz="1600" dirty="0"/>
+          </a:p>
+        </p:txBody>
+      </p:sp>
+      <p:sp>
+        <p:nvSpPr>
+          <p:cNvPr id="8" name="Text 5"/>
+          <p:cNvSpPr/>
+          <p:nvPr/>
+        </p:nvSpPr>
+        <p:spPr>
+          <a:xfrm>
+            <a:off x="8046720" y="749808"/>
+            <a:ext cx="3749040" cy="868680"/>
+          </a:xfrm>
+          <a:prstGeom prst="roundRect">
+            <a:avLst>
+              <a:gd name="adj" fmla="val 8421"/>
+            </a:avLst>
+          </a:prstGeom>
+          <a:solidFill>
+            <a:srgbClr val="FFFFFF"/>
+          </a:solidFill>
+          <a:ln w="12700">
+            <a:solidFill>
+              <a:srgbClr val="C5CDD6"/>
+            </a:solidFill>
+          </a:ln>
+        </p:spPr>
+        <p:txBody>
+          <a:bodyPr wrap="square" lIns="50800" tIns="50800" rIns="50800" bIns="50800" rtlCol="0" anchor="ctr"/>
+          <a:lstStyle/>
+          <a:p>
+            <a:pPr algn="ctr" indent="0" marL="0">
+              <a:buNone/>
+            </a:pPr>
+            <a:r>
+              <a:rPr lang="ja-JP" altLang="en-US" sz="1600" dirty="0">
+                <a:solidFill>
+                  <a:srgbClr val="1B2430"/>
+                </a:solidFill>
+                <a:latin typeface="Yu Gothic UI" pitchFamily="34" charset="0"/>
+                <a:ea typeface="Yu Gothic UI" pitchFamily="34" charset="-122"/>
+                <a:cs typeface="Yu Gothic UI" pitchFamily="34" charset="-120"/>
+              </a:rPr>
+              <a:t>普及率 約33%</a:t>
+            </a:r>
+            <a:endParaRPr lang="ja-JP" sz="1600" dirty="0"/>
+          </a:p>
+          <a:p>
+            <a:pPr algn="ctr" indent="0" marL="0">
+              <a:buNone/>
+            </a:pPr>
+            <a:r>
+              <a:rPr lang="ja-JP" altLang="en-US" sz="1600" dirty="0">
+                <a:solidFill>
+                  <a:srgbClr val="1B2430"/>
+                </a:solidFill>
+                <a:latin typeface="Yu Gothic UI" pitchFamily="34" charset="0"/>
+                <a:ea typeface="Yu Gothic UI" pitchFamily="34" charset="-122"/>
+                <a:cs typeface="Yu Gothic UI" pitchFamily="34" charset="-120"/>
+              </a:rPr>
+              <a:t>SoC全体の金額に注意</a:t>
+            </a:r>
+            <a:endParaRPr lang="ja-JP" sz="1600" dirty="0"/>
+          </a:p>
+        </p:txBody>
+      </p:sp>
+      <p:pic>
+        <p:nvPicPr>
+          <p:cNvPr id="9" name="Image 0" descr="RISC-V搭載SoCの出荷数と普及率（2022〜2031）">    </p:cNvPr>
+          <p:cNvPicPr>
+            <a:picLocks noChangeAspect="1"/>
+          </p:cNvPicPr>
+          <p:nvPr/>
+        </p:nvPicPr>
+        <p:blipFill>
+          <a:blip r:embed="rId1"/>
+          <a:srcRect l="0" r="0" t="0" b="0"/>
+          <a:stretch/>
+        </p:blipFill>
+        <p:spPr>
+          <a:xfrm>
+            <a:off x="320040" y="1719072"/>
+            <a:ext cx="5760720" cy="4114800"/>
           </a:xfrm>
           <a:prstGeom prst="rect">
             <a:avLst/>
@@ -1122,7 +3779,7 @@
       </p:pic>
       <p:pic>
         <p:nvPicPr>
-          <p:cNvPr id="8" name="Image 1" descr="RISC-V搭載SoCの売上と普及率（2022〜2031）">    </p:cNvPr>
+          <p:cNvPr id="10" name="Image 1" descr="RISC-V搭載SoCの売上と普及率（2022〜2031）">    </p:cNvPr>
           <p:cNvPicPr>
             <a:picLocks noChangeAspect="1"/>
           </p:cNvPicPr>
@@ -1135,8 +3792,8 @@
         </p:blipFill>
         <p:spPr>
           <a:xfrm>
-            <a:off x="6181344" y="713232"/>
-            <a:ext cx="5833872" cy="3291840"/>
+            <a:off x="6126480" y="1719072"/>
+            <a:ext cx="5760720" cy="4114800"/>
           </a:xfrm>
           <a:prstGeom prst="rect">
             <a:avLst/>
@@ -1145,26 +3802,478 @@
       </p:pic>
       <p:sp>
         <p:nvSpPr>
-          <p:cNvPr id="9" name="Text 4"/>
-          <p:cNvSpPr/>
-          <p:nvPr/>
-        </p:nvSpPr>
-        <p:spPr>
-          <a:xfrm>
-            <a:off x="292608" y="5074920"/>
-            <a:ext cx="11603736" cy="868680"/>
+          <p:cNvPr id="11" name="Text 6"/>
+          <p:cNvSpPr/>
+          <p:nvPr/>
+        </p:nvSpPr>
+        <p:spPr>
+          <a:xfrm>
+            <a:off x="411480" y="5943600"/>
+            <a:ext cx="11338560" cy="365760"/>
+          </a:xfrm>
+          <a:prstGeom prst="rect">
+            <a:avLst/>
+          </a:prstGeom>
+          <a:noFill/>
+          <a:ln/>
+        </p:spPr>
+        <p:txBody>
+          <a:bodyPr wrap="none" lIns="0" tIns="0" rIns="0" bIns="0" rtlCol="0" anchor="ctr"/>
+          <a:lstStyle/>
+          <a:p>
+            <a:pPr indent="0" marL="0">
+              <a:buNone/>
+            </a:pPr>
+            <a:r>
+              <a:rPr lang="ja-JP" altLang="en-US" sz="1600" dirty="0">
+                <a:solidFill>
+                  <a:srgbClr val="5C6B7A"/>
+                </a:solidFill>
+                <a:latin typeface="Yu Gothic UI" pitchFamily="34" charset="0"/>
+                <a:ea typeface="Yu Gothic UI" pitchFamily="34" charset="-122"/>
+                <a:cs typeface="Yu Gothic UI" pitchFamily="34" charset="-120"/>
+              </a:rPr>
+              <a:t>SHD102-26 Abridged, April 2026, Tables 13–14（公開数値から再作図）</a:t>
+            </a:r>
+            <a:endParaRPr lang="ja-JP" sz="1600" dirty="0"/>
+          </a:p>
+        </p:txBody>
+      </p:sp>
+    </p:spTree>
+  </p:cSld>
+  <p:clrMapOvr>
+    <a:masterClrMapping/>
+  </p:clrMapOvr>
+</p:sld>
+</file>
+
+<file path=ppt/slides/slide7.xml><?xml version="1.0" encoding="utf-8"?>
+<p:sld xmlns:a="http://schemas.openxmlformats.org/drawingml/2006/main" xmlns:r="http://schemas.openxmlformats.org/officeDocument/2006/relationships" xmlns:p="http://schemas.openxmlformats.org/presentationml/2006/main">
+  <p:cSld name="Slide 7">
+    <p:spTree>
+      <p:nvGrpSpPr>
+        <p:cNvPr id="1" name=""/>
+        <p:cNvGrpSpPr/>
+        <p:nvPr/>
+      </p:nvGrpSpPr>
+      <p:grpSpPr>
+        <a:xfrm>
+          <a:off x="0" y="0"/>
+          <a:ext cx="0" cy="0"/>
+          <a:chOff x="0" y="0"/>
+          <a:chExt cx="0" cy="0"/>
+        </a:xfrm>
+      </p:grpSpPr>
+      <p:sp>
+        <p:nvSpPr>
+          <p:cNvPr id="3" name="Text 0"/>
+          <p:cNvSpPr/>
+          <p:nvPr/>
+        </p:nvSpPr>
+        <p:spPr>
+          <a:xfrm>
+            <a:off x="9875520" y="6419088"/>
+            <a:ext cx="2011680" cy="438912"/>
+          </a:xfrm>
+          <a:prstGeom prst="rect">
+            <a:avLst/>
+          </a:prstGeom>
+          <a:noFill/>
+          <a:ln/>
+        </p:spPr>
+        <p:txBody>
+          <a:bodyPr wrap="none" lIns="0" tIns="0" rIns="0" bIns="0" rtlCol="0" anchor="ctr"/>
+          <a:lstStyle/>
+          <a:p>
+            <a:pPr algn="r" indent="0" marL="0">
+              <a:buNone/>
+            </a:pPr>
+            <a:r>
+              <a:rPr lang="ja-JP" altLang="en-US" sz="1800" dirty="0">
+                <a:solidFill>
+                  <a:srgbClr val="5C6B7A"/>
+                </a:solidFill>
+                <a:latin typeface="Yu Gothic UI" pitchFamily="34" charset="0"/>
+                <a:ea typeface="Yu Gothic UI" pitchFamily="34" charset="-122"/>
+                <a:cs typeface="Yu Gothic UI" pitchFamily="34" charset="-120"/>
+              </a:rPr>
+              <a:t>7 / 8</a:t>
+            </a:r>
+            <a:endParaRPr lang="ja-JP" sz="1800" dirty="0"/>
+          </a:p>
+        </p:txBody>
+      </p:sp>
+      <p:sp>
+        <p:nvSpPr>
+          <p:cNvPr id="4" name="Text 1"/>
+          <p:cNvSpPr/>
+          <p:nvPr/>
+        </p:nvSpPr>
+        <p:spPr>
+          <a:xfrm>
+            <a:off x="411480" y="36576"/>
+            <a:ext cx="7772400" cy="585216"/>
+          </a:xfrm>
+          <a:prstGeom prst="rect">
+            <a:avLst/>
+          </a:prstGeom>
+          <a:noFill/>
+          <a:ln/>
+        </p:spPr>
+        <p:txBody>
+          <a:bodyPr wrap="none" lIns="0" tIns="0" rIns="0" bIns="0" rtlCol="0" anchor="ctr"/>
+          <a:lstStyle/>
+          <a:p>
+            <a:pPr indent="0" marL="0">
+              <a:buNone/>
+            </a:pPr>
+            <a:r>
+              <a:rPr lang="ja-JP" altLang="en-US" sz="2800" b="1" dirty="0">
+                <a:solidFill>
+                  <a:srgbClr val="1B2430"/>
+                </a:solidFill>
+                <a:latin typeface="Yu Gothic UI" pitchFamily="34" charset="0"/>
+                <a:ea typeface="Yu Gothic UI" pitchFamily="34" charset="-122"/>
+                <a:cs typeface="Yu Gothic UI" pitchFamily="34" charset="-120"/>
+              </a:rPr>
+              <a:t>RISC-V CPU IP売上予測</a:t>
+            </a:r>
+            <a:endParaRPr lang="ja-JP" sz="2800" dirty="0"/>
+          </a:p>
+        </p:txBody>
+      </p:sp>
+      <p:sp>
+        <p:nvSpPr>
+          <p:cNvPr id="5" name="Text 2"/>
+          <p:cNvSpPr/>
+          <p:nvPr/>
+        </p:nvSpPr>
+        <p:spPr>
+          <a:xfrm>
+            <a:off x="7955280" y="73152"/>
+            <a:ext cx="3840480" cy="502920"/>
+          </a:xfrm>
+          <a:prstGeom prst="rect">
+            <a:avLst/>
+          </a:prstGeom>
+          <a:noFill/>
+          <a:ln/>
+        </p:spPr>
+        <p:txBody>
+          <a:bodyPr wrap="none" lIns="0" tIns="0" rIns="0" bIns="0" rtlCol="0" anchor="ctr"/>
+          <a:lstStyle/>
+          <a:p>
+            <a:pPr algn="r" indent="0" marL="0">
+              <a:buNone/>
+            </a:pPr>
+            <a:r>
+              <a:rPr lang="ja-JP" altLang="en-US" sz="1800" dirty="0">
+                <a:solidFill>
+                  <a:srgbClr val="0B6BCB"/>
+                </a:solidFill>
+                <a:latin typeface="Yu Gothic UI" pitchFamily="34" charset="0"/>
+                <a:ea typeface="Yu Gothic UI" pitchFamily="34" charset="-122"/>
+                <a:cs typeface="Yu Gothic UI" pitchFamily="34" charset="-120"/>
+              </a:rPr>
+              <a:t>2024 $205M → 2031 $1.91B</a:t>
+            </a:r>
+            <a:endParaRPr lang="ja-JP" sz="1800" dirty="0"/>
+          </a:p>
+        </p:txBody>
+      </p:sp>
+      <p:sp>
+        <p:nvSpPr>
+          <p:cNvPr id="6" name="Text 3"/>
+          <p:cNvSpPr/>
+          <p:nvPr/>
+        </p:nvSpPr>
+        <p:spPr>
+          <a:xfrm>
+            <a:off x="365760" y="777240"/>
+            <a:ext cx="3703320" cy="658368"/>
           </a:xfrm>
           <a:prstGeom prst="roundRect">
             <a:avLst>
-              <a:gd name="adj" fmla="val 14737"/>
+              <a:gd name="adj" fmla="val 11111"/>
             </a:avLst>
           </a:prstGeom>
           <a:solidFill>
-            <a:srgbClr val="1B365D"/>
-          </a:solidFill>
+            <a:srgbClr val="FFFFFF"/>
+          </a:solidFill>
+          <a:ln w="12700">
+            <a:solidFill>
+              <a:srgbClr val="C5CDD6"/>
+            </a:solidFill>
+          </a:ln>
+        </p:spPr>
+        <p:txBody>
+          <a:bodyPr wrap="none" lIns="50800" tIns="50800" rIns="50800" bIns="50800" rtlCol="0" anchor="ctr"/>
+          <a:lstStyle/>
+          <a:p>
+            <a:pPr algn="ctr" indent="0" marL="0">
+              <a:buNone/>
+            </a:pPr>
+            <a:r>
+              <a:rPr lang="ja-JP" altLang="en-US" sz="1600" dirty="0">
+                <a:solidFill>
+                  <a:srgbClr val="1B2430"/>
+                </a:solidFill>
+                <a:latin typeface="Yu Gothic UI" pitchFamily="34" charset="0"/>
+                <a:ea typeface="Yu Gothic UI" pitchFamily="34" charset="-122"/>
+                <a:cs typeface="Yu Gothic UI" pitchFamily="34" charset="-120"/>
+              </a:rPr>
+              <a:t>2024年  2.05億ドル（実績）</a:t>
+            </a:r>
+            <a:endParaRPr lang="ja-JP" sz="1600" dirty="0"/>
+          </a:p>
+        </p:txBody>
+      </p:sp>
+      <p:sp>
+        <p:nvSpPr>
+          <p:cNvPr id="7" name="Text 4"/>
+          <p:cNvSpPr/>
+          <p:nvPr/>
+        </p:nvSpPr>
+        <p:spPr>
+          <a:xfrm>
+            <a:off x="4206240" y="777240"/>
+            <a:ext cx="3703320" cy="658368"/>
+          </a:xfrm>
+          <a:prstGeom prst="roundRect">
+            <a:avLst>
+              <a:gd name="adj" fmla="val 11111"/>
+            </a:avLst>
+          </a:prstGeom>
+          <a:solidFill>
+            <a:srgbClr val="FFFFFF"/>
+          </a:solidFill>
+          <a:ln w="12700">
+            <a:solidFill>
+              <a:srgbClr val="C5CDD6"/>
+            </a:solidFill>
+          </a:ln>
+        </p:spPr>
+        <p:txBody>
+          <a:bodyPr wrap="none" lIns="50800" tIns="50800" rIns="50800" bIns="50800" rtlCol="0" anchor="ctr"/>
+          <a:lstStyle/>
+          <a:p>
+            <a:pPr algn="ctr" indent="0" marL="0">
+              <a:buNone/>
+            </a:pPr>
+            <a:r>
+              <a:rPr lang="ja-JP" altLang="en-US" sz="1600" dirty="0">
+                <a:solidFill>
+                  <a:srgbClr val="1B2430"/>
+                </a:solidFill>
+                <a:latin typeface="Yu Gothic UI" pitchFamily="34" charset="0"/>
+                <a:ea typeface="Yu Gothic UI" pitchFamily="34" charset="-122"/>
+                <a:cs typeface="Yu Gothic UI" pitchFamily="34" charset="-120"/>
+              </a:rPr>
+              <a:t>2031年  19.1億ドル（予測）</a:t>
+            </a:r>
+            <a:endParaRPr lang="ja-JP" sz="1600" dirty="0"/>
+          </a:p>
+        </p:txBody>
+      </p:sp>
+      <p:sp>
+        <p:nvSpPr>
+          <p:cNvPr id="8" name="Text 5"/>
+          <p:cNvSpPr/>
+          <p:nvPr/>
+        </p:nvSpPr>
+        <p:spPr>
+          <a:xfrm>
+            <a:off x="8046720" y="777240"/>
+            <a:ext cx="3749040" cy="658368"/>
+          </a:xfrm>
+          <a:prstGeom prst="roundRect">
+            <a:avLst>
+              <a:gd name="adj" fmla="val 11111"/>
+            </a:avLst>
+          </a:prstGeom>
+          <a:solidFill>
+            <a:srgbClr val="FFFFFF"/>
+          </a:solidFill>
+          <a:ln w="12700">
+            <a:solidFill>
+              <a:srgbClr val="C5CDD6"/>
+            </a:solidFill>
+          </a:ln>
+        </p:spPr>
+        <p:txBody>
+          <a:bodyPr wrap="none" lIns="50800" tIns="50800" rIns="50800" bIns="50800" rtlCol="0" anchor="ctr"/>
+          <a:lstStyle/>
+          <a:p>
+            <a:pPr algn="ctr" indent="0" marL="0">
+              <a:buNone/>
+            </a:pPr>
+            <a:r>
+              <a:rPr lang="ja-JP" altLang="en-US" sz="1600" dirty="0">
+                <a:solidFill>
+                  <a:srgbClr val="1B2430"/>
+                </a:solidFill>
+                <a:latin typeface="Yu Gothic UI" pitchFamily="34" charset="0"/>
+                <a:ea typeface="Yu Gothic UI" pitchFamily="34" charset="-122"/>
+                <a:cs typeface="Yu Gothic UI" pitchFamily="34" charset="-120"/>
+              </a:rPr>
+              <a:t>CAGR 39.7%（2025–31）</a:t>
+            </a:r>
+            <a:endParaRPr lang="ja-JP" sz="1600" dirty="0"/>
+          </a:p>
+        </p:txBody>
+      </p:sp>
+      <p:pic>
+        <p:nvPicPr>
+          <p:cNvPr id="9" name="Image 0" descr="RISC-V CPU IP 市場売上の内訳（2022〜2031）">    </p:cNvPr>
+          <p:cNvPicPr>
+            <a:picLocks noChangeAspect="1"/>
+          </p:cNvPicPr>
+          <p:nvPr/>
+        </p:nvPicPr>
+        <p:blipFill>
+          <a:blip r:embed="rId1"/>
+          <a:srcRect l="0" r="0" t="0" b="0"/>
+          <a:stretch/>
+        </p:blipFill>
+        <p:spPr>
+          <a:xfrm>
+            <a:off x="1051560" y="1536192"/>
+            <a:ext cx="10058400" cy="4434840"/>
+          </a:xfrm>
+          <a:prstGeom prst="rect">
+            <a:avLst/>
+          </a:prstGeom>
+        </p:spPr>
+      </p:pic>
+      <p:sp>
+        <p:nvSpPr>
+          <p:cNvPr id="10" name="Text 6"/>
+          <p:cNvSpPr/>
+          <p:nvPr/>
+        </p:nvSpPr>
+        <p:spPr>
+          <a:xfrm>
+            <a:off x="411480" y="6016752"/>
+            <a:ext cx="11338560" cy="320040"/>
+          </a:xfrm>
+          <a:prstGeom prst="rect">
+            <a:avLst/>
+          </a:prstGeom>
+          <a:noFill/>
           <a:ln/>
         </p:spPr>
         <p:txBody>
+          <a:bodyPr wrap="none" lIns="0" tIns="0" rIns="0" bIns="0" rtlCol="0" anchor="ctr"/>
+          <a:lstStyle/>
+          <a:p>
+            <a:pPr indent="0" marL="0">
+              <a:buNone/>
+            </a:pPr>
+            <a:r>
+              <a:rPr lang="ja-JP" altLang="en-US" sz="1600" dirty="0">
+                <a:solidFill>
+                  <a:srgbClr val="5C6B7A"/>
+                </a:solidFill>
+                <a:latin typeface="Yu Gothic UI" pitchFamily="34" charset="0"/>
+                <a:ea typeface="Yu Gothic UI" pitchFamily="34" charset="-122"/>
+                <a:cs typeface="Yu Gothic UI" pitchFamily="34" charset="-120"/>
+              </a:rPr>
+              <a:t>SHD102-26 Abridged, April 2026, Table 32（公開数値から再作図）</a:t>
+            </a:r>
+            <a:endParaRPr lang="ja-JP" sz="1600" dirty="0"/>
+          </a:p>
+        </p:txBody>
+      </p:sp>
+    </p:spTree>
+  </p:cSld>
+  <p:clrMapOvr>
+    <a:masterClrMapping/>
+  </p:clrMapOvr>
+</p:sld>
+</file>
+
+<file path=ppt/slides/slide8.xml><?xml version="1.0" encoding="utf-8"?>
+<p:sld xmlns:a="http://schemas.openxmlformats.org/drawingml/2006/main" xmlns:r="http://schemas.openxmlformats.org/officeDocument/2006/relationships" xmlns:p="http://schemas.openxmlformats.org/presentationml/2006/main">
+  <p:cSld name="Slide 8">
+    <p:spTree>
+      <p:nvGrpSpPr>
+        <p:cNvPr id="1" name=""/>
+        <p:cNvGrpSpPr/>
+        <p:nvPr/>
+      </p:nvGrpSpPr>
+      <p:grpSpPr>
+        <a:xfrm>
+          <a:off x="0" y="0"/>
+          <a:ext cx="0" cy="0"/>
+          <a:chOff x="0" y="0"/>
+          <a:chExt cx="0" cy="0"/>
+        </a:xfrm>
+      </p:grpSpPr>
+      <p:sp>
+        <p:nvSpPr>
+          <p:cNvPr id="3" name="Text 0"/>
+          <p:cNvSpPr/>
+          <p:nvPr/>
+        </p:nvSpPr>
+        <p:spPr>
+          <a:xfrm>
+            <a:off x="9875520" y="6419088"/>
+            <a:ext cx="2011680" cy="438912"/>
+          </a:xfrm>
+          <a:prstGeom prst="rect">
+            <a:avLst/>
+          </a:prstGeom>
+          <a:noFill/>
+          <a:ln/>
+        </p:spPr>
+        <p:txBody>
+          <a:bodyPr wrap="none" lIns="0" tIns="0" rIns="0" bIns="0" rtlCol="0" anchor="ctr"/>
+          <a:lstStyle/>
+          <a:p>
+            <a:pPr algn="r" indent="0" marL="0">
+              <a:buNone/>
+            </a:pPr>
+            <a:r>
+              <a:rPr lang="ja-JP" altLang="en-US" sz="1800" dirty="0">
+                <a:solidFill>
+                  <a:srgbClr val="5C6B7A"/>
+                </a:solidFill>
+                <a:latin typeface="Yu Gothic UI" pitchFamily="34" charset="0"/>
+                <a:ea typeface="Yu Gothic UI" pitchFamily="34" charset="-122"/>
+                <a:cs typeface="Yu Gothic UI" pitchFamily="34" charset="-120"/>
+              </a:rPr>
+              <a:t>8 / 8</a:t>
+            </a:r>
+            <a:endParaRPr lang="ja-JP" sz="1800" dirty="0"/>
+          </a:p>
+        </p:txBody>
+      </p:sp>
+      <p:sp>
+        <p:nvSpPr>
+          <p:cNvPr id="4" name="Text 1"/>
+          <p:cNvSpPr/>
+          <p:nvPr/>
+        </p:nvSpPr>
+        <p:spPr>
+          <a:xfrm>
+            <a:off x="292608" y="2788920"/>
+            <a:ext cx="11612880" cy="1133856"/>
+          </a:xfrm>
+          <a:prstGeom prst="roundRect">
+            <a:avLst>
+              <a:gd name="adj" fmla="val 9677"/>
+            </a:avLst>
+          </a:prstGeom>
+          <a:solidFill>
+            <a:srgbClr val="E8F3FF"/>
+          </a:solidFill>
+          <a:ln w="27940">
+            <a:solidFill>
+              <a:srgbClr val="1B365D"/>
+            </a:solidFill>
+          </a:ln>
+        </p:spPr>
+        <p:txBody>
           <a:bodyPr wrap="none" lIns="50800" tIns="50800" rIns="50800" bIns="50800" rtlCol="0" anchor="ctr"/>
           <a:lstStyle/>
           <a:p>
@@ -1172,9 +4281,9 @@
               <a:buNone/>
             </a:pPr>
             <a:r>
-              <a:rPr lang="ja-JP" altLang="en-US" sz="2000" b="1" dirty="0">
-                <a:solidFill>
-                  <a:srgbClr val="FFFFFF"/>
+              <a:rPr lang="ja-JP" altLang="en-US" sz="1600" b="1" dirty="0">
+                <a:solidFill>
+                  <a:srgbClr val="1B365D"/>
                 </a:solidFill>
                 <a:latin typeface="Yu Gothic UI" pitchFamily="34" charset="0"/>
                 <a:ea typeface="Yu Gothic UI" pitchFamily="34" charset="-122"/>
@@ -1182,7 +4291,7 @@
               </a:rPr>
               <a:t>2026年、RISC-VはRVA23実機とAIで成長期へ。ただしオープンISA≠無償シリコン、対Armはこれから。</a:t>
             </a:r>
-            <a:endParaRPr lang="ja-JP" sz="2000" dirty="0"/>
+            <a:endParaRPr lang="ja-JP" sz="1600" dirty="0"/>
           </a:p>
         </p:txBody>
       </p:sp>

</xml_diff>